<commit_message>
Report + slides: fill in the team's names and matric number
Lee Tze Hian, Ong Chuan Hau (C240087), See Jun Wen -- in that order, per
the user. Jeb's and junwen's matric numbers left blank for now; only
Ong Chuan Hau's was given.

Zero [TEAM] placeholders remain in the report. Verified: exactly one
paragraph changed in the .docx (the byline), no tables touched, checked
on the real rendered page; the slide title page checked the same way.

Co-Authored-By: Claude Sonnet 5 <noreply@anthropic.com>
</commit_message>
<xml_diff>
--- a/docs/report/CT3201_Slides.pptx
+++ b/docs/report/CT3201_Slides.pptx
@@ -3174,7 +3174,7 @@
                   <a:srgbClr val="222222"/>
                 </a:solidFill>
               </a:rPr>
-              <a:t>Team: [TEAM — add full names and matriculation numbers]</a:t>
+              <a:t>Team: Lee Tze Hian, Ong Chuan Hau (C240087), See Jun Wen</a:t>
             </a:r>
           </a:p>
           <a:p>
@@ -3255,7 +3255,17 @@
                   <a:srgbClr val="1F4E79"/>
                 </a:solidFill>
               </a:rPr>
-              <a:t>9 - Conclusion</a:t>
+              <a:t>8 - Human-AI Reflection</a:t>
+            </a:r>
+          </a:p>
+          <a:p>
+            <a:r>
+              <a:rPr sz="1300">
+                <a:solidFill>
+                  <a:srgbClr val="666666"/>
+                </a:solidFill>
+              </a:rPr>
+              <a:t>Phase 8, Stage 9 - MANDATORY</a:t>
             </a:r>
           </a:p>
         </p:txBody>
@@ -3268,7 +3278,7 @@
         </p:nvSpPr>
         <p:spPr>
           <a:xfrm>
-            <a:off x="640080" y="1645920"/>
+            <a:off x="640080" y="1371600"/>
             <a:ext cx="10972800" cy="5029200"/>
           </a:xfrm>
           <a:prstGeom prst="rect">
@@ -3288,12 +3298,12 @@
               </a:spcAft>
             </a:pPr>
             <a:r>
-              <a:rPr sz="1600">
+              <a:rPr sz="1300">
                 <a:solidFill>
                   <a:srgbClr val="222222"/>
                 </a:solidFill>
               </a:rPr>
-              <a:t>Designed the agent human-first, then used AI to challenge and broaden it</a:t>
+              <a:t>AI helped: explained tiles-vs-cost, listed search options, caught bad assumptions; later, built the whole UI rebuild fast (results, menus, pause, HUD, intro)</a:t>
             </a:r>
           </a:p>
           <a:p>
@@ -3303,12 +3313,12 @@
               </a:spcAft>
             </a:pPr>
             <a:r>
-              <a:rPr sz="1600">
+              <a:rPr sz="1300">
                 <a:solidFill>
                   <a:srgbClr val="222222"/>
                 </a:solidFill>
               </a:rPr>
-              <a:t>AI moved us from unweighted BFS to a hazard-weighted A* agent that plans under partial information and re-plans as the building changes</a:t>
+              <a:t>AI got wrong: the video model couldn't animate toward/away from camera; recommended Greedy without weighing safe vs fast; later, wrongly credited a teammate for a feature based only on a git commit's account</a:t>
             </a:r>
           </a:p>
           <a:p>
@@ -3318,12 +3328,12 @@
               </a:spcAft>
             </a:pPr>
             <a:r>
-              <a:rPr sz="1600">
+              <a:rPr sz="1300">
                 <a:solidFill>
                   <a:srgbClr val="222222"/>
                 </a:solidFill>
               </a:rPr>
-              <a:t>Tested an AI recommendation (Greedy) against a purpose-built comparison — found it inappropriate, rejected it with evidence</a:t>
+              <a:t>Accepted: weighted costs, A*, partial observability, key sub-goal, connectivity-checked collapse, braided maze; later, the UI rebuild — reviewed screen by screen</a:t>
             </a:r>
           </a:p>
           <a:p>
@@ -3333,12 +3343,12 @@
               </a:spcAft>
             </a:pPr>
             <a:r>
-              <a:rPr sz="1600">
+              <a:rPr sz="1300">
                 <a:solidFill>
                   <a:srgbClr val="222222"/>
                 </a:solidFill>
               </a:rPr>
-              <a:t>The AI's clearest failures — directional NPC animation, and a wrong authorship claim — were identified, verified, and corrected</a:t>
+              <a:t>Rejected: Greedy &amp; BFS for routing, full occupant map, AI-video for toward/away; later, AI opening PRs or merging into master unprompted</a:t>
             </a:r>
           </a:p>
           <a:p>
@@ -3348,12 +3358,12 @@
               </a:spcAft>
             </a:pPr>
             <a:r>
-              <a:rPr sz="1600">
+              <a:rPr sz="1300">
                 <a:solidFill>
                   <a:srgbClr val="222222"/>
                 </a:solidFill>
               </a:rPr>
-              <a:t>An optional learned-AI brain (imitating A*) was added and evaluated: it roughly matches A* on familiar stages and trails it on new ones — A* stays the default</a:t>
+              <a:t>Verified via: search theory, a purpose-built harness, unit tests, assets vs engine requirements; later, real screenshots, the real test suite, the real game run end-to-end</a:t>
             </a:r>
           </a:p>
           <a:p>
@@ -3363,12 +3373,42 @@
               </a:spcAft>
             </a:pPr>
             <a:r>
-              <a:rPr sz="1600">
+              <a:rPr sz="1300">
                 <a:solidFill>
                   <a:srgbClr val="222222"/>
                 </a:solidFill>
               </a:rPr>
-              <a:t>AI widened the option space and sped the work; the objective, the verification and every final decision were ours</a:t>
+              <a:t>Human judgement was necessary for: scope, tuning, seeing the AI failure was narrow, the Responsible-AI stance, catching the wrong-authorship claim, judging the UI by eye</a:t>
+            </a:r>
+          </a:p>
+          <a:p>
+            <a:pPr>
+              <a:spcAft>
+                <a:spcPts val="600"/>
+              </a:spcAft>
+            </a:pPr>
+            <a:r>
+              <a:rPr sz="1300">
+                <a:solidFill>
+                  <a:srgbClr val="222222"/>
+                </a:solidFill>
+              </a:rPr>
+              <a:t>If we'd blindly followed AI: agent walks through fire (looks like bad balance, not a wrong algorithm); a teammate wrongly credited; AI colliding with a teammate's work on master</a:t>
+            </a:r>
+          </a:p>
+          <a:p>
+            <a:pPr>
+              <a:spcAft>
+                <a:spcPts val="600"/>
+              </a:spcAft>
+            </a:pPr>
+            <a:r>
+              <a:rPr sz="1300">
+                <a:solidFill>
+                  <a:srgbClr val="222222"/>
+                </a:solidFill>
+              </a:rPr>
+              <a:t>Learned: a technically-true claim (“fewer expansions”) can still be wrong for the problem; a git commit proves whose account, not who typed the code — verify evidence, not summaries</a:t>
             </a:r>
           </a:p>
         </p:txBody>
@@ -3419,17 +3459,7 @@
                   <a:srgbClr val="1F4E79"/>
                 </a:solidFill>
               </a:rPr>
-              <a:t>Critical Evaluation — What AI Got Wrong</a:t>
-            </a:r>
-          </a:p>
-          <a:p>
-            <a:r>
-              <a:rPr sz="1300">
-                <a:solidFill>
-                  <a:srgbClr val="666666"/>
-                </a:solidFill>
-              </a:rPr>
-              <a:t>Compulsory slide — what worked, what didn't, how it was verified</a:t>
+              <a:t>9 - Conclusion</a:t>
             </a:r>
           </a:p>
         </p:txBody>
@@ -3442,7 +3472,7 @@
         </p:nvSpPr>
         <p:spPr>
           <a:xfrm>
-            <a:off x="640080" y="1371600"/>
+            <a:off x="640080" y="1645920"/>
             <a:ext cx="10972800" cy="5029200"/>
           </a:xfrm>
           <a:prstGeom prst="rect">
@@ -3462,12 +3492,12 @@
               </a:spcAft>
             </a:pPr>
             <a:r>
-              <a:rPr sz="1500">
+              <a:rPr sz="1600">
                 <a:solidFill>
                   <a:srgbClr val="222222"/>
                 </a:solidFill>
               </a:rPr>
-              <a:t>What worked: side-view (left/right) walk clips, concept art, the whole implementation</a:t>
+              <a:t>Designed the agent human-first, then used AI to challenge and broaden it</a:t>
             </a:r>
           </a:p>
           <a:p>
@@ -3477,12 +3507,12 @@
               </a:spcAft>
             </a:pPr>
             <a:r>
-              <a:rPr sz="1500">
+              <a:rPr sz="1600">
                 <a:solidFill>
                   <a:srgbClr val="222222"/>
                 </a:solidFill>
               </a:rPr>
-              <a:t>What didn't: no working “toward camera” or “away from camera” walk, across multiple re-prompts — that axis never worked</a:t>
+              <a:t>AI moved us from unweighted BFS to a hazard-weighted A* agent that plans under partial information and re-plans as the building changes</a:t>
             </a:r>
           </a:p>
           <a:p>
@@ -3492,12 +3522,12 @@
               </a:spcAft>
             </a:pPr>
             <a:r>
-              <a:rPr sz="1500">
+              <a:rPr sz="1600">
                 <a:solidFill>
                   <a:srgbClr val="222222"/>
                 </a:solidFill>
               </a:rPr>
-              <a:t>What AI got wrong: it treated “looks like a walk” as done; it never delivered a complete, 4-direction, production-ready set</a:t>
+              <a:t>Tested an AI recommendation (Greedy) against a purpose-built comparison — found it inappropriate, rejected it with evidence</a:t>
             </a:r>
           </a:p>
           <a:p>
@@ -3507,12 +3537,12 @@
               </a:spcAft>
             </a:pPr>
             <a:r>
-              <a:rPr sz="1500">
+              <a:rPr sz="1600">
                 <a:solidFill>
                   <a:srgbClr val="222222"/>
                 </a:solidFill>
               </a:rPr>
-              <a:t>How verified: checked against the engine's own requirements — 4 directions, fixed sprite size, feet-anchored — it met exactly one of four</a:t>
+              <a:t>The AI's clearest failures — directional NPC animation, and a wrong authorship claim — were identified, verified, and corrected</a:t>
             </a:r>
           </a:p>
           <a:p>
@@ -3522,12 +3552,12 @@
               </a:spcAft>
             </a:pPr>
             <a:r>
-              <a:rPr sz="1500">
+              <a:rPr sz="1600">
                 <a:solidFill>
                   <a:srgbClr val="222222"/>
                 </a:solidFill>
               </a:rPr>
-              <a:t>Corrected: assembled the 4-direction set from mixed sources (front/back from the character sheet, one side frame mirrored) + a procedural walk bob</a:t>
+              <a:t>An optional learned-AI brain (imitating A*) was added and evaluated: it roughly matches A* on familiar stages and trails it on new ones — A* stays the default</a:t>
             </a:r>
           </a:p>
           <a:p>
@@ -3537,27 +3567,12 @@
               </a:spcAft>
             </a:pPr>
             <a:r>
-              <a:rPr sz="1500">
+              <a:rPr sz="1600">
                 <a:solidFill>
                   <a:srgbClr val="222222"/>
                 </a:solidFill>
               </a:rPr>
-              <a:t>Second example: AI also claimed a teammate personally wrote a feature based only on a git commit's account — challenged, and corrected (a commit proves whose account, not who typed the code)</a:t>
-            </a:r>
-          </a:p>
-          <a:p>
-            <a:pPr>
-              <a:spcAft>
-                <a:spcPts val="600"/>
-              </a:spcAft>
-            </a:pPr>
-            <a:r>
-              <a:rPr sz="1500">
-                <a:solidFill>
-                  <a:srgbClr val="222222"/>
-                </a:solidFill>
-              </a:rPr>
-              <a:t>This is the mandatory identified → verified → corrected example.</a:t>
+              <a:t>AI widened the option space and sped the work; the objective, the verification and every final decision were ours</a:t>
             </a:r>
           </a:p>
         </p:txBody>
@@ -5932,7 +5947,7 @@
                   <a:srgbClr val="1F4E79"/>
                 </a:solidFill>
               </a:rPr>
-              <a:t>8 - Human-AI Reflection</a:t>
+              <a:t>Critical Evaluation — What AI Got Wrong</a:t>
             </a:r>
           </a:p>
           <a:p>
@@ -5942,7 +5957,7 @@
                   <a:srgbClr val="666666"/>
                 </a:solidFill>
               </a:rPr>
-              <a:t>Phase 8, Stage 9 - MANDATORY</a:t>
+              <a:t>Compulsory slide — what worked, what didn't, how it was verified</a:t>
             </a:r>
           </a:p>
         </p:txBody>
@@ -5975,12 +5990,12 @@
               </a:spcAft>
             </a:pPr>
             <a:r>
-              <a:rPr sz="1300">
+              <a:rPr sz="1500">
                 <a:solidFill>
                   <a:srgbClr val="222222"/>
                 </a:solidFill>
               </a:rPr>
-              <a:t>AI helped: explained tiles-vs-cost, listed search options, caught bad assumptions; later, built the whole UI rebuild fast (results, menus, pause, HUD, intro)</a:t>
+              <a:t>What worked: side-view (left/right) walk clips, concept art, the whole implementation</a:t>
             </a:r>
           </a:p>
           <a:p>
@@ -5990,12 +6005,12 @@
               </a:spcAft>
             </a:pPr>
             <a:r>
-              <a:rPr sz="1300">
+              <a:rPr sz="1500">
                 <a:solidFill>
                   <a:srgbClr val="222222"/>
                 </a:solidFill>
               </a:rPr>
-              <a:t>AI got wrong: the video model couldn't animate toward/away from camera; recommended Greedy without weighing safe vs fast; later, wrongly credited a teammate for a feature based only on a git commit's account</a:t>
+              <a:t>What didn't: no working “toward camera” or “away from camera” walk, across multiple re-prompts — that axis never worked</a:t>
             </a:r>
           </a:p>
           <a:p>
@@ -6005,12 +6020,12 @@
               </a:spcAft>
             </a:pPr>
             <a:r>
-              <a:rPr sz="1300">
+              <a:rPr sz="1500">
                 <a:solidFill>
                   <a:srgbClr val="222222"/>
                 </a:solidFill>
               </a:rPr>
-              <a:t>Accepted: weighted costs, A*, partial observability, key sub-goal, connectivity-checked collapse, braided maze; later, the UI rebuild — reviewed screen by screen</a:t>
+              <a:t>What AI got wrong: it treated “looks like a walk” as done; it never delivered a complete, 4-direction, production-ready set</a:t>
             </a:r>
           </a:p>
           <a:p>
@@ -6020,12 +6035,12 @@
               </a:spcAft>
             </a:pPr>
             <a:r>
-              <a:rPr sz="1300">
+              <a:rPr sz="1500">
                 <a:solidFill>
                   <a:srgbClr val="222222"/>
                 </a:solidFill>
               </a:rPr>
-              <a:t>Rejected: Greedy &amp; BFS for routing, full occupant map, AI-video for toward/away; later, AI opening PRs or merging into master unprompted</a:t>
+              <a:t>How verified: checked against the engine's own requirements — 4 directions, fixed sprite size, feet-anchored — it met exactly one of four</a:t>
             </a:r>
           </a:p>
           <a:p>
@@ -6035,12 +6050,12 @@
               </a:spcAft>
             </a:pPr>
             <a:r>
-              <a:rPr sz="1300">
+              <a:rPr sz="1500">
                 <a:solidFill>
                   <a:srgbClr val="222222"/>
                 </a:solidFill>
               </a:rPr>
-              <a:t>Verified via: search theory, a purpose-built harness, unit tests, assets vs engine requirements; later, real screenshots, the real test suite, the real game run end-to-end</a:t>
+              <a:t>Corrected: assembled the 4-direction set from mixed sources (front/back from the character sheet, one side frame mirrored) + a procedural walk bob</a:t>
             </a:r>
           </a:p>
           <a:p>
@@ -6050,12 +6065,12 @@
               </a:spcAft>
             </a:pPr>
             <a:r>
-              <a:rPr sz="1300">
+              <a:rPr sz="1500">
                 <a:solidFill>
                   <a:srgbClr val="222222"/>
                 </a:solidFill>
               </a:rPr>
-              <a:t>Human judgement was necessary for: scope, tuning, seeing the AI failure was narrow, the Responsible-AI stance, catching the wrong-authorship claim, judging the UI by eye</a:t>
+              <a:t>Second example: AI also claimed a teammate personally wrote a feature based only on a git commit's account — challenged, and corrected (a commit proves whose account, not who typed the code)</a:t>
             </a:r>
           </a:p>
           <a:p>
@@ -6065,27 +6080,12 @@
               </a:spcAft>
             </a:pPr>
             <a:r>
-              <a:rPr sz="1300">
+              <a:rPr sz="1500">
                 <a:solidFill>
                   <a:srgbClr val="222222"/>
                 </a:solidFill>
               </a:rPr>
-              <a:t>If we'd blindly followed AI: agent walks through fire (looks like bad balance, not a wrong algorithm); a teammate wrongly credited; AI colliding with a teammate's work on master</a:t>
-            </a:r>
-          </a:p>
-          <a:p>
-            <a:pPr>
-              <a:spcAft>
-                <a:spcPts val="600"/>
-              </a:spcAft>
-            </a:pPr>
-            <a:r>
-              <a:rPr sz="1300">
-                <a:solidFill>
-                  <a:srgbClr val="222222"/>
-                </a:solidFill>
-              </a:rPr>
-              <a:t>Learned: a technically-true claim (“fewer expansions”) can still be wrong for the problem; a git commit proves whose account, not who typed the code — verify evidence, not summaries</a:t>
+              <a:t>This is the mandatory identified → verified → corrected example.</a:t>
             </a:r>
           </a:p>
         </p:txBody>

</xml_diff>

<commit_message>
Remove pause-screen "AI got it wrong" story from report and slides
Git history shows Jeb's account did author the original pause-screen
commit; the "AI wrongly credited a teammate" example no longer holds
up, so it's dropped from REPORT.md, the IEEE docx, the interaction log
(row 11), and both slides (9 and 10), with the AI-interaction-log rows
renumbered.

Co-Authored-By: Claude Sonnet 5 <noreply@anthropic.com>
</commit_message>
<xml_diff>
--- a/docs/report/CT3201_Slides.pptx
+++ b/docs/report/CT3201_Slides.pptx
@@ -3318,7 +3318,7 @@
                   <a:srgbClr val="222222"/>
                 </a:solidFill>
               </a:rPr>
-              <a:t>AI got wrong: the video model couldn't animate toward/away from camera; recommended Greedy without weighing safe vs fast; later, wrongly credited a teammate for a feature based only on a git commit's account</a:t>
+              <a:t>AI got wrong: the video model couldn't animate toward/away from camera; recommended Greedy without weighing safe vs fast</a:t>
             </a:r>
           </a:p>
           <a:p>
@@ -3378,7 +3378,7 @@
                   <a:srgbClr val="222222"/>
                 </a:solidFill>
               </a:rPr>
-              <a:t>Human judgement was necessary for: scope, tuning, seeing the AI failure was narrow, the Responsible-AI stance, catching the wrong-authorship claim, judging the UI by eye</a:t>
+              <a:t>Human judgement was necessary for: scope, tuning, seeing the AI failure was narrow, the Responsible-AI stance, judging the UI by eye</a:t>
             </a:r>
           </a:p>
           <a:p>
@@ -3393,7 +3393,7 @@
                   <a:srgbClr val="222222"/>
                 </a:solidFill>
               </a:rPr>
-              <a:t>If we'd blindly followed AI: agent walks through fire (looks like bad balance, not a wrong algorithm); a teammate wrongly credited; AI colliding with a teammate's work on master</a:t>
+              <a:t>If we'd blindly followed AI: agent walks through fire (looks like bad balance, not a wrong algorithm); AI colliding with a teammate's work on master</a:t>
             </a:r>
           </a:p>
           <a:p>
@@ -6056,21 +6056,6 @@
                 </a:solidFill>
               </a:rPr>
               <a:t>Corrected: assembled the 4-direction set from mixed sources (front/back from the character sheet, one side frame mirrored) + a procedural walk bob</a:t>
-            </a:r>
-          </a:p>
-          <a:p>
-            <a:pPr>
-              <a:spcAft>
-                <a:spcPts val="600"/>
-              </a:spcAft>
-            </a:pPr>
-            <a:r>
-              <a:rPr sz="1500">
-                <a:solidFill>
-                  <a:srgbClr val="222222"/>
-                </a:solidFill>
-              </a:rPr>
-              <a:t>Second example: AI also claimed a teammate personally wrote a feature based only on a git commit's account — challenged, and corrected (a commit proves whose account, not who typed the code)</a:t>
             </a:r>
           </a:p>
           <a:p>

</xml_diff>

<commit_message>
Slides: fold in the matric-number and conclusion-wording fixes
Same two fixes as fix/title-slide-matric-number and
fix/slide-conclusion-wording, reapplied here so the visual redesign
that follows builds on top of both instead of forking a third copy
of this binary file from master.

Co-Authored-By: Claude Sonnet 5 <noreply@anthropic.com>
</commit_message>
<xml_diff>
--- a/docs/report/CT3201_Slides.pptx
+++ b/docs/report/CT3201_Slides.pptx
@@ -3174,7 +3174,7 @@
                   <a:srgbClr val="222222"/>
                 </a:solidFill>
               </a:rPr>
-              <a:t>Team: Lee Tze Hian, Ong Chuan Hau (U2420725E), See Jun Wen (U2420456K)</a:t>
+              <a:t>Team: Lee Tze Hian (U2423241F), Ong Chuan Hau (U2420725E), See Jun Wen (U2420456K)</a:t>
             </a:r>
           </a:p>
           <a:p>
@@ -3542,7 +3542,7 @@
                   <a:srgbClr val="222222"/>
                 </a:solidFill>
               </a:rPr>
-              <a:t>The AI's clearest failures — directional NPC animation, and a wrong authorship claim — were identified, verified, and corrected</a:t>
+              <a:t>The AI's clearest failure — directional NPC animation — was identified, verified, and corrected</a:t>
             </a:r>
           </a:p>
           <a:p>

</xml_diff>

<commit_message>
Slides: bump table text from 10-11pt to 13pt to match the rest of the deck
Tables were a leftover from the original plain build script and sat
noticeably smaller than the 16pt bullets around them. Resized every
table cell's font only -- no color, bold or wording touched (verified
by diffing all text against the prior commit). Also incidentally
closes most of the dead space on the Responsible AI slide, since the
table now fills more of it.

Co-Authored-By: Claude Sonnet 5 <noreply@anthropic.com>
</commit_message>
<xml_diff>
--- a/docs/report/CT3201_Slides.pptx
+++ b/docs/report/CT3201_Slides.pptx
@@ -5227,7 +5227,7 @@
                     <a:lstStyle/>
                     <a:p>
                       <a:r>
-                        <a:rPr sz="1100" b="1">
+                        <a:rPr sz="1300" b="1">
                           <a:solidFill>
                             <a:srgbClr val="FFFFFF"/>
                           </a:solidFill>
@@ -5248,7 +5248,7 @@
                     <a:lstStyle/>
                     <a:p>
                       <a:r>
-                        <a:rPr sz="1100" b="1">
+                        <a:rPr sz="1300" b="1">
                           <a:solidFill>
                             <a:srgbClr val="FFFFFF"/>
                           </a:solidFill>
@@ -5271,7 +5271,7 @@
                     <a:lstStyle/>
                     <a:p>
                       <a:r>
-                        <a:rPr sz="1100"/>
+                        <a:rPr sz="1300"/>
                         <a:t>Agent</a:t>
                       </a:r>
                     </a:p>
@@ -5284,7 +5284,7 @@
                     <a:lstStyle/>
                     <a:p>
                       <a:r>
-                        <a:rPr sz="1100"/>
+                        <a:rPr sz="1300"/>
                         <a:t>one autonomous rescue unit (robot or drone skin, player's choice; human plays the same role)</a:t>
                       </a:r>
                     </a:p>
@@ -5299,7 +5299,7 @@
                     <a:lstStyle/>
                     <a:p>
                       <a:r>
-                        <a:rPr sz="1100"/>
+                        <a:rPr sz="1300"/>
                         <a:t>State</a:t>
                       </a:r>
                     </a:p>
@@ -5312,7 +5312,7 @@
                     <a:lstStyle/>
                     <a:p>
                       <a:r>
-                        <a:rPr sz="1100"/>
+                        <a:rPr sz="1300"/>
                         <a:t>current cell · occupant statuses · map seen so far · health</a:t>
                       </a:r>
                     </a:p>
@@ -5327,7 +5327,7 @@
                     <a:lstStyle/>
                     <a:p>
                       <a:r>
-                        <a:rPr sz="1100"/>
+                        <a:rPr sz="1300"/>
                         <a:t>Actions</a:t>
                       </a:r>
                     </a:p>
@@ -5340,7 +5340,7 @@
                     <a:lstStyle/>
                     <a:p>
                       <a:r>
-                        <a:rPr sz="1100"/>
+                        <a:rPr sz="1300"/>
                         <a:t>move to one of the 4 adjacent floor cells</a:t>
                       </a:r>
                     </a:p>
@@ -5355,7 +5355,7 @@
                     <a:lstStyle/>
                     <a:p>
                       <a:r>
-                        <a:rPr sz="1100"/>
+                        <a:rPr sz="1300"/>
                         <a:t>Goal</a:t>
                       </a:r>
                     </a:p>
@@ -5368,7 +5368,7 @@
                     <a:lstStyle/>
                     <a:p>
                       <a:r>
-                        <a:rPr sz="1100"/>
+                        <a:rPr sz="1300"/>
                         <a:t>lead every reachable occupant to the exit, then exit</a:t>
                       </a:r>
                     </a:p>
@@ -5383,7 +5383,7 @@
                     <a:lstStyle/>
                     <a:p>
                       <a:r>
-                        <a:rPr sz="1100"/>
+                        <a:rPr sz="1300"/>
                         <a:t>Cost</a:t>
                       </a:r>
                     </a:p>
@@ -5396,7 +5396,7 @@
                     <a:lstStyle/>
                     <a:p>
                       <a:r>
-                        <a:rPr sz="1100"/>
+                        <a:rPr sz="1300"/>
                         <a:t>1 / step + hazard surcharge (fire +8, smoke +2xdensity, panel +7.5, pending collapse +25)</a:t>
                       </a:r>
                     </a:p>
@@ -5411,7 +5411,7 @@
                     <a:lstStyle/>
                     <a:p>
                       <a:r>
-                        <a:rPr sz="1100"/>
+                        <a:rPr sz="1300"/>
                         <a:t>Constraints</a:t>
                       </a:r>
                     </a:p>
@@ -5424,7 +5424,7 @@
                     <a:lstStyle/>
                     <a:p>
                       <a:r>
-                        <a:rPr sz="1100"/>
+                        <a:rPr sz="1300"/>
                         <a:t>walls &amp; debris impassable; door impassable until key; health drains in hazards, 0 = run over</a:t>
                       </a:r>
                     </a:p>
@@ -5439,7 +5439,7 @@
                     <a:lstStyle/>
                     <a:p>
                       <a:r>
-                        <a:rPr sz="1100"/>
+                        <a:rPr sz="1300"/>
                         <a:t>Information</a:t>
                       </a:r>
                     </a:p>
@@ -5452,7 +5452,7 @@
                     <a:lstStyle/>
                     <a:p>
                       <a:r>
-                        <a:rPr sz="1100"/>
+                        <a:rPr sz="1300"/>
                         <a:t>PARTIAL - only cells/occupants within a vision radius; re-plan when reality differs</a:t>
                       </a:r>
                     </a:p>
@@ -5866,7 +5866,7 @@
                     <a:lstStyle/>
                     <a:p>
                       <a:r>
-                        <a:rPr sz="1100" b="1">
+                        <a:rPr sz="1300" b="1">
                           <a:solidFill>
                             <a:srgbClr val="FFFFFF"/>
                           </a:solidFill>
@@ -5887,7 +5887,7 @@
                     <a:lstStyle/>
                     <a:p>
                       <a:r>
-                        <a:rPr sz="1100" b="1">
+                        <a:rPr sz="1300" b="1">
                           <a:solidFill>
                             <a:srgbClr val="FFFFFF"/>
                           </a:solidFill>
@@ -5908,7 +5908,7 @@
                     <a:lstStyle/>
                     <a:p>
                       <a:r>
-                        <a:rPr sz="1100" b="1">
+                        <a:rPr sz="1300" b="1">
                           <a:solidFill>
                             <a:srgbClr val="FFFFFF"/>
                           </a:solidFill>
@@ -5931,7 +5931,7 @@
                     <a:lstStyle/>
                     <a:p>
                       <a:r>
-                        <a:rPr sz="1100"/>
+                        <a:rPr sz="1300"/>
                         <a:t>challenge BFS-with-fire-as-a-wall</a:t>
                       </a:r>
                     </a:p>
@@ -5944,7 +5944,7 @@
                     <a:lstStyle/>
                     <a:p>
                       <a:r>
-                        <a:rPr sz="1100"/>
+                        <a:rPr sz="1300"/>
                         <a:t>BFS minimises tiles, not danger - it walks through fire to save a step</a:t>
                       </a:r>
                     </a:p>
@@ -5957,7 +5957,7 @@
                     <a:lstStyle/>
                     <a:p>
                       <a:r>
-                        <a:rPr sz="1100"/>
+                        <a:rPr sz="1300"/>
                         <a:t>treat hazards as weighted costs; use cost-aware search</a:t>
                       </a:r>
                     </a:p>
@@ -5972,7 +5972,7 @@
                     <a:lstStyle/>
                     <a:p>
                       <a:r>
-                        <a:rPr sz="1100"/>
+                        <a:rPr sz="1300"/>
                         <a:t>suggest alternative search strategies</a:t>
                       </a:r>
                     </a:p>
@@ -5985,7 +5985,7 @@
                     <a:lstStyle/>
                     <a:p>
                       <a:r>
-                        <a:rPr sz="1100"/>
+                        <a:rPr sz="1300"/>
                         <a:t>Dijkstra / A* / Greedy and their trade-offs</a:t>
                       </a:r>
                     </a:p>
@@ -5998,7 +5998,7 @@
                     <a:lstStyle/>
                     <a:p>
                       <a:r>
-                        <a:rPr sz="1100"/>
+                        <a:rPr sz="1300"/>
                         <a:t>implement all four to compare on our own map</a:t>
                       </a:r>
                     </a:p>
@@ -6013,7 +6013,7 @@
                     <a:lstStyle/>
                     <a:p>
                       <a:r>
-                        <a:rPr sz="1100"/>
+                        <a:rPr sz="1300"/>
                         <a:t>point out assumptions</a:t>
                       </a:r>
                     </a:p>
@@ -6026,7 +6026,7 @@
                     <a:lstStyle/>
                     <a:p>
                       <a:r>
-                        <a:rPr sz="1100"/>
+                        <a:rPr sz="1300"/>
                         <a:t>we assumed a full map of occupant locations</a:t>
                       </a:r>
                     </a:p>
@@ -6039,7 +6039,7 @@
                     <a:lstStyle/>
                     <a:p>
                       <a:r>
-                        <a:rPr sz="1100"/>
+                        <a:rPr sz="1300"/>
                         <a:t>add partial observability + frontier exploration</a:t>
                       </a:r>
                     </a:p>
@@ -6054,7 +6054,7 @@
                     <a:lstStyle/>
                     <a:p>
                       <a:r>
-                        <a:rPr sz="1100"/>
+                        <a:rPr sz="1300"/>
                         <a:t>what could make it fail?</a:t>
                       </a:r>
                     </a:p>
@@ -6067,7 +6067,7 @@
                     <a:lstStyle/>
                     <a:p>
                       <a:r>
-                        <a:rPr sz="1100"/>
+                        <a:rPr sz="1300"/>
                         <a:t>locked door on the only corridor; a collapse could trap someone</a:t>
                       </a:r>
                     </a:p>
@@ -6080,7 +6080,7 @@
                     <a:lstStyle/>
                     <a:p>
                       <a:r>
-                        <a:rPr sz="1100"/>
+                        <a:rPr sz="1300"/>
                         <a:t>key sub-goal; connectivity-checked collapse</a:t>
                       </a:r>
                     </a:p>
@@ -6437,7 +6437,7 @@
                     <a:lstStyle/>
                     <a:p>
                       <a:r>
-                        <a:rPr sz="1000" b="1">
+                        <a:rPr sz="1300" b="1">
                           <a:solidFill>
                             <a:srgbClr val="FFFFFF"/>
                           </a:solidFill>
@@ -6458,7 +6458,7 @@
                     <a:lstStyle/>
                     <a:p>
                       <a:r>
-                        <a:rPr sz="1000" b="1">
+                        <a:rPr sz="1300" b="1">
                           <a:solidFill>
                             <a:srgbClr val="FFFFFF"/>
                           </a:solidFill>
@@ -6479,7 +6479,7 @@
                     <a:lstStyle/>
                     <a:p>
                       <a:r>
-                        <a:rPr sz="1000" b="1">
+                        <a:rPr sz="1300" b="1">
                           <a:solidFill>
                             <a:srgbClr val="FFFFFF"/>
                           </a:solidFill>
@@ -6502,7 +6502,7 @@
                     <a:lstStyle/>
                     <a:p>
                       <a:r>
-                        <a:rPr sz="1000" b="1">
+                        <a:rPr sz="1300" b="1">
                           <a:solidFill>
                             <a:srgbClr val="A32B1F"/>
                           </a:solidFill>
@@ -6523,7 +6523,7 @@
                     <a:lstStyle/>
                     <a:p>
                       <a:r>
-                        <a:rPr sz="1000" b="1">
+                        <a:rPr sz="1300" b="1">
                           <a:solidFill>
                             <a:srgbClr val="A32B1F"/>
                           </a:solidFill>
@@ -6544,7 +6544,7 @@
                     <a:lstStyle/>
                     <a:p>
                       <a:r>
-                        <a:rPr sz="1000" b="1">
+                        <a:rPr sz="1300" b="1">
                           <a:solidFill>
                             <a:srgbClr val="A32B1F"/>
                           </a:solidFill>
@@ -6567,7 +6567,7 @@
                     <a:lstStyle/>
                     <a:p>
                       <a:r>
-                        <a:rPr sz="1000" b="1">
+                        <a:rPr sz="1300" b="1">
                           <a:solidFill>
                             <a:srgbClr val="1E6B3D"/>
                           </a:solidFill>
@@ -6588,7 +6588,7 @@
                     <a:lstStyle/>
                     <a:p>
                       <a:r>
-                        <a:rPr sz="1000" b="1">
+                        <a:rPr sz="1300" b="1">
                           <a:solidFill>
                             <a:srgbClr val="1E6B3D"/>
                           </a:solidFill>
@@ -6609,7 +6609,7 @@
                     <a:lstStyle/>
                     <a:p>
                       <a:r>
-                        <a:rPr sz="1000" b="1">
+                        <a:rPr sz="1300" b="1">
                           <a:solidFill>
                             <a:srgbClr val="1E6B3D"/>
                           </a:solidFill>
@@ -6632,7 +6632,7 @@
                     <a:lstStyle/>
                     <a:p>
                       <a:r>
-                        <a:rPr sz="1000" b="1">
+                        <a:rPr sz="1300" b="1">
                           <a:solidFill>
                             <a:srgbClr val="1E6B3D"/>
                           </a:solidFill>
@@ -6653,7 +6653,7 @@
                     <a:lstStyle/>
                     <a:p>
                       <a:r>
-                        <a:rPr sz="1000" b="1">
+                        <a:rPr sz="1300" b="1">
                           <a:solidFill>
                             <a:srgbClr val="1E6B3D"/>
                           </a:solidFill>
@@ -6674,7 +6674,7 @@
                     <a:lstStyle/>
                     <a:p>
                       <a:r>
-                        <a:rPr sz="1000" b="1">
+                        <a:rPr sz="1300" b="1">
                           <a:solidFill>
                             <a:srgbClr val="1E6B3D"/>
                           </a:solidFill>
@@ -6697,7 +6697,7 @@
                     <a:lstStyle/>
                     <a:p>
                       <a:r>
-                        <a:rPr sz="1000" b="1">
+                        <a:rPr sz="1300" b="1">
                           <a:solidFill>
                             <a:srgbClr val="A32B1F"/>
                           </a:solidFill>
@@ -6718,7 +6718,7 @@
                     <a:lstStyle/>
                     <a:p>
                       <a:r>
-                        <a:rPr sz="1000" b="1">
+                        <a:rPr sz="1300" b="1">
                           <a:solidFill>
                             <a:srgbClr val="A32B1F"/>
                           </a:solidFill>
@@ -6739,7 +6739,7 @@
                     <a:lstStyle/>
                     <a:p>
                       <a:r>
-                        <a:rPr sz="1000" b="1">
+                        <a:rPr sz="1300" b="1">
                           <a:solidFill>
                             <a:srgbClr val="A32B1F"/>
                           </a:solidFill>
@@ -6762,7 +6762,7 @@
                     <a:lstStyle/>
                     <a:p>
                       <a:r>
-                        <a:rPr sz="1000" b="1">
+                        <a:rPr sz="1300" b="1">
                           <a:solidFill>
                             <a:srgbClr val="8A5A12"/>
                           </a:solidFill>
@@ -6783,7 +6783,7 @@
                     <a:lstStyle/>
                     <a:p>
                       <a:r>
-                        <a:rPr sz="1000" b="1">
+                        <a:rPr sz="1300" b="1">
                           <a:solidFill>
                             <a:srgbClr val="8A5A12"/>
                           </a:solidFill>
@@ -6804,7 +6804,7 @@
                     <a:lstStyle/>
                     <a:p>
                       <a:r>
-                        <a:rPr sz="1000" b="1">
+                        <a:rPr sz="1300" b="1">
                           <a:solidFill>
                             <a:srgbClr val="8A5A12"/>
                           </a:solidFill>
@@ -6827,7 +6827,7 @@
                     <a:lstStyle/>
                     <a:p>
                       <a:r>
-                        <a:rPr sz="1000" b="1">
+                        <a:rPr sz="1300" b="1">
                           <a:solidFill>
                             <a:srgbClr val="A32B1F"/>
                           </a:solidFill>
@@ -6848,7 +6848,7 @@
                     <a:lstStyle/>
                     <a:p>
                       <a:r>
-                        <a:rPr sz="1000" b="1">
+                        <a:rPr sz="1300" b="1">
                           <a:solidFill>
                             <a:srgbClr val="A32B1F"/>
                           </a:solidFill>
@@ -6869,7 +6869,7 @@
                     <a:lstStyle/>
                     <a:p>
                       <a:r>
-                        <a:rPr sz="1000" b="1">
+                        <a:rPr sz="1300" b="1">
                           <a:solidFill>
                             <a:srgbClr val="A32B1F"/>
                           </a:solidFill>
@@ -7840,7 +7840,7 @@
                     <a:lstStyle/>
                     <a:p>
                       <a:r>
-                        <a:rPr sz="1200" b="1">
+                        <a:rPr sz="1300" b="1">
                           <a:solidFill>
                             <a:srgbClr val="FFFFFF"/>
                           </a:solidFill>
@@ -7861,7 +7861,7 @@
                     <a:lstStyle/>
                     <a:p>
                       <a:r>
-                        <a:rPr sz="1200" b="1">
+                        <a:rPr sz="1300" b="1">
                           <a:solidFill>
                             <a:srgbClr val="FFFFFF"/>
                           </a:solidFill>
@@ -7882,7 +7882,7 @@
                     <a:lstStyle/>
                     <a:p>
                       <a:r>
-                        <a:rPr sz="1200" b="1">
+                        <a:rPr sz="1300" b="1">
                           <a:solidFill>
                             <a:srgbClr val="FFFFFF"/>
                           </a:solidFill>
@@ -7903,7 +7903,7 @@
                     <a:lstStyle/>
                     <a:p>
                       <a:r>
-                        <a:rPr sz="1200" b="1">
+                        <a:rPr sz="1300" b="1">
                           <a:solidFill>
                             <a:srgbClr val="FFFFFF"/>
                           </a:solidFill>
@@ -7926,7 +7926,7 @@
                     <a:lstStyle/>
                     <a:p>
                       <a:r>
-                        <a:rPr sz="1200" b="1">
+                        <a:rPr sz="1300" b="1">
                           <a:solidFill>
                             <a:srgbClr val="A32B1F"/>
                           </a:solidFill>
@@ -7947,7 +7947,7 @@
                     <a:lstStyle/>
                     <a:p>
                       <a:r>
-                        <a:rPr sz="1200" b="1">
+                        <a:rPr sz="1300" b="1">
                           <a:solidFill>
                             <a:srgbClr val="A32B1F"/>
                           </a:solidFill>
@@ -7968,7 +7968,7 @@
                     <a:lstStyle/>
                     <a:p>
                       <a:r>
-                        <a:rPr sz="1200" b="1">
+                        <a:rPr sz="1300" b="1">
                           <a:solidFill>
                             <a:srgbClr val="A32B1F"/>
                           </a:solidFill>
@@ -7989,7 +7989,7 @@
                     <a:lstStyle/>
                     <a:p>
                       <a:r>
-                        <a:rPr sz="1200" b="1">
+                        <a:rPr sz="1300" b="1">
                           <a:solidFill>
                             <a:srgbClr val="A32B1F"/>
                           </a:solidFill>
@@ -8012,7 +8012,7 @@
                     <a:lstStyle/>
                     <a:p>
                       <a:r>
-                        <a:rPr sz="1200"/>
+                        <a:rPr sz="1300"/>
                         <a:t>Dijkstra</a:t>
                       </a:r>
                     </a:p>
@@ -8025,7 +8025,7 @@
                     <a:lstStyle/>
                     <a:p>
                       <a:r>
-                        <a:rPr sz="1200"/>
+                        <a:rPr sz="1300"/>
                         <a:t>43.8</a:t>
                       </a:r>
                     </a:p>
@@ -8038,7 +8038,7 @@
                     <a:lstStyle/>
                     <a:p>
                       <a:r>
-                        <a:rPr sz="1200"/>
+                        <a:rPr sz="1300"/>
                         <a:t>42</a:t>
                       </a:r>
                     </a:p>
@@ -8051,7 +8051,7 @@
                     <a:lstStyle/>
                     <a:p>
                       <a:r>
-                        <a:rPr sz="1200"/>
+                        <a:rPr sz="1300"/>
                         <a:t>2</a:t>
                       </a:r>
                     </a:p>
@@ -8066,7 +8066,7 @@
                     <a:lstStyle/>
                     <a:p>
                       <a:r>
-                        <a:rPr sz="1200" b="1">
+                        <a:rPr sz="1300" b="1">
                           <a:solidFill>
                             <a:srgbClr val="1E6B3D"/>
                           </a:solidFill>
@@ -8087,7 +8087,7 @@
                     <a:lstStyle/>
                     <a:p>
                       <a:r>
-                        <a:rPr sz="1200" b="1">
+                        <a:rPr sz="1300" b="1">
                           <a:solidFill>
                             <a:srgbClr val="1E6B3D"/>
                           </a:solidFill>
@@ -8108,7 +8108,7 @@
                     <a:lstStyle/>
                     <a:p>
                       <a:r>
-                        <a:rPr sz="1200" b="1">
+                        <a:rPr sz="1300" b="1">
                           <a:solidFill>
                             <a:srgbClr val="1E6B3D"/>
                           </a:solidFill>
@@ -8129,7 +8129,7 @@
                     <a:lstStyle/>
                     <a:p>
                       <a:r>
-                        <a:rPr sz="1200" b="1">
+                        <a:rPr sz="1300" b="1">
                           <a:solidFill>
                             <a:srgbClr val="1E6B3D"/>
                           </a:solidFill>
@@ -8152,7 +8152,7 @@
                     <a:lstStyle/>
                     <a:p>
                       <a:r>
-                        <a:rPr sz="1200" b="1">
+                        <a:rPr sz="1300" b="1">
                           <a:solidFill>
                             <a:srgbClr val="A32B1F"/>
                           </a:solidFill>
@@ -8173,7 +8173,7 @@
                     <a:lstStyle/>
                     <a:p>
                       <a:r>
-                        <a:rPr sz="1200" b="1">
+                        <a:rPr sz="1300" b="1">
                           <a:solidFill>
                             <a:srgbClr val="A32B1F"/>
                           </a:solidFill>
@@ -8194,7 +8194,7 @@
                     <a:lstStyle/>
                     <a:p>
                       <a:r>
-                        <a:rPr sz="1200" b="1">
+                        <a:rPr sz="1300" b="1">
                           <a:solidFill>
                             <a:srgbClr val="A32B1F"/>
                           </a:solidFill>
@@ -8215,7 +8215,7 @@
                     <a:lstStyle/>
                     <a:p>
                       <a:r>
-                        <a:rPr sz="1200" b="1">
+                        <a:rPr sz="1300" b="1">
                           <a:solidFill>
                             <a:srgbClr val="A32B1F"/>
                           </a:solidFill>
@@ -8704,7 +8704,7 @@
                     <a:lstStyle/>
                     <a:p>
                       <a:r>
-                        <a:rPr sz="1000" b="1">
+                        <a:rPr sz="1300" b="1">
                           <a:solidFill>
                             <a:srgbClr val="FFFFFF"/>
                           </a:solidFill>
@@ -8725,7 +8725,7 @@
                     <a:lstStyle/>
                     <a:p>
                       <a:r>
-                        <a:rPr sz="1000" b="1">
+                        <a:rPr sz="1300" b="1">
                           <a:solidFill>
                             <a:srgbClr val="FFFFFF"/>
                           </a:solidFill>
@@ -8748,7 +8748,7 @@
                     <a:lstStyle/>
                     <a:p>
                       <a:r>
-                        <a:rPr sz="1000"/>
+                        <a:rPr sz="1300"/>
                         <a:t>Fairness</a:t>
                       </a:r>
                     </a:p>
@@ -8761,7 +8761,7 @@
                     <a:lstStyle/>
                     <a:p>
                       <a:r>
-                        <a:rPr sz="1000"/>
+                        <a:rPr sz="1300"/>
                         <a:t>in-game the AI agent takes hazard damage &amp; has the same vision as the human - fair by construction</a:t>
                       </a:r>
                     </a:p>
@@ -8776,7 +8776,7 @@
                     <a:lstStyle/>
                     <a:p>
                       <a:r>
-                        <a:rPr sz="1000"/>
+                        <a:rPr sz="1300"/>
                         <a:t>Bias</a:t>
                       </a:r>
                     </a:p>
@@ -8789,7 +8789,7 @@
                     <a:lstStyle/>
                     <a:p>
                       <a:r>
-                        <a:rPr sz="1000"/>
+                        <a:rPr sz="1300"/>
                         <a:t>goal selection is greedy nearest-first: no triage, no notion of who is most at risk</a:t>
                       </a:r>
                     </a:p>
@@ -8804,7 +8804,7 @@
                     <a:lstStyle/>
                     <a:p>
                       <a:r>
-                        <a:rPr sz="1000"/>
+                        <a:rPr sz="1300"/>
                         <a:t>Transparency</a:t>
                       </a:r>
                     </a:p>
@@ -8817,7 +8817,7 @@
                     <a:lstStyle/>
                     <a:p>
                       <a:r>
-                        <a:rPr sz="1000"/>
+                        <a:rPr sz="1300"/>
                         <a:t>the agent DRAWS its planned route + walked trail - you can see what it decided and why it changed</a:t>
                       </a:r>
                     </a:p>
@@ -8832,7 +8832,7 @@
                     <a:lstStyle/>
                     <a:p>
                       <a:r>
-                        <a:rPr sz="1000"/>
+                        <a:rPr sz="1300"/>
                         <a:t>Privacy</a:t>
                       </a:r>
                     </a:p>
@@ -8845,7 +8845,7 @@
                     <a:lstStyle/>
                     <a:p>
                       <a:r>
-                        <a:rPr sz="1000"/>
+                        <a:rPr sz="1300"/>
                         <a:t>a real occupant-locator needs live location data on people - sensitive, must be minimised</a:t>
                       </a:r>
                     </a:p>
@@ -8860,7 +8860,7 @@
                     <a:lstStyle/>
                     <a:p>
                       <a:r>
-                        <a:rPr sz="1000"/>
+                        <a:rPr sz="1300"/>
                         <a:t>Security</a:t>
                       </a:r>
                     </a:p>
@@ -8873,7 +8873,7 @@
                     <a:lstStyle/>
                     <a:p>
                       <a:r>
-                        <a:rPr sz="1000"/>
+                        <a:rPr sz="1300"/>
                         <a:t>the agent trusts its hazard map; a spoofed feed could steer it (and followers) into a hazard</a:t>
                       </a:r>
                     </a:p>
@@ -8888,7 +8888,7 @@
                     <a:lstStyle/>
                     <a:p>
                       <a:r>
-                        <a:rPr sz="1000"/>
+                        <a:rPr sz="1300"/>
                         <a:t>Accountability</a:t>
                       </a:r>
                     </a:p>
@@ -8901,7 +8901,7 @@
                     <a:lstStyle/>
                     <a:p>
                       <a:r>
-                        <a:rPr sz="1000"/>
+                        <a:rPr sz="1300"/>
                         <a:t>if it leads someone into a collapse - operator? developer? sensor vendor? needs an audit log</a:t>
                       </a:r>
                     </a:p>
@@ -8916,7 +8916,7 @@
                     <a:lstStyle/>
                     <a:p>
                       <a:r>
-                        <a:rPr sz="1000"/>
+                        <a:rPr sz="1300"/>
                         <a:t>Human oversight</a:t>
                       </a:r>
                     </a:p>
@@ -8929,7 +8929,7 @@
                     <a:lstStyle/>
                     <a:p>
                       <a:r>
-                        <a:rPr sz="1000"/>
+                        <a:rPr sz="1300"/>
                         <a:t>it's decision-support, not an autonomous replacement for firefighters - the right posture</a:t>
                       </a:r>
                     </a:p>

</xml_diff>

<commit_message>
Slides: capitalize Search/Intelligent/Decision-making and And on the title slide
Co-Authored-By: Claude Sonnet 5 <noreply@anthropic.com>
</commit_message>
<xml_diff>
--- a/docs/report/CT3201_Slides.pptx
+++ b/docs/report/CT3201_Slides.pptx
@@ -3271,7 +3271,7 @@
                   <a:srgbClr val="2B2B2B"/>
                 </a:solidFill>
               </a:rPr>
-              <a:t>search / intelligent agent / decision-making under uncertainty</a:t>
+              <a:t>Search / Intelligent agent / Decision-making under uncertainty</a:t>
             </a:r>
           </a:p>
           <a:p>
@@ -3297,7 +3297,7 @@
                   <a:srgbClr val="2B2B2B"/>
                 </a:solidFill>
               </a:rPr>
-              <a:t>Can AI help us design AI — and can we recognise when AI is wrong?</a:t>
+              <a:t>Can AI help us design AI — And can we recognise when AI is wrong?</a:t>
             </a:r>
           </a:p>
         </p:txBody>

</xml_diff>

<commit_message>
Slides: center the Element column header and labels in the formulation table
Vertically centers the single-word labels within rows made taller by
the wrapped text in the Our project column, instead of sitting pinned
to the top.

Co-Authored-By: Claude Sonnet 5 <noreply@anthropic.com>
</commit_message>
<xml_diff>
--- a/docs/report/CT3201_Slides.pptx
+++ b/docs/report/CT3201_Slides.pptx
@@ -5226,6 +5226,7 @@
                     <a:bodyPr/>
                     <a:lstStyle/>
                     <a:p>
+                      <a:pPr algn="ctr"/>
                       <a:r>
                         <a:rPr sz="1300" b="1">
                           <a:solidFill>
@@ -5236,7 +5237,7 @@
                       </a:r>
                     </a:p>
                   </a:txBody>
-                  <a:tcPr>
+                  <a:tcPr anchor="ctr">
                     <a:solidFill>
                       <a:srgbClr val="1F4E79"/>
                     </a:solidFill>
@@ -5270,13 +5271,14 @@
                     <a:bodyPr/>
                     <a:lstStyle/>
                     <a:p>
+                      <a:pPr algn="ctr"/>
                       <a:r>
                         <a:rPr sz="1300"/>
                         <a:t>Agent</a:t>
                       </a:r>
                     </a:p>
                   </a:txBody>
-                  <a:tcPr/>
+                  <a:tcPr anchor="ctr"/>
                 </a:tc>
                 <a:tc>
                   <a:txBody>
@@ -5298,13 +5300,14 @@
                     <a:bodyPr/>
                     <a:lstStyle/>
                     <a:p>
+                      <a:pPr algn="ctr"/>
                       <a:r>
                         <a:rPr sz="1300"/>
                         <a:t>State</a:t>
                       </a:r>
                     </a:p>
                   </a:txBody>
-                  <a:tcPr/>
+                  <a:tcPr anchor="ctr"/>
                 </a:tc>
                 <a:tc>
                   <a:txBody>
@@ -5326,13 +5329,14 @@
                     <a:bodyPr/>
                     <a:lstStyle/>
                     <a:p>
+                      <a:pPr algn="ctr"/>
                       <a:r>
                         <a:rPr sz="1300"/>
                         <a:t>Actions</a:t>
                       </a:r>
                     </a:p>
                   </a:txBody>
-                  <a:tcPr/>
+                  <a:tcPr anchor="ctr"/>
                 </a:tc>
                 <a:tc>
                   <a:txBody>
@@ -5354,13 +5358,14 @@
                     <a:bodyPr/>
                     <a:lstStyle/>
                     <a:p>
+                      <a:pPr algn="ctr"/>
                       <a:r>
                         <a:rPr sz="1300"/>
                         <a:t>Goal</a:t>
                       </a:r>
                     </a:p>
                   </a:txBody>
-                  <a:tcPr/>
+                  <a:tcPr anchor="ctr"/>
                 </a:tc>
                 <a:tc>
                   <a:txBody>
@@ -5382,13 +5387,14 @@
                     <a:bodyPr/>
                     <a:lstStyle/>
                     <a:p>
+                      <a:pPr algn="ctr"/>
                       <a:r>
                         <a:rPr sz="1300"/>
                         <a:t>Cost</a:t>
                       </a:r>
                     </a:p>
                   </a:txBody>
-                  <a:tcPr/>
+                  <a:tcPr anchor="ctr"/>
                 </a:tc>
                 <a:tc>
                   <a:txBody>
@@ -5410,13 +5416,14 @@
                     <a:bodyPr/>
                     <a:lstStyle/>
                     <a:p>
+                      <a:pPr algn="ctr"/>
                       <a:r>
                         <a:rPr sz="1300"/>
                         <a:t>Constraints</a:t>
                       </a:r>
                     </a:p>
                   </a:txBody>
-                  <a:tcPr/>
+                  <a:tcPr anchor="ctr"/>
                 </a:tc>
                 <a:tc>
                   <a:txBody>
@@ -5438,13 +5445,14 @@
                     <a:bodyPr/>
                     <a:lstStyle/>
                     <a:p>
+                      <a:pPr algn="ctr"/>
                       <a:r>
                         <a:rPr sz="1300"/>
                         <a:t>Information</a:t>
                       </a:r>
                     </a:p>
                   </a:txBody>
-                  <a:tcPr/>
+                  <a:tcPr anchor="ctr"/>
                 </a:tc>
                 <a:tc>
                   <a:txBody>

</xml_diff>

<commit_message>
Slides: vertically center and capitalize the Our project column
Same vertical-centering treatment as the Element column. Also
capitalized the first letter of every cell for consistency, and
normalized "PARTIAL" (the one all-caps outlier) to sentence case
"Partial" to match the rest.

Co-Authored-By: Claude Sonnet 5 <noreply@anthropic.com>
</commit_message>
<xml_diff>
--- a/docs/report/CT3201_Slides.pptx
+++ b/docs/report/CT3201_Slides.pptx
@@ -5258,7 +5258,7 @@
                       </a:r>
                     </a:p>
                   </a:txBody>
-                  <a:tcPr>
+                  <a:tcPr anchor="ctr">
                     <a:solidFill>
                       <a:srgbClr val="1F4E79"/>
                     </a:solidFill>
@@ -5287,11 +5287,11 @@
                     <a:p>
                       <a:r>
                         <a:rPr sz="1300"/>
-                        <a:t>one autonomous rescue unit (robot or drone skin, player's choice; human plays the same role)</a:t>
+                        <a:t>One autonomous rescue unit (robot or drone skin, player's choice; human plays the same role)</a:t>
                       </a:r>
                     </a:p>
                   </a:txBody>
-                  <a:tcPr/>
+                  <a:tcPr anchor="ctr"/>
                 </a:tc>
               </a:tr>
               <a:tr h="365760">
@@ -5316,11 +5316,11 @@
                     <a:p>
                       <a:r>
                         <a:rPr sz="1300"/>
-                        <a:t>current cell · occupant statuses · map seen so far · health</a:t>
+                        <a:t>Current cell · occupant statuses · map seen so far · health</a:t>
                       </a:r>
                     </a:p>
                   </a:txBody>
-                  <a:tcPr/>
+                  <a:tcPr anchor="ctr"/>
                 </a:tc>
               </a:tr>
               <a:tr h="365760">
@@ -5345,11 +5345,11 @@
                     <a:p>
                       <a:r>
                         <a:rPr sz="1300"/>
-                        <a:t>move to one of the 4 adjacent floor cells</a:t>
+                        <a:t>Move to one of the 4 adjacent floor cells</a:t>
                       </a:r>
                     </a:p>
                   </a:txBody>
-                  <a:tcPr/>
+                  <a:tcPr anchor="ctr"/>
                 </a:tc>
               </a:tr>
               <a:tr h="365760">
@@ -5374,11 +5374,11 @@
                     <a:p>
                       <a:r>
                         <a:rPr sz="1300"/>
-                        <a:t>lead every reachable occupant to the exit, then exit</a:t>
+                        <a:t>Lead every reachable occupant to the exit, then exit</a:t>
                       </a:r>
                     </a:p>
                   </a:txBody>
-                  <a:tcPr/>
+                  <a:tcPr anchor="ctr"/>
                 </a:tc>
               </a:tr>
               <a:tr h="365760">
@@ -5407,7 +5407,7 @@
                       </a:r>
                     </a:p>
                   </a:txBody>
-                  <a:tcPr/>
+                  <a:tcPr anchor="ctr"/>
                 </a:tc>
               </a:tr>
               <a:tr h="365760">
@@ -5432,11 +5432,11 @@
                     <a:p>
                       <a:r>
                         <a:rPr sz="1300"/>
-                        <a:t>walls &amp; debris impassable; door impassable until key; health drains in hazards, 0 = run over</a:t>
+                        <a:t>Walls &amp; debris impassable; door impassable until key; health drains in hazards, 0 = run over</a:t>
                       </a:r>
                     </a:p>
                   </a:txBody>
-                  <a:tcPr/>
+                  <a:tcPr anchor="ctr"/>
                 </a:tc>
               </a:tr>
               <a:tr h="365760">
@@ -5461,11 +5461,11 @@
                     <a:p>
                       <a:r>
                         <a:rPr sz="1300"/>
-                        <a:t>PARTIAL - only cells/occupants within a vision radius; re-plan when reality differs</a:t>
+                        <a:t>Partial - only cells/occupants within a vision radius; re-plan when reality differs</a:t>
                       </a:r>
                     </a:p>
                   </a:txBody>
-                  <a:tcPr/>
+                  <a:tcPr anchor="ctr"/>
                 </a:tc>
               </a:tr>
             </a:tbl>

</xml_diff>

<commit_message>
Slides: capitalize the first letter of every bullet, table cell and subtitle
A full sweep, not just the slides already pointed out: every "Label:
lowercase..." bullet body, every table cell, every table header, and
the remaining "Phase X, Stage Y - lowercase..." subtitles are now
sentence case throughout.

Verified case-insensitive text is byte-identical to the prior commit
(same 181 paragraphs/cells, only casing differs) -- no wording lost.

Co-Authored-By: Claude Sonnet 5 <noreply@anthropic.com>
</commit_message>
<xml_diff>
--- a/docs/report/CT3201_Slides.pptx
+++ b/docs/report/CT3201_Slides.pptx
@@ -3614,7 +3614,7 @@
                   <a:srgbClr val="2B2B2B"/>
                 </a:solidFill>
               </a:rPr>
-              <a:t>explained tiles-vs-cost, listed search options, caught bad assumptions; later, built the whole UI rebuild fast (results, menus, pause, HUD, intro)</a:t>
+              <a:t>Explained tiles-vs-cost, listed search options, caught bad assumptions; later, built the whole UI rebuild fast (results, menus, pause, HUD, intro)</a:t>
             </a:r>
           </a:p>
           <a:p>
@@ -3648,7 +3648,7 @@
                   <a:srgbClr val="2B2B2B"/>
                 </a:solidFill>
               </a:rPr>
-              <a:t>the video model couldn't animate toward/away from camera; recommended Greedy without weighing safe vs fast</a:t>
+              <a:t>The video model couldn't animate toward/away from camera; recommended Greedy without weighing safe vs fast</a:t>
             </a:r>
           </a:p>
           <a:p>
@@ -3682,7 +3682,7 @@
                   <a:srgbClr val="2B2B2B"/>
                 </a:solidFill>
               </a:rPr>
-              <a:t>weighted costs, A*, partial observability, key sub-goal, connectivity-checked collapse, braided maze; later, the UI rebuild — reviewed screen by screen</a:t>
+              <a:t>Weighted costs, A*, partial observability, key sub-goal, connectivity-checked collapse, braided maze; later, the UI rebuild — reviewed screen by screen</a:t>
             </a:r>
           </a:p>
           <a:p>
@@ -3750,7 +3750,7 @@
                   <a:srgbClr val="2B2B2B"/>
                 </a:solidFill>
               </a:rPr>
-              <a:t>search theory, a purpose-built harness, unit tests, assets vs engine requirements; later, real screenshots, the real test suite, the real game run end-to-end</a:t>
+              <a:t>Search theory, a purpose-built harness, unit tests, assets vs engine requirements; later, real screenshots, the real test suite, the real game run end-to-end</a:t>
             </a:r>
           </a:p>
           <a:p>
@@ -3784,7 +3784,7 @@
                   <a:srgbClr val="2B2B2B"/>
                 </a:solidFill>
               </a:rPr>
-              <a:t>scope, tuning, seeing the AI failure was narrow, the Responsible-AI stance, judging the UI by eye</a:t>
+              <a:t>Scope, tuning, seeing the AI failure was narrow, the Responsible-AI stance, judging the UI by eye</a:t>
             </a:r>
           </a:p>
           <a:p>
@@ -3818,7 +3818,7 @@
                   <a:srgbClr val="2B2B2B"/>
                 </a:solidFill>
               </a:rPr>
-              <a:t>agent walks through fire (looks like bad balance, not a wrong algorithm); AI colliding with a teammate's work on master</a:t>
+              <a:t>Agent walks through fire (looks like bad balance, not a wrong algorithm); AI colliding with a teammate's work on master</a:t>
             </a:r>
           </a:p>
           <a:p>
@@ -3852,7 +3852,7 @@
                   <a:srgbClr val="2B2B2B"/>
                 </a:solidFill>
               </a:rPr>
-              <a:t>a technically-true claim (“fewer expansions”) can still be wrong for the problem; a git commit proves whose account, not who typed the code — verify evidence, not summaries</a:t>
+              <a:t>A technically-true claim (“fewer expansions”) can still be wrong for the problem; a git commit proves whose account, not who typed the code — verify evidence, not summaries</a:t>
             </a:r>
           </a:p>
         </p:txBody>
@@ -4708,7 +4708,7 @@
                   <a:srgbClr val="2B2B2B"/>
                 </a:solidFill>
               </a:rPr>
-              <a:t>occupants who don't know a burning building's layout must be found and led to an exit before fire, smoke and collapse cut the route off</a:t>
+              <a:t>Occupants who don't know a burning building's layout must be found and led to an exit before fire, smoke and collapse cut the route off</a:t>
             </a:r>
           </a:p>
           <a:p>
@@ -4742,7 +4742,7 @@
                   <a:srgbClr val="2B2B2B"/>
                 </a:solidFill>
               </a:rPr>
-              <a:t>a rescuer inside the building (human or AI) — the system is a decision-support tool that proposes a route, not an autonomous replacement</a:t>
+              <a:t>A rescuer inside the building (human or AI) — the system is a decision-support tool that proposes a route, not an autonomous replacement</a:t>
             </a:r>
           </a:p>
           <a:p>
@@ -4776,7 +4776,7 @@
                   <a:srgbClr val="2B2B2B"/>
                 </a:solidFill>
               </a:rPr>
-              <a:t>multi-room floor plan as a grid graph; hazards evolve over time; only a small radius is visible</a:t>
+              <a:t>Multi-room floor plan as a grid graph; hazards evolve over time; only a small radius is visible</a:t>
             </a:r>
           </a:p>
           <a:p>
@@ -4810,7 +4810,7 @@
                   <a:srgbClr val="2B2B2B"/>
                 </a:solidFill>
               </a:rPr>
-              <a:t>all reachable occupants out, then the rescuer out — fast, with minimal hazard exposure</a:t>
+              <a:t>All reachable occupants out, then the rescuer out — fast, with minimal hazard exposure</a:t>
             </a:r>
           </a:p>
           <a:p>
@@ -4844,7 +4844,7 @@
                   <a:srgbClr val="2B2B2B"/>
                 </a:solidFill>
               </a:rPr>
-              <a:t>push deeper for another occupant, or take the ones I have and get out now?</a:t>
+              <a:t>Push deeper for another occupant, or take the ones I have and get out now?</a:t>
             </a:r>
           </a:p>
           <a:p>
@@ -4878,7 +4878,7 @@
                   <a:srgbClr val="2B2B2B"/>
                 </a:solidFill>
               </a:rPr>
-              <a:t>the team brainstormed and picked this problem before opening any AI tool</a:t>
+              <a:t>The team brainstormed and picked this problem before opening any AI tool</a:t>
             </a:r>
           </a:p>
         </p:txBody>
@@ -5840,7 +5840,7 @@
                   <a:srgbClr val="C9D7E4"/>
                 </a:solidFill>
               </a:rPr>
-              <a:t>Phase 2, Stage 3 - used AI to challenge, not to design</a:t>
+              <a:t>Phase 2, Stage 3 - Used AI to challenge, not to design</a:t>
             </a:r>
           </a:p>
         </p:txBody>
@@ -5941,7 +5941,7 @@
                     <a:p>
                       <a:r>
                         <a:rPr sz="1300"/>
-                        <a:t>challenge BFS-with-fire-as-a-wall</a:t>
+                        <a:t>Challenge BFS-with-fire-as-a-wall</a:t>
                       </a:r>
                     </a:p>
                   </a:txBody>
@@ -5967,7 +5967,7 @@
                     <a:p>
                       <a:r>
                         <a:rPr sz="1300"/>
-                        <a:t>treat hazards as weighted costs; use cost-aware search</a:t>
+                        <a:t>Treat hazards as weighted costs; use cost-aware search</a:t>
                       </a:r>
                     </a:p>
                   </a:txBody>
@@ -5982,7 +5982,7 @@
                     <a:p>
                       <a:r>
                         <a:rPr sz="1300"/>
-                        <a:t>suggest alternative search strategies</a:t>
+                        <a:t>Suggest alternative search strategies</a:t>
                       </a:r>
                     </a:p>
                   </a:txBody>
@@ -6008,7 +6008,7 @@
                     <a:p>
                       <a:r>
                         <a:rPr sz="1300"/>
-                        <a:t>implement all four to compare on our own map</a:t>
+                        <a:t>Implement all four to compare on our own map</a:t>
                       </a:r>
                     </a:p>
                   </a:txBody>
@@ -6023,7 +6023,7 @@
                     <a:p>
                       <a:r>
                         <a:rPr sz="1300"/>
-                        <a:t>point out assumptions</a:t>
+                        <a:t>Point out assumptions</a:t>
                       </a:r>
                     </a:p>
                   </a:txBody>
@@ -6036,7 +6036,7 @@
                     <a:p>
                       <a:r>
                         <a:rPr sz="1300"/>
-                        <a:t>we assumed a full map of occupant locations</a:t>
+                        <a:t>We assumed a full map of occupant locations</a:t>
                       </a:r>
                     </a:p>
                   </a:txBody>
@@ -6049,7 +6049,7 @@
                     <a:p>
                       <a:r>
                         <a:rPr sz="1300"/>
-                        <a:t>add partial observability + frontier exploration</a:t>
+                        <a:t>Add partial observability + frontier exploration</a:t>
                       </a:r>
                     </a:p>
                   </a:txBody>
@@ -6064,7 +6064,7 @@
                     <a:p>
                       <a:r>
                         <a:rPr sz="1300"/>
-                        <a:t>what could make it fail?</a:t>
+                        <a:t>What could make it fail?</a:t>
                       </a:r>
                     </a:p>
                   </a:txBody>
@@ -6077,7 +6077,7 @@
                     <a:p>
                       <a:r>
                         <a:rPr sz="1300"/>
-                        <a:t>locked door on the only corridor; a collapse could trap someone</a:t>
+                        <a:t>Locked door on the only corridor; a collapse could trap someone</a:t>
                       </a:r>
                     </a:p>
                   </a:txBody>
@@ -6090,7 +6090,7 @@
                     <a:p>
                       <a:r>
                         <a:rPr sz="1300"/>
-                        <a:t>key sub-goal; connectivity-checked collapse</a:t>
+                        <a:t>Key sub-goal; connectivity-checked collapse</a:t>
                       </a:r>
                     </a:p>
                   </a:txBody>
@@ -6558,7 +6558,7 @@
                             <a:srgbClr val="A32B1F"/>
                           </a:solidFill>
                         </a:rPr>
-                        <a:t>not cost-optimal on a weighted map; comparison harness shows BFS routes through 9 fire tiles</a:t>
+                        <a:t>Not cost-optimal on a weighted map; comparison harness shows BFS routes through 9 fire tiles</a:t>
                       </a:r>
                     </a:p>
                   </a:txBody>
@@ -6623,7 +6623,7 @@
                             <a:srgbClr val="1E6B3D"/>
                           </a:solidFill>
                         </a:rPr>
-                        <a:t>ties Dijkstra for optimality, far fewer expansions; search theory + harness</a:t>
+                        <a:t>Ties Dijkstra for optimality, far fewer expansions; search theory + harness</a:t>
                       </a:r>
                     </a:p>
                   </a:txBody>
@@ -6688,7 +6688,7 @@
                             <a:srgbClr val="1E6B3D"/>
                           </a:solidFill>
                         </a:rPr>
-                        <a:t>fire-ring counting &amp; connectivity have no weights; unit tests</a:t>
+                        <a:t>Fire-ring counting &amp; connectivity have no weights; unit tests</a:t>
                       </a:r>
                     </a:p>
                   </a:txBody>
@@ -6753,7 +6753,7 @@
                             <a:srgbClr val="A32B1F"/>
                           </a:solidFill>
                         </a:rPr>
-                        <a:t>video model only did side-view, unstable; checked vs engine needs (see ai_critique.md)</a:t>
+                        <a:t>Video model only did side-view, unstable; checked vs engine needs (see ai_critique.md)</a:t>
                       </a:r>
                     </a:p>
                   </a:txBody>
@@ -6818,7 +6818,7 @@
                             <a:srgbClr val="8A5A12"/>
                           </a:solidFill>
                         </a:rPr>
-                        <a:t>every search returns the same route -&gt; braided the maze so routing has choices</a:t>
+                        <a:t>Every search returns the same route -&gt; braided the maze so routing has choices</a:t>
                       </a:r>
                     </a:p>
                   </a:txBody>
@@ -6883,7 +6883,7 @@
                             <a:srgbClr val="A32B1F"/>
                           </a:solidFill>
                         </a:rPr>
-                        <a:t>contradicts 'you don't know the building'; unbalances the human-vs-AI race</a:t>
+                        <a:t>Contradicts 'you don't know the building'; unbalances the human-vs-AI race</a:t>
                       </a:r>
                     </a:p>
                   </a:txBody>
@@ -7208,7 +7208,7 @@
                   <a:srgbClr val="C9D7E4"/>
                 </a:solidFill>
               </a:rPr>
-              <a:t>playable game + autonomous rescue agent (robot or drone skin)</a:t>
+              <a:t>Playable game + autonomous rescue agent (robot or drone skin)</a:t>
             </a:r>
           </a:p>
         </p:txBody>
@@ -7265,7 +7265,7 @@
                   <a:srgbClr val="2B2B2B"/>
                 </a:solidFill>
               </a:rPr>
-              <a:t>sense (vision radius) -&gt; choose goal -&gt; hazard-weighted A* plan -&gt; step -&gt; re-plan every 0.25 s</a:t>
+              <a:t>Sense (vision radius) -&gt; choose goal -&gt; hazard-weighted A* plan -&gt; step -&gt; re-plan every 0.25 s</a:t>
             </a:r>
           </a:p>
           <a:p>
@@ -7299,7 +7299,7 @@
                   <a:srgbClr val="2B2B2B"/>
                 </a:solidFill>
               </a:rPr>
-              <a:t>nearest KNOWN occupant by weighted distance; else nearest unexplored area; else the exit; key first if a door blocks the goal</a:t>
+              <a:t>Nearest KNOWN occupant by weighted distance; else nearest unexplored area; else the exit; key first if a door blocks the goal</a:t>
             </a:r>
           </a:p>
           <a:p>
@@ -7359,7 +7359,7 @@
                   <a:srgbClr val="2B2B2B"/>
                 </a:solidFill>
               </a:rPr>
-              <a:t>spreading fire + functional smoke • sparking panels • timed ceiling collapse • locked door + key • fog of war with memory</a:t>
+              <a:t>Spreading fire + functional smoke • sparking panels • timed ceiling collapse • locked door + key • fog of war with memory</a:t>
             </a:r>
           </a:p>
           <a:p>
@@ -7756,7 +7756,7 @@
                   <a:srgbClr val="C9D7E4"/>
                 </a:solidFill>
               </a:rPr>
-              <a:t>Phase 6, Stage 7 - testing an AI recommendation with evidence</a:t>
+              <a:t>Phase 6, Stage 7 - Testing an AI recommendation with evidence</a:t>
             </a:r>
           </a:p>
         </p:txBody>
@@ -7854,7 +7854,7 @@
                             <a:srgbClr val="FFFFFF"/>
                           </a:solidFill>
                         </a:rPr>
-                        <a:t>strategy</a:t>
+                        <a:t>Strategy</a:t>
                       </a:r>
                     </a:p>
                   </a:txBody>
@@ -7875,7 +7875,7 @@
                             <a:srgbClr val="FFFFFF"/>
                           </a:solidFill>
                         </a:rPr>
-                        <a:t>path cost</a:t>
+                        <a:t>Path cost</a:t>
                       </a:r>
                     </a:p>
                   </a:txBody>
@@ -7896,7 +7896,7 @@
                             <a:srgbClr val="FFFFFF"/>
                           </a:solidFill>
                         </a:rPr>
-                        <a:t>steps</a:t>
+                        <a:t>Steps</a:t>
                       </a:r>
                     </a:p>
                   </a:txBody>
@@ -7917,7 +7917,7 @@
                             <a:srgbClr val="FFFFFF"/>
                           </a:solidFill>
                         </a:rPr>
-                        <a:t>hazard tiles crossed</a:t>
+                        <a:t>Hazard tiles crossed</a:t>
                       </a:r>
                     </a:p>
                   </a:txBody>
@@ -8679,7 +8679,7 @@
                   <a:srgbClr val="C9D7E4"/>
                 </a:solidFill>
               </a:rPr>
-              <a:t>Phase 7, Stage 8 - should this system be deployed?</a:t>
+              <a:t>Phase 7, Stage 8 - Should this system be deployed?</a:t>
             </a:r>
           </a:p>
         </p:txBody>
@@ -8771,7 +8771,7 @@
                     <a:p>
                       <a:r>
                         <a:rPr sz="1300"/>
-                        <a:t>in-game the AI agent takes hazard damage &amp; has the same vision as the human - fair by construction</a:t>
+                        <a:t>In-game the AI agent takes hazard damage &amp; has the same vision as the human - fair by construction</a:t>
                       </a:r>
                     </a:p>
                   </a:txBody>
@@ -8799,7 +8799,7 @@
                     <a:p>
                       <a:r>
                         <a:rPr sz="1300"/>
-                        <a:t>goal selection is greedy nearest-first: no triage, no notion of who is most at risk</a:t>
+                        <a:t>Goal selection is greedy nearest-first: no triage, no notion of who is most at risk</a:t>
                       </a:r>
                     </a:p>
                   </a:txBody>
@@ -8827,7 +8827,7 @@
                     <a:p>
                       <a:r>
                         <a:rPr sz="1300"/>
-                        <a:t>the agent DRAWS its planned route + walked trail - you can see what it decided and why it changed</a:t>
+                        <a:t>The agent DRAWS its planned route + walked trail - you can see what it decided and why it changed</a:t>
                       </a:r>
                     </a:p>
                   </a:txBody>
@@ -8855,7 +8855,7 @@
                     <a:p>
                       <a:r>
                         <a:rPr sz="1300"/>
-                        <a:t>a real occupant-locator needs live location data on people - sensitive, must be minimised</a:t>
+                        <a:t>A real occupant-locator needs live location data on people - sensitive, must be minimised</a:t>
                       </a:r>
                     </a:p>
                   </a:txBody>
@@ -8883,7 +8883,7 @@
                     <a:p>
                       <a:r>
                         <a:rPr sz="1300"/>
-                        <a:t>the agent trusts its hazard map; a spoofed feed could steer it (and followers) into a hazard</a:t>
+                        <a:t>The agent trusts its hazard map; a spoofed feed could steer it (and followers) into a hazard</a:t>
                       </a:r>
                     </a:p>
                   </a:txBody>
@@ -8911,7 +8911,7 @@
                     <a:p>
                       <a:r>
                         <a:rPr sz="1300"/>
-                        <a:t>if it leads someone into a collapse - operator? developer? sensor vendor? needs an audit log</a:t>
+                        <a:t>If it leads someone into a collapse - operator? developer? sensor vendor? needs an audit log</a:t>
                       </a:r>
                     </a:p>
                   </a:txBody>
@@ -8939,7 +8939,7 @@
                     <a:p>
                       <a:r>
                         <a:rPr sz="1300"/>
-                        <a:t>it's decision-support, not an autonomous replacement for firefighters - the right posture</a:t>
+                        <a:t>It's decision-support, not an autonomous replacement for firefighters - the right posture</a:t>
                       </a:r>
                     </a:p>
                   </a:txBody>
@@ -9317,7 +9317,7 @@
                   <a:srgbClr val="C9D7E4"/>
                 </a:solidFill>
               </a:rPr>
-              <a:t>Compulsory slide — what worked, what didn't, how it was verified</a:t>
+              <a:t>Compulsory slide — What worked, what didn't, how it was verified</a:t>
             </a:r>
           </a:p>
         </p:txBody>
@@ -9374,7 +9374,7 @@
                   <a:srgbClr val="2B2B2B"/>
                 </a:solidFill>
               </a:rPr>
-              <a:t>side-view (left/right) walk clips, concept art, the whole implementation</a:t>
+              <a:t>Side-view (left/right) walk clips, concept art, the whole implementation</a:t>
             </a:r>
           </a:p>
           <a:p>
@@ -9408,7 +9408,7 @@
                   <a:srgbClr val="2B2B2B"/>
                 </a:solidFill>
               </a:rPr>
-              <a:t>no working “toward camera” or “away from camera” walk, across multiple re-prompts — that axis never worked</a:t>
+              <a:t>No working “toward camera” or “away from camera” walk, across multiple re-prompts — that axis never worked</a:t>
             </a:r>
           </a:p>
           <a:p>
@@ -9442,7 +9442,7 @@
                   <a:srgbClr val="2B2B2B"/>
                 </a:solidFill>
               </a:rPr>
-              <a:t>it treated “looks like a walk” as done; it never delivered a complete, 4-direction, production-ready set</a:t>
+              <a:t>It treated “looks like a walk” as done; it never delivered a complete, 4-direction, production-ready set</a:t>
             </a:r>
           </a:p>
           <a:p>
@@ -9476,7 +9476,7 @@
                   <a:srgbClr val="2B2B2B"/>
                 </a:solidFill>
               </a:rPr>
-              <a:t>checked against the engine's own requirements — 4 directions, fixed sprite size, feet-anchored — it met exactly one of four</a:t>
+              <a:t>Checked against the engine's own requirements — 4 directions, fixed sprite size, feet-anchored — it met exactly one of four</a:t>
             </a:r>
           </a:p>
           <a:p>
@@ -9510,7 +9510,7 @@
                   <a:srgbClr val="2B2B2B"/>
                 </a:solidFill>
               </a:rPr>
-              <a:t>assembled the 4-direction set from mixed sources (front/back from the character sheet, one side frame mirrored) + a procedural walk bob</a:t>
+              <a:t>Assembled the 4-direction set from mixed sources (front/back from the character sheet, one side frame mirrored) + a procedural walk bob</a:t>
             </a:r>
           </a:p>
           <a:p>

</xml_diff>

<commit_message>
Slides: center the AI-Assisted Exploration table's headers and cells
Co-Authored-By: Claude Sonnet 5 <noreply@anthropic.com>
</commit_message>
<xml_diff>
--- a/docs/report/CT3201_Slides.pptx
+++ b/docs/report/CT3201_Slides.pptx
@@ -5874,6 +5874,7 @@
                     <a:bodyPr/>
                     <a:lstStyle/>
                     <a:p>
+                      <a:pPr algn="ctr"/>
                       <a:r>
                         <a:rPr sz="1300" b="1">
                           <a:solidFill>
@@ -5884,7 +5885,7 @@
                       </a:r>
                     </a:p>
                   </a:txBody>
-                  <a:tcPr>
+                  <a:tcPr anchor="ctr">
                     <a:solidFill>
                       <a:srgbClr val="1F4E79"/>
                     </a:solidFill>
@@ -5895,6 +5896,7 @@
                     <a:bodyPr/>
                     <a:lstStyle/>
                     <a:p>
+                      <a:pPr algn="ctr"/>
                       <a:r>
                         <a:rPr sz="1300" b="1">
                           <a:solidFill>
@@ -5905,7 +5907,7 @@
                       </a:r>
                     </a:p>
                   </a:txBody>
-                  <a:tcPr>
+                  <a:tcPr anchor="ctr">
                     <a:solidFill>
                       <a:srgbClr val="1F4E79"/>
                     </a:solidFill>
@@ -5916,6 +5918,7 @@
                     <a:bodyPr/>
                     <a:lstStyle/>
                     <a:p>
+                      <a:pPr algn="ctr"/>
                       <a:r>
                         <a:rPr sz="1300" b="1">
                           <a:solidFill>
@@ -5926,7 +5929,7 @@
                       </a:r>
                     </a:p>
                   </a:txBody>
-                  <a:tcPr>
+                  <a:tcPr anchor="ctr">
                     <a:solidFill>
                       <a:srgbClr val="1F4E79"/>
                     </a:solidFill>
@@ -5939,39 +5942,42 @@
                     <a:bodyPr/>
                     <a:lstStyle/>
                     <a:p>
+                      <a:pPr algn="ctr"/>
                       <a:r>
                         <a:rPr sz="1300"/>
                         <a:t>Challenge BFS-with-fire-as-a-wall</a:t>
                       </a:r>
                     </a:p>
                   </a:txBody>
-                  <a:tcPr/>
+                  <a:tcPr anchor="ctr"/>
                 </a:tc>
                 <a:tc>
                   <a:txBody>
                     <a:bodyPr/>
                     <a:lstStyle/>
                     <a:p>
+                      <a:pPr algn="ctr"/>
                       <a:r>
                         <a:rPr sz="1300"/>
                         <a:t>BFS minimises tiles, not danger - it walks through fire to save a step</a:t>
                       </a:r>
                     </a:p>
                   </a:txBody>
-                  <a:tcPr/>
+                  <a:tcPr anchor="ctr"/>
                 </a:tc>
                 <a:tc>
                   <a:txBody>
                     <a:bodyPr/>
                     <a:lstStyle/>
                     <a:p>
+                      <a:pPr algn="ctr"/>
                       <a:r>
                         <a:rPr sz="1300"/>
                         <a:t>Treat hazards as weighted costs; use cost-aware search</a:t>
                       </a:r>
                     </a:p>
                   </a:txBody>
-                  <a:tcPr/>
+                  <a:tcPr anchor="ctr"/>
                 </a:tc>
               </a:tr>
               <a:tr h="365760">
@@ -5980,39 +5986,42 @@
                     <a:bodyPr/>
                     <a:lstStyle/>
                     <a:p>
+                      <a:pPr algn="ctr"/>
                       <a:r>
                         <a:rPr sz="1300"/>
                         <a:t>Suggest alternative search strategies</a:t>
                       </a:r>
                     </a:p>
                   </a:txBody>
-                  <a:tcPr/>
+                  <a:tcPr anchor="ctr"/>
                 </a:tc>
                 <a:tc>
                   <a:txBody>
                     <a:bodyPr/>
                     <a:lstStyle/>
                     <a:p>
+                      <a:pPr algn="ctr"/>
                       <a:r>
                         <a:rPr sz="1300"/>
                         <a:t>Dijkstra / A* / Greedy and their trade-offs</a:t>
                       </a:r>
                     </a:p>
                   </a:txBody>
-                  <a:tcPr/>
+                  <a:tcPr anchor="ctr"/>
                 </a:tc>
                 <a:tc>
                   <a:txBody>
                     <a:bodyPr/>
                     <a:lstStyle/>
                     <a:p>
+                      <a:pPr algn="ctr"/>
                       <a:r>
                         <a:rPr sz="1300"/>
                         <a:t>Implement all four to compare on our own map</a:t>
                       </a:r>
                     </a:p>
                   </a:txBody>
-                  <a:tcPr/>
+                  <a:tcPr anchor="ctr"/>
                 </a:tc>
               </a:tr>
               <a:tr h="365760">
@@ -6021,39 +6030,42 @@
                     <a:bodyPr/>
                     <a:lstStyle/>
                     <a:p>
+                      <a:pPr algn="ctr"/>
                       <a:r>
                         <a:rPr sz="1300"/>
                         <a:t>Point out assumptions</a:t>
                       </a:r>
                     </a:p>
                   </a:txBody>
-                  <a:tcPr/>
+                  <a:tcPr anchor="ctr"/>
                 </a:tc>
                 <a:tc>
                   <a:txBody>
                     <a:bodyPr/>
                     <a:lstStyle/>
                     <a:p>
+                      <a:pPr algn="ctr"/>
                       <a:r>
                         <a:rPr sz="1300"/>
                         <a:t>We assumed a full map of occupant locations</a:t>
                       </a:r>
                     </a:p>
                   </a:txBody>
-                  <a:tcPr/>
+                  <a:tcPr anchor="ctr"/>
                 </a:tc>
                 <a:tc>
                   <a:txBody>
                     <a:bodyPr/>
                     <a:lstStyle/>
                     <a:p>
+                      <a:pPr algn="ctr"/>
                       <a:r>
                         <a:rPr sz="1300"/>
                         <a:t>Add partial observability + frontier exploration</a:t>
                       </a:r>
                     </a:p>
                   </a:txBody>
-                  <a:tcPr/>
+                  <a:tcPr anchor="ctr"/>
                 </a:tc>
               </a:tr>
               <a:tr h="365760">
@@ -6062,39 +6074,42 @@
                     <a:bodyPr/>
                     <a:lstStyle/>
                     <a:p>
+                      <a:pPr algn="ctr"/>
                       <a:r>
                         <a:rPr sz="1300"/>
                         <a:t>What could make it fail?</a:t>
                       </a:r>
                     </a:p>
                   </a:txBody>
-                  <a:tcPr/>
+                  <a:tcPr anchor="ctr"/>
                 </a:tc>
                 <a:tc>
                   <a:txBody>
                     <a:bodyPr/>
                     <a:lstStyle/>
                     <a:p>
+                      <a:pPr algn="ctr"/>
                       <a:r>
                         <a:rPr sz="1300"/>
                         <a:t>Locked door on the only corridor; a collapse could trap someone</a:t>
                       </a:r>
                     </a:p>
                   </a:txBody>
-                  <a:tcPr/>
+                  <a:tcPr anchor="ctr"/>
                 </a:tc>
                 <a:tc>
                   <a:txBody>
                     <a:bodyPr/>
                     <a:lstStyle/>
                     <a:p>
+                      <a:pPr algn="ctr"/>
                       <a:r>
                         <a:rPr sz="1300"/>
                         <a:t>Key sub-goal; connectivity-checked collapse</a:t>
                       </a:r>
                     </a:p>
                   </a:txBody>
-                  <a:tcPr/>
+                  <a:tcPr anchor="ctr"/>
                 </a:tc>
               </a:tr>
             </a:tbl>

</xml_diff>

<commit_message>
Slides: center the AI Critique table's headers and cells
Same treatment as the AI-Assisted Exploration table.

Co-Authored-By: Claude Sonnet 5 <noreply@anthropic.com>
</commit_message>
<xml_diff>
--- a/docs/report/CT3201_Slides.pptx
+++ b/docs/report/CT3201_Slides.pptx
@@ -6460,6 +6460,7 @@
                     <a:bodyPr/>
                     <a:lstStyle/>
                     <a:p>
+                      <a:pPr algn="ctr"/>
                       <a:r>
                         <a:rPr sz="1300" b="1">
                           <a:solidFill>
@@ -6470,7 +6471,7 @@
                       </a:r>
                     </a:p>
                   </a:txBody>
-                  <a:tcPr>
+                  <a:tcPr anchor="ctr">
                     <a:solidFill>
                       <a:srgbClr val="1F4E79"/>
                     </a:solidFill>
@@ -6481,6 +6482,7 @@
                     <a:bodyPr/>
                     <a:lstStyle/>
                     <a:p>
+                      <a:pPr algn="ctr"/>
                       <a:r>
                         <a:rPr sz="1300" b="1">
                           <a:solidFill>
@@ -6491,7 +6493,7 @@
                       </a:r>
                     </a:p>
                   </a:txBody>
-                  <a:tcPr>
+                  <a:tcPr anchor="ctr">
                     <a:solidFill>
                       <a:srgbClr val="1F4E79"/>
                     </a:solidFill>
@@ -6502,6 +6504,7 @@
                     <a:bodyPr/>
                     <a:lstStyle/>
                     <a:p>
+                      <a:pPr algn="ctr"/>
                       <a:r>
                         <a:rPr sz="1300" b="1">
                           <a:solidFill>
@@ -6512,7 +6515,7 @@
                       </a:r>
                     </a:p>
                   </a:txBody>
-                  <a:tcPr>
+                  <a:tcPr anchor="ctr">
                     <a:solidFill>
                       <a:srgbClr val="1F4E79"/>
                     </a:solidFill>
@@ -6525,6 +6528,7 @@
                     <a:bodyPr/>
                     <a:lstStyle/>
                     <a:p>
+                      <a:pPr algn="ctr"/>
                       <a:r>
                         <a:rPr sz="1300" b="1">
                           <a:solidFill>
@@ -6535,7 +6539,7 @@
                       </a:r>
                     </a:p>
                   </a:txBody>
-                  <a:tcPr>
+                  <a:tcPr anchor="ctr">
                     <a:solidFill>
                       <a:srgbClr val="FBE7E4"/>
                     </a:solidFill>
@@ -6546,6 +6550,7 @@
                     <a:bodyPr/>
                     <a:lstStyle/>
                     <a:p>
+                      <a:pPr algn="ctr"/>
                       <a:r>
                         <a:rPr sz="1300" b="1">
                           <a:solidFill>
@@ -6556,7 +6561,7 @@
                       </a:r>
                     </a:p>
                   </a:txBody>
-                  <a:tcPr>
+                  <a:tcPr anchor="ctr">
                     <a:solidFill>
                       <a:srgbClr val="FBE7E4"/>
                     </a:solidFill>
@@ -6567,6 +6572,7 @@
                     <a:bodyPr/>
                     <a:lstStyle/>
                     <a:p>
+                      <a:pPr algn="ctr"/>
                       <a:r>
                         <a:rPr sz="1300" b="1">
                           <a:solidFill>
@@ -6577,7 +6583,7 @@
                       </a:r>
                     </a:p>
                   </a:txBody>
-                  <a:tcPr>
+                  <a:tcPr anchor="ctr">
                     <a:solidFill>
                       <a:srgbClr val="FBE7E4"/>
                     </a:solidFill>
@@ -6590,6 +6596,7 @@
                     <a:bodyPr/>
                     <a:lstStyle/>
                     <a:p>
+                      <a:pPr algn="ctr"/>
                       <a:r>
                         <a:rPr sz="1300" b="1">
                           <a:solidFill>
@@ -6600,7 +6607,7 @@
                       </a:r>
                     </a:p>
                   </a:txBody>
-                  <a:tcPr>
+                  <a:tcPr anchor="ctr">
                     <a:solidFill>
                       <a:srgbClr val="E4F3E8"/>
                     </a:solidFill>
@@ -6611,6 +6618,7 @@
                     <a:bodyPr/>
                     <a:lstStyle/>
                     <a:p>
+                      <a:pPr algn="ctr"/>
                       <a:r>
                         <a:rPr sz="1300" b="1">
                           <a:solidFill>
@@ -6621,7 +6629,7 @@
                       </a:r>
                     </a:p>
                   </a:txBody>
-                  <a:tcPr>
+                  <a:tcPr anchor="ctr">
                     <a:solidFill>
                       <a:srgbClr val="E4F3E8"/>
                     </a:solidFill>
@@ -6632,6 +6640,7 @@
                     <a:bodyPr/>
                     <a:lstStyle/>
                     <a:p>
+                      <a:pPr algn="ctr"/>
                       <a:r>
                         <a:rPr sz="1300" b="1">
                           <a:solidFill>
@@ -6642,7 +6651,7 @@
                       </a:r>
                     </a:p>
                   </a:txBody>
-                  <a:tcPr>
+                  <a:tcPr anchor="ctr">
                     <a:solidFill>
                       <a:srgbClr val="E4F3E8"/>
                     </a:solidFill>
@@ -6655,6 +6664,7 @@
                     <a:bodyPr/>
                     <a:lstStyle/>
                     <a:p>
+                      <a:pPr algn="ctr"/>
                       <a:r>
                         <a:rPr sz="1300" b="1">
                           <a:solidFill>
@@ -6665,7 +6675,7 @@
                       </a:r>
                     </a:p>
                   </a:txBody>
-                  <a:tcPr>
+                  <a:tcPr anchor="ctr">
                     <a:solidFill>
                       <a:srgbClr val="E4F3E8"/>
                     </a:solidFill>
@@ -6676,6 +6686,7 @@
                     <a:bodyPr/>
                     <a:lstStyle/>
                     <a:p>
+                      <a:pPr algn="ctr"/>
                       <a:r>
                         <a:rPr sz="1300" b="1">
                           <a:solidFill>
@@ -6686,7 +6697,7 @@
                       </a:r>
                     </a:p>
                   </a:txBody>
-                  <a:tcPr>
+                  <a:tcPr anchor="ctr">
                     <a:solidFill>
                       <a:srgbClr val="E4F3E8"/>
                     </a:solidFill>
@@ -6697,6 +6708,7 @@
                     <a:bodyPr/>
                     <a:lstStyle/>
                     <a:p>
+                      <a:pPr algn="ctr"/>
                       <a:r>
                         <a:rPr sz="1300" b="1">
                           <a:solidFill>
@@ -6707,7 +6719,7 @@
                       </a:r>
                     </a:p>
                   </a:txBody>
-                  <a:tcPr>
+                  <a:tcPr anchor="ctr">
                     <a:solidFill>
                       <a:srgbClr val="E4F3E8"/>
                     </a:solidFill>
@@ -6720,6 +6732,7 @@
                     <a:bodyPr/>
                     <a:lstStyle/>
                     <a:p>
+                      <a:pPr algn="ctr"/>
                       <a:r>
                         <a:rPr sz="1300" b="1">
                           <a:solidFill>
@@ -6730,7 +6743,7 @@
                       </a:r>
                     </a:p>
                   </a:txBody>
-                  <a:tcPr>
+                  <a:tcPr anchor="ctr">
                     <a:solidFill>
                       <a:srgbClr val="FBE7E4"/>
                     </a:solidFill>
@@ -6741,6 +6754,7 @@
                     <a:bodyPr/>
                     <a:lstStyle/>
                     <a:p>
+                      <a:pPr algn="ctr"/>
                       <a:r>
                         <a:rPr sz="1300" b="1">
                           <a:solidFill>
@@ -6751,7 +6765,7 @@
                       </a:r>
                     </a:p>
                   </a:txBody>
-                  <a:tcPr>
+                  <a:tcPr anchor="ctr">
                     <a:solidFill>
                       <a:srgbClr val="FBE7E4"/>
                     </a:solidFill>
@@ -6762,6 +6776,7 @@
                     <a:bodyPr/>
                     <a:lstStyle/>
                     <a:p>
+                      <a:pPr algn="ctr"/>
                       <a:r>
                         <a:rPr sz="1300" b="1">
                           <a:solidFill>
@@ -6772,7 +6787,7 @@
                       </a:r>
                     </a:p>
                   </a:txBody>
-                  <a:tcPr>
+                  <a:tcPr anchor="ctr">
                     <a:solidFill>
                       <a:srgbClr val="FBE7E4"/>
                     </a:solidFill>
@@ -6785,6 +6800,7 @@
                     <a:bodyPr/>
                     <a:lstStyle/>
                     <a:p>
+                      <a:pPr algn="ctr"/>
                       <a:r>
                         <a:rPr sz="1300" b="1">
                           <a:solidFill>
@@ -6795,7 +6811,7 @@
                       </a:r>
                     </a:p>
                   </a:txBody>
-                  <a:tcPr>
+                  <a:tcPr anchor="ctr">
                     <a:solidFill>
                       <a:srgbClr val="FAF1DF"/>
                     </a:solidFill>
@@ -6806,6 +6822,7 @@
                     <a:bodyPr/>
                     <a:lstStyle/>
                     <a:p>
+                      <a:pPr algn="ctr"/>
                       <a:r>
                         <a:rPr sz="1300" b="1">
                           <a:solidFill>
@@ -6816,7 +6833,7 @@
                       </a:r>
                     </a:p>
                   </a:txBody>
-                  <a:tcPr>
+                  <a:tcPr anchor="ctr">
                     <a:solidFill>
                       <a:srgbClr val="FAF1DF"/>
                     </a:solidFill>
@@ -6827,6 +6844,7 @@
                     <a:bodyPr/>
                     <a:lstStyle/>
                     <a:p>
+                      <a:pPr algn="ctr"/>
                       <a:r>
                         <a:rPr sz="1300" b="1">
                           <a:solidFill>
@@ -6837,7 +6855,7 @@
                       </a:r>
                     </a:p>
                   </a:txBody>
-                  <a:tcPr>
+                  <a:tcPr anchor="ctr">
                     <a:solidFill>
                       <a:srgbClr val="FAF1DF"/>
                     </a:solidFill>
@@ -6850,6 +6868,7 @@
                     <a:bodyPr/>
                     <a:lstStyle/>
                     <a:p>
+                      <a:pPr algn="ctr"/>
                       <a:r>
                         <a:rPr sz="1300" b="1">
                           <a:solidFill>
@@ -6860,7 +6879,7 @@
                       </a:r>
                     </a:p>
                   </a:txBody>
-                  <a:tcPr>
+                  <a:tcPr anchor="ctr">
                     <a:solidFill>
                       <a:srgbClr val="FBE7E4"/>
                     </a:solidFill>
@@ -6871,6 +6890,7 @@
                     <a:bodyPr/>
                     <a:lstStyle/>
                     <a:p>
+                      <a:pPr algn="ctr"/>
                       <a:r>
                         <a:rPr sz="1300" b="1">
                           <a:solidFill>
@@ -6881,7 +6901,7 @@
                       </a:r>
                     </a:p>
                   </a:txBody>
-                  <a:tcPr>
+                  <a:tcPr anchor="ctr">
                     <a:solidFill>
                       <a:srgbClr val="FBE7E4"/>
                     </a:solidFill>
@@ -6892,6 +6912,7 @@
                     <a:bodyPr/>
                     <a:lstStyle/>
                     <a:p>
+                      <a:pPr algn="ctr"/>
                       <a:r>
                         <a:rPr sz="1300" b="1">
                           <a:solidFill>
@@ -6902,7 +6923,7 @@
                       </a:r>
                     </a:p>
                   </a:txBody>
-                  <a:tcPr>
+                  <a:tcPr anchor="ctr">
                     <a:solidFill>
                       <a:srgbClr val="FBE7E4"/>
                     </a:solidFill>

</xml_diff>

<commit_message>
Slides: replace the dense contact sheet with two readable panels, center slide 7's table
- Slide 6: swapped the tiny 8-panel contact sheet for two cropped,
  enlarged panels (in-game HUD, results screen) with captions --
  readable in an actual presentation instead of only as repo evidence.
- Slide 7: centered the search-strategy table's headers and cells,
  same treatment as the other two decision tables.

Co-Authored-By: Claude Sonnet 5 <noreply@anthropic.com>
</commit_message>
<xml_diff>
--- a/docs/report/CT3201_Slides.pptx
+++ b/docs/report/CT3201_Slides.pptx
@@ -5,19 +5,19 @@
     <p:sldMasterId id="2147483648" r:id="rId1"/>
   </p:sldMasterIdLst>
   <p:sldIdLst>
-    <p:sldId id="256" r:id="rId7"/>
-    <p:sldId id="257" r:id="rId8"/>
-    <p:sldId id="258" r:id="rId9"/>
-    <p:sldId id="259" r:id="rId10"/>
-    <p:sldId id="260" r:id="rId11"/>
-    <p:sldId id="261" r:id="rId12"/>
-    <p:sldId id="262" r:id="rId13"/>
-    <p:sldId id="263" r:id="rId14"/>
-    <p:sldId id="266" r:id="rId17"/>
-    <p:sldId id="264" r:id="rId15"/>
-    <p:sldId id="265" r:id="rId16"/>
+    <p:sldId id="256" r:id="rId2"/>
+    <p:sldId id="257" r:id="rId3"/>
+    <p:sldId id="258" r:id="rId4"/>
+    <p:sldId id="259" r:id="rId5"/>
+    <p:sldId id="260" r:id="rId6"/>
+    <p:sldId id="261" r:id="rId7"/>
+    <p:sldId id="262" r:id="rId8"/>
+    <p:sldId id="263" r:id="rId9"/>
+    <p:sldId id="266" r:id="rId10"/>
+    <p:sldId id="264" r:id="rId11"/>
+    <p:sldId id="265" r:id="rId12"/>
   </p:sldIdLst>
-  <p:sldSz cx="12191695" cy="6858000" type="screen4x3"/>
+  <p:sldSz cx="12192000" cy="6858000"/>
   <p:notesSz cx="6858000" cy="9144000"/>
   <p:defaultTextStyle>
     <a:defPPr>
@@ -114,6 +114,22 @@
       </a:defRPr>
     </a:lvl9pPr>
   </p:defaultTextStyle>
+  <p:extLst>
+    <p:ext uri="{EFAFB233-063F-42B5-8137-9DF3F51BA10A}">
+      <p15:sldGuideLst xmlns:p15="http://schemas.microsoft.com/office/powerpoint/2012/main">
+        <p15:guide id="1" orient="horz" pos="2160">
+          <p15:clr>
+            <a:srgbClr val="A4A3A4"/>
+          </p15:clr>
+        </p15:guide>
+        <p15:guide id="2" pos="2880">
+          <p15:clr>
+            <a:srgbClr val="A4A3A4"/>
+          </p15:clr>
+        </p15:guide>
+      </p15:sldGuideLst>
+    </p:ext>
+  </p:extLst>
 </p:presentation>
 </file>
 
@@ -155,10 +171,9 @@
           <a:lstStyle/>
           <a:p>
             <a:r>
-              <a:rPr lang="en-US" smtClean="0"/>
+              <a:rPr lang="en-US"/>
               <a:t>Click to edit Master title style</a:t>
             </a:r>
-            <a:endParaRPr lang="en-US"/>
           </a:p>
         </p:txBody>
       </p:sp>
@@ -274,10 +289,9 @@
           </a:lstStyle>
           <a:p>
             <a:r>
-              <a:rPr lang="en-US" smtClean="0"/>
+              <a:rPr lang="en-US"/>
               <a:t>Click to edit Master subtitle style</a:t>
             </a:r>
-            <a:endParaRPr lang="en-US"/>
           </a:p>
         </p:txBody>
       </p:sp>
@@ -298,7 +312,7 @@
           <a:p>
             <a:fld id="{5BCAD085-E8A6-8845-BD4E-CB4CCA059FC4}" type="datetimeFigureOut">
               <a:rPr lang="en-US" smtClean="0"/>
-              <a:t>1/27/13</a:t>
+              <a:t>10/2/2026</a:t>
             </a:fld>
             <a:endParaRPr lang="en-US"/>
           </a:p>
@@ -392,10 +406,9 @@
           <a:lstStyle/>
           <a:p>
             <a:r>
-              <a:rPr lang="en-US" smtClean="0"/>
+              <a:rPr lang="en-US"/>
               <a:t>Click to edit Master title style</a:t>
             </a:r>
-            <a:endParaRPr lang="en-US"/>
           </a:p>
         </p:txBody>
       </p:sp>
@@ -416,38 +429,37 @@
           <a:p>
             <a:pPr lvl="0"/>
             <a:r>
-              <a:rPr lang="en-US" smtClean="0"/>
+              <a:rPr lang="en-US"/>
               <a:t>Click to edit Master text styles</a:t>
             </a:r>
           </a:p>
           <a:p>
             <a:pPr lvl="1"/>
             <a:r>
-              <a:rPr lang="en-US" smtClean="0"/>
+              <a:rPr lang="en-US"/>
               <a:t>Second level</a:t>
             </a:r>
           </a:p>
           <a:p>
             <a:pPr lvl="2"/>
             <a:r>
-              <a:rPr lang="en-US" smtClean="0"/>
+              <a:rPr lang="en-US"/>
               <a:t>Third level</a:t>
             </a:r>
           </a:p>
           <a:p>
             <a:pPr lvl="3"/>
             <a:r>
-              <a:rPr lang="en-US" smtClean="0"/>
+              <a:rPr lang="en-US"/>
               <a:t>Fourth level</a:t>
             </a:r>
           </a:p>
           <a:p>
             <a:pPr lvl="4"/>
             <a:r>
-              <a:rPr lang="en-US" smtClean="0"/>
+              <a:rPr lang="en-US"/>
               <a:t>Fifth level</a:t>
             </a:r>
-            <a:endParaRPr lang="en-US"/>
           </a:p>
         </p:txBody>
       </p:sp>
@@ -468,7 +480,7 @@
           <a:p>
             <a:fld id="{5BCAD085-E8A6-8845-BD4E-CB4CCA059FC4}" type="datetimeFigureOut">
               <a:rPr lang="en-US" smtClean="0"/>
-              <a:t>1/27/13</a:t>
+              <a:t>10/2/2026</a:t>
             </a:fld>
             <a:endParaRPr lang="en-US"/>
           </a:p>
@@ -567,10 +579,9 @@
           <a:lstStyle/>
           <a:p>
             <a:r>
-              <a:rPr lang="en-US" smtClean="0"/>
+              <a:rPr lang="en-US"/>
               <a:t>Click to edit Master title style</a:t>
             </a:r>
-            <a:endParaRPr lang="en-US"/>
           </a:p>
         </p:txBody>
       </p:sp>
@@ -596,38 +607,37 @@
           <a:p>
             <a:pPr lvl="0"/>
             <a:r>
-              <a:rPr lang="en-US" smtClean="0"/>
+              <a:rPr lang="en-US"/>
               <a:t>Click to edit Master text styles</a:t>
             </a:r>
           </a:p>
           <a:p>
             <a:pPr lvl="1"/>
             <a:r>
-              <a:rPr lang="en-US" smtClean="0"/>
+              <a:rPr lang="en-US"/>
               <a:t>Second level</a:t>
             </a:r>
           </a:p>
           <a:p>
             <a:pPr lvl="2"/>
             <a:r>
-              <a:rPr lang="en-US" smtClean="0"/>
+              <a:rPr lang="en-US"/>
               <a:t>Third level</a:t>
             </a:r>
           </a:p>
           <a:p>
             <a:pPr lvl="3"/>
             <a:r>
-              <a:rPr lang="en-US" smtClean="0"/>
+              <a:rPr lang="en-US"/>
               <a:t>Fourth level</a:t>
             </a:r>
           </a:p>
           <a:p>
             <a:pPr lvl="4"/>
             <a:r>
-              <a:rPr lang="en-US" smtClean="0"/>
+              <a:rPr lang="en-US"/>
               <a:t>Fifth level</a:t>
             </a:r>
-            <a:endParaRPr lang="en-US"/>
           </a:p>
         </p:txBody>
       </p:sp>
@@ -648,7 +658,7 @@
           <a:p>
             <a:fld id="{5BCAD085-E8A6-8845-BD4E-CB4CCA059FC4}" type="datetimeFigureOut">
               <a:rPr lang="en-US" smtClean="0"/>
-              <a:t>1/27/13</a:t>
+              <a:t>10/2/2026</a:t>
             </a:fld>
             <a:endParaRPr lang="en-US"/>
           </a:p>
@@ -742,10 +752,9 @@
           <a:lstStyle/>
           <a:p>
             <a:r>
-              <a:rPr lang="en-US" smtClean="0"/>
+              <a:rPr lang="en-US"/>
               <a:t>Click to edit Master title style</a:t>
             </a:r>
-            <a:endParaRPr lang="en-US"/>
           </a:p>
         </p:txBody>
       </p:sp>
@@ -766,38 +775,37 @@
           <a:p>
             <a:pPr lvl="0"/>
             <a:r>
-              <a:rPr lang="en-US" smtClean="0"/>
+              <a:rPr lang="en-US"/>
               <a:t>Click to edit Master text styles</a:t>
             </a:r>
           </a:p>
           <a:p>
             <a:pPr lvl="1"/>
             <a:r>
-              <a:rPr lang="en-US" smtClean="0"/>
+              <a:rPr lang="en-US"/>
               <a:t>Second level</a:t>
             </a:r>
           </a:p>
           <a:p>
             <a:pPr lvl="2"/>
             <a:r>
-              <a:rPr lang="en-US" smtClean="0"/>
+              <a:rPr lang="en-US"/>
               <a:t>Third level</a:t>
             </a:r>
           </a:p>
           <a:p>
             <a:pPr lvl="3"/>
             <a:r>
-              <a:rPr lang="en-US" smtClean="0"/>
+              <a:rPr lang="en-US"/>
               <a:t>Fourth level</a:t>
             </a:r>
           </a:p>
           <a:p>
             <a:pPr lvl="4"/>
             <a:r>
-              <a:rPr lang="en-US" smtClean="0"/>
+              <a:rPr lang="en-US"/>
               <a:t>Fifth level</a:t>
             </a:r>
-            <a:endParaRPr lang="en-US"/>
           </a:p>
         </p:txBody>
       </p:sp>
@@ -818,7 +826,7 @@
           <a:p>
             <a:fld id="{5BCAD085-E8A6-8845-BD4E-CB4CCA059FC4}" type="datetimeFigureOut">
               <a:rPr lang="en-US" smtClean="0"/>
-              <a:t>1/27/13</a:t>
+              <a:t>10/2/2026</a:t>
             </a:fld>
             <a:endParaRPr lang="en-US"/>
           </a:p>
@@ -921,10 +929,9 @@
           </a:lstStyle>
           <a:p>
             <a:r>
-              <a:rPr lang="en-US" smtClean="0"/>
+              <a:rPr lang="en-US"/>
               <a:t>Click to edit Master title style</a:t>
             </a:r>
-            <a:endParaRPr lang="en-US"/>
           </a:p>
         </p:txBody>
       </p:sp>
@@ -1041,7 +1048,7 @@
           <a:p>
             <a:pPr lvl="0"/>
             <a:r>
-              <a:rPr lang="en-US" smtClean="0"/>
+              <a:rPr lang="en-US"/>
               <a:t>Click to edit Master text styles</a:t>
             </a:r>
           </a:p>
@@ -1064,7 +1071,7 @@
           <a:p>
             <a:fld id="{5BCAD085-E8A6-8845-BD4E-CB4CCA059FC4}" type="datetimeFigureOut">
               <a:rPr lang="en-US" smtClean="0"/>
-              <a:t>1/27/13</a:t>
+              <a:t>10/2/2026</a:t>
             </a:fld>
             <a:endParaRPr lang="en-US"/>
           </a:p>
@@ -1158,10 +1165,9 @@
           <a:lstStyle/>
           <a:p>
             <a:r>
-              <a:rPr lang="en-US" smtClean="0"/>
+              <a:rPr lang="en-US"/>
               <a:t>Click to edit Master title style</a:t>
             </a:r>
-            <a:endParaRPr lang="en-US"/>
           </a:p>
         </p:txBody>
       </p:sp>
@@ -1215,38 +1221,37 @@
           <a:p>
             <a:pPr lvl="0"/>
             <a:r>
-              <a:rPr lang="en-US" smtClean="0"/>
+              <a:rPr lang="en-US"/>
               <a:t>Click to edit Master text styles</a:t>
             </a:r>
           </a:p>
           <a:p>
             <a:pPr lvl="1"/>
             <a:r>
-              <a:rPr lang="en-US" smtClean="0"/>
+              <a:rPr lang="en-US"/>
               <a:t>Second level</a:t>
             </a:r>
           </a:p>
           <a:p>
             <a:pPr lvl="2"/>
             <a:r>
-              <a:rPr lang="en-US" smtClean="0"/>
+              <a:rPr lang="en-US"/>
               <a:t>Third level</a:t>
             </a:r>
           </a:p>
           <a:p>
             <a:pPr lvl="3"/>
             <a:r>
-              <a:rPr lang="en-US" smtClean="0"/>
+              <a:rPr lang="en-US"/>
               <a:t>Fourth level</a:t>
             </a:r>
           </a:p>
           <a:p>
             <a:pPr lvl="4"/>
             <a:r>
-              <a:rPr lang="en-US" smtClean="0"/>
+              <a:rPr lang="en-US"/>
               <a:t>Fifth level</a:t>
             </a:r>
-            <a:endParaRPr lang="en-US"/>
           </a:p>
         </p:txBody>
       </p:sp>
@@ -1300,38 +1305,37 @@
           <a:p>
             <a:pPr lvl="0"/>
             <a:r>
-              <a:rPr lang="en-US" smtClean="0"/>
+              <a:rPr lang="en-US"/>
               <a:t>Click to edit Master text styles</a:t>
             </a:r>
           </a:p>
           <a:p>
             <a:pPr lvl="1"/>
             <a:r>
-              <a:rPr lang="en-US" smtClean="0"/>
+              <a:rPr lang="en-US"/>
               <a:t>Second level</a:t>
             </a:r>
           </a:p>
           <a:p>
             <a:pPr lvl="2"/>
             <a:r>
-              <a:rPr lang="en-US" smtClean="0"/>
+              <a:rPr lang="en-US"/>
               <a:t>Third level</a:t>
             </a:r>
           </a:p>
           <a:p>
             <a:pPr lvl="3"/>
             <a:r>
-              <a:rPr lang="en-US" smtClean="0"/>
+              <a:rPr lang="en-US"/>
               <a:t>Fourth level</a:t>
             </a:r>
           </a:p>
           <a:p>
             <a:pPr lvl="4"/>
             <a:r>
-              <a:rPr lang="en-US" smtClean="0"/>
+              <a:rPr lang="en-US"/>
               <a:t>Fifth level</a:t>
             </a:r>
-            <a:endParaRPr lang="en-US"/>
           </a:p>
         </p:txBody>
       </p:sp>
@@ -1352,7 +1356,7 @@
           <a:p>
             <a:fld id="{5BCAD085-E8A6-8845-BD4E-CB4CCA059FC4}" type="datetimeFigureOut">
               <a:rPr lang="en-US" smtClean="0"/>
-              <a:t>1/27/13</a:t>
+              <a:t>10/2/2026</a:t>
             </a:fld>
             <a:endParaRPr lang="en-US"/>
           </a:p>
@@ -1450,10 +1454,9 @@
           </a:lstStyle>
           <a:p>
             <a:r>
-              <a:rPr lang="en-US" smtClean="0"/>
+              <a:rPr lang="en-US"/>
               <a:t>Click to edit Master title style</a:t>
             </a:r>
-            <a:endParaRPr lang="en-US"/>
           </a:p>
         </p:txBody>
       </p:sp>
@@ -1516,7 +1519,7 @@
           <a:p>
             <a:pPr lvl="0"/>
             <a:r>
-              <a:rPr lang="en-US" smtClean="0"/>
+              <a:rPr lang="en-US"/>
               <a:t>Click to edit Master text styles</a:t>
             </a:r>
           </a:p>
@@ -1572,38 +1575,37 @@
           <a:p>
             <a:pPr lvl="0"/>
             <a:r>
-              <a:rPr lang="en-US" smtClean="0"/>
+              <a:rPr lang="en-US"/>
               <a:t>Click to edit Master text styles</a:t>
             </a:r>
           </a:p>
           <a:p>
             <a:pPr lvl="1"/>
             <a:r>
-              <a:rPr lang="en-US" smtClean="0"/>
+              <a:rPr lang="en-US"/>
               <a:t>Second level</a:t>
             </a:r>
           </a:p>
           <a:p>
             <a:pPr lvl="2"/>
             <a:r>
-              <a:rPr lang="en-US" smtClean="0"/>
+              <a:rPr lang="en-US"/>
               <a:t>Third level</a:t>
             </a:r>
           </a:p>
           <a:p>
             <a:pPr lvl="3"/>
             <a:r>
-              <a:rPr lang="en-US" smtClean="0"/>
+              <a:rPr lang="en-US"/>
               <a:t>Fourth level</a:t>
             </a:r>
           </a:p>
           <a:p>
             <a:pPr lvl="4"/>
             <a:r>
-              <a:rPr lang="en-US" smtClean="0"/>
+              <a:rPr lang="en-US"/>
               <a:t>Fifth level</a:t>
             </a:r>
-            <a:endParaRPr lang="en-US"/>
           </a:p>
         </p:txBody>
       </p:sp>
@@ -1666,7 +1668,7 @@
           <a:p>
             <a:pPr lvl="0"/>
             <a:r>
-              <a:rPr lang="en-US" smtClean="0"/>
+              <a:rPr lang="en-US"/>
               <a:t>Click to edit Master text styles</a:t>
             </a:r>
           </a:p>
@@ -1722,38 +1724,37 @@
           <a:p>
             <a:pPr lvl="0"/>
             <a:r>
-              <a:rPr lang="en-US" smtClean="0"/>
+              <a:rPr lang="en-US"/>
               <a:t>Click to edit Master text styles</a:t>
             </a:r>
           </a:p>
           <a:p>
             <a:pPr lvl="1"/>
             <a:r>
-              <a:rPr lang="en-US" smtClean="0"/>
+              <a:rPr lang="en-US"/>
               <a:t>Second level</a:t>
             </a:r>
           </a:p>
           <a:p>
             <a:pPr lvl="2"/>
             <a:r>
-              <a:rPr lang="en-US" smtClean="0"/>
+              <a:rPr lang="en-US"/>
               <a:t>Third level</a:t>
             </a:r>
           </a:p>
           <a:p>
             <a:pPr lvl="3"/>
             <a:r>
-              <a:rPr lang="en-US" smtClean="0"/>
+              <a:rPr lang="en-US"/>
               <a:t>Fourth level</a:t>
             </a:r>
           </a:p>
           <a:p>
             <a:pPr lvl="4"/>
             <a:r>
-              <a:rPr lang="en-US" smtClean="0"/>
+              <a:rPr lang="en-US"/>
               <a:t>Fifth level</a:t>
             </a:r>
-            <a:endParaRPr lang="en-US"/>
           </a:p>
         </p:txBody>
       </p:sp>
@@ -1774,7 +1775,7 @@
           <a:p>
             <a:fld id="{5BCAD085-E8A6-8845-BD4E-CB4CCA059FC4}" type="datetimeFigureOut">
               <a:rPr lang="en-US" smtClean="0"/>
-              <a:t>1/27/13</a:t>
+              <a:t>10/2/2026</a:t>
             </a:fld>
             <a:endParaRPr lang="en-US"/>
           </a:p>
@@ -1868,10 +1869,9 @@
           <a:lstStyle/>
           <a:p>
             <a:r>
-              <a:rPr lang="en-US" smtClean="0"/>
+              <a:rPr lang="en-US"/>
               <a:t>Click to edit Master title style</a:t>
             </a:r>
-            <a:endParaRPr lang="en-US"/>
           </a:p>
         </p:txBody>
       </p:sp>
@@ -1892,7 +1892,7 @@
           <a:p>
             <a:fld id="{5BCAD085-E8A6-8845-BD4E-CB4CCA059FC4}" type="datetimeFigureOut">
               <a:rPr lang="en-US" smtClean="0"/>
-              <a:t>1/27/13</a:t>
+              <a:t>10/2/2026</a:t>
             </a:fld>
             <a:endParaRPr lang="en-US"/>
           </a:p>
@@ -1987,7 +1987,7 @@
           <a:p>
             <a:fld id="{5BCAD085-E8A6-8845-BD4E-CB4CCA059FC4}" type="datetimeFigureOut">
               <a:rPr lang="en-US" smtClean="0"/>
-              <a:t>1/27/13</a:t>
+              <a:t>10/2/2026</a:t>
             </a:fld>
             <a:endParaRPr lang="en-US"/>
           </a:p>
@@ -2090,10 +2090,9 @@
           </a:lstStyle>
           <a:p>
             <a:r>
-              <a:rPr lang="en-US" smtClean="0"/>
+              <a:rPr lang="en-US"/>
               <a:t>Click to edit Master title style</a:t>
             </a:r>
-            <a:endParaRPr lang="en-US"/>
           </a:p>
         </p:txBody>
       </p:sp>
@@ -2147,38 +2146,37 @@
           <a:p>
             <a:pPr lvl="0"/>
             <a:r>
-              <a:rPr lang="en-US" smtClean="0"/>
+              <a:rPr lang="en-US"/>
               <a:t>Click to edit Master text styles</a:t>
             </a:r>
           </a:p>
           <a:p>
             <a:pPr lvl="1"/>
             <a:r>
-              <a:rPr lang="en-US" smtClean="0"/>
+              <a:rPr lang="en-US"/>
               <a:t>Second level</a:t>
             </a:r>
           </a:p>
           <a:p>
             <a:pPr lvl="2"/>
             <a:r>
-              <a:rPr lang="en-US" smtClean="0"/>
+              <a:rPr lang="en-US"/>
               <a:t>Third level</a:t>
             </a:r>
           </a:p>
           <a:p>
             <a:pPr lvl="3"/>
             <a:r>
-              <a:rPr lang="en-US" smtClean="0"/>
+              <a:rPr lang="en-US"/>
               <a:t>Fourth level</a:t>
             </a:r>
           </a:p>
           <a:p>
             <a:pPr lvl="4"/>
             <a:r>
-              <a:rPr lang="en-US" smtClean="0"/>
+              <a:rPr lang="en-US"/>
               <a:t>Fifth level</a:t>
             </a:r>
-            <a:endParaRPr lang="en-US"/>
           </a:p>
         </p:txBody>
       </p:sp>
@@ -2241,7 +2239,7 @@
           <a:p>
             <a:pPr lvl="0"/>
             <a:r>
-              <a:rPr lang="en-US" smtClean="0"/>
+              <a:rPr lang="en-US"/>
               <a:t>Click to edit Master text styles</a:t>
             </a:r>
           </a:p>
@@ -2264,7 +2262,7 @@
           <a:p>
             <a:fld id="{5BCAD085-E8A6-8845-BD4E-CB4CCA059FC4}" type="datetimeFigureOut">
               <a:rPr lang="en-US" smtClean="0"/>
-              <a:t>1/27/13</a:t>
+              <a:t>10/2/2026</a:t>
             </a:fld>
             <a:endParaRPr lang="en-US"/>
           </a:p>
@@ -2367,10 +2365,9 @@
           </a:lstStyle>
           <a:p>
             <a:r>
-              <a:rPr lang="en-US" smtClean="0"/>
+              <a:rPr lang="en-US"/>
               <a:t>Click to edit Master title style</a:t>
             </a:r>
-            <a:endParaRPr lang="en-US"/>
           </a:p>
         </p:txBody>
       </p:sp>
@@ -2494,7 +2491,7 @@
           <a:p>
             <a:pPr lvl="0"/>
             <a:r>
-              <a:rPr lang="en-US" smtClean="0"/>
+              <a:rPr lang="en-US"/>
               <a:t>Click to edit Master text styles</a:t>
             </a:r>
           </a:p>
@@ -2517,7 +2514,7 @@
           <a:p>
             <a:fld id="{5BCAD085-E8A6-8845-BD4E-CB4CCA059FC4}" type="datetimeFigureOut">
               <a:rPr lang="en-US" smtClean="0"/>
-              <a:t>1/27/13</a:t>
+              <a:t>10/2/2026</a:t>
             </a:fld>
             <a:endParaRPr lang="en-US"/>
           </a:p>
@@ -2626,10 +2623,9 @@
           <a:lstStyle/>
           <a:p>
             <a:r>
-              <a:rPr lang="en-US" smtClean="0"/>
+              <a:rPr lang="en-US"/>
               <a:t>Click to edit Master title style</a:t>
             </a:r>
-            <a:endParaRPr lang="en-US"/>
           </a:p>
         </p:txBody>
       </p:sp>
@@ -2660,38 +2656,37 @@
           <a:p>
             <a:pPr lvl="0"/>
             <a:r>
-              <a:rPr lang="en-US" smtClean="0"/>
+              <a:rPr lang="en-US"/>
               <a:t>Click to edit Master text styles</a:t>
             </a:r>
           </a:p>
           <a:p>
             <a:pPr lvl="1"/>
             <a:r>
-              <a:rPr lang="en-US" smtClean="0"/>
+              <a:rPr lang="en-US"/>
               <a:t>Second level</a:t>
             </a:r>
           </a:p>
           <a:p>
             <a:pPr lvl="2"/>
             <a:r>
-              <a:rPr lang="en-US" smtClean="0"/>
+              <a:rPr lang="en-US"/>
               <a:t>Third level</a:t>
             </a:r>
           </a:p>
           <a:p>
             <a:pPr lvl="3"/>
             <a:r>
-              <a:rPr lang="en-US" smtClean="0"/>
+              <a:rPr lang="en-US"/>
               <a:t>Fourth level</a:t>
             </a:r>
           </a:p>
           <a:p>
             <a:pPr lvl="4"/>
             <a:r>
-              <a:rPr lang="en-US" smtClean="0"/>
+              <a:rPr lang="en-US"/>
               <a:t>Fifth level</a:t>
             </a:r>
-            <a:endParaRPr lang="en-US"/>
           </a:p>
         </p:txBody>
       </p:sp>
@@ -2730,7 +2725,7 @@
           <a:p>
             <a:fld id="{5BCAD085-E8A6-8845-BD4E-CB4CCA059FC4}" type="datetimeFigureOut">
               <a:rPr lang="en-US" smtClean="0"/>
-              <a:t>1/27/13</a:t>
+              <a:t>10/2/2026</a:t>
             </a:fld>
             <a:endParaRPr lang="en-US"/>
           </a:p>
@@ -3089,7 +3084,7 @@
 </file>
 
 <file path=ppt/slides/slide1.xml><?xml version="1.0" encoding="utf-8"?>
-<p:sld xmlns:a="http://schemas.openxmlformats.org/drawingml/2006/main" xmlns:p="http://schemas.openxmlformats.org/presentationml/2006/main" xmlns:r="http://schemas.openxmlformats.org/officeDocument/2006/relationships">
+<p:sld xmlns:a="http://schemas.openxmlformats.org/drawingml/2006/main" xmlns:r="http://schemas.openxmlformats.org/officeDocument/2006/relationships" xmlns:p="http://schemas.openxmlformats.org/presentationml/2006/main">
   <p:cSld>
     <p:spTree>
       <p:nvGrpSpPr>
@@ -3097,7 +3092,14 @@
         <p:cNvGrpSpPr/>
         <p:nvPr/>
       </p:nvGrpSpPr>
-      <p:grpSpPr/>
+      <p:grpSpPr>
+        <a:xfrm>
+          <a:off x="0" y="0"/>
+          <a:ext cx="0" cy="0"/>
+          <a:chOff x="0" y="0"/>
+          <a:chExt cx="0" cy="0"/>
+        </a:xfrm>
+      </p:grpSpPr>
       <p:sp>
         <p:nvSpPr>
           <p:cNvPr id="4" name="Rectangle 3"/>
@@ -3139,6 +3141,7 @@
           <a:lstStyle/>
           <a:p>
             <a:pPr algn="ctr"/>
+            <a:endParaRPr/>
           </a:p>
         </p:txBody>
       </p:sp>
@@ -3216,7 +3219,7 @@
               </a:spcAft>
             </a:pPr>
             <a:r>
-              <a:rPr b="1" sz="1600">
+              <a:rPr sz="1600" b="1">
                 <a:solidFill>
                   <a:srgbClr val="C8820E"/>
                 </a:solidFill>
@@ -3224,7 +3227,7 @@
               <a:t>▸  </a:t>
             </a:r>
             <a:r>
-              <a:rPr b="1" sz="1600">
+              <a:rPr sz="1600" b="1">
                 <a:solidFill>
                   <a:srgbClr val="1F4E79"/>
                 </a:solidFill>
@@ -3250,7 +3253,7 @@
               </a:spcAft>
             </a:pPr>
             <a:r>
-              <a:rPr b="1" sz="1600">
+              <a:rPr sz="1600" b="1">
                 <a:solidFill>
                   <a:srgbClr val="C8820E"/>
                 </a:solidFill>
@@ -3258,7 +3261,7 @@
               <a:t>▸  </a:t>
             </a:r>
             <a:r>
-              <a:rPr b="1" sz="1600">
+              <a:rPr sz="1600" b="1">
                 <a:solidFill>
                   <a:srgbClr val="1F4E79"/>
                 </a:solidFill>
@@ -3284,7 +3287,7 @@
               </a:spcAft>
             </a:pPr>
             <a:r>
-              <a:rPr b="1" sz="1600">
+              <a:rPr sz="1600" b="1">
                 <a:solidFill>
                   <a:srgbClr val="C8820E"/>
                 </a:solidFill>
@@ -3343,6 +3346,7 @@
           <a:lstStyle/>
           <a:p>
             <a:pPr algn="ctr"/>
+            <a:endParaRPr/>
           </a:p>
         </p:txBody>
       </p:sp>
@@ -3387,6 +3391,7 @@
           <a:lstStyle/>
           <a:p>
             <a:pPr algn="ctr"/>
+            <a:endParaRPr/>
           </a:p>
         </p:txBody>
       </p:sp>
@@ -3466,7 +3471,7 @@
 </file>
 
 <file path=ppt/slides/slide10.xml><?xml version="1.0" encoding="utf-8"?>
-<p:sld xmlns:a="http://schemas.openxmlformats.org/drawingml/2006/main" xmlns:p="http://schemas.openxmlformats.org/presentationml/2006/main" xmlns:r="http://schemas.openxmlformats.org/officeDocument/2006/relationships">
+<p:sld xmlns:a="http://schemas.openxmlformats.org/drawingml/2006/main" xmlns:r="http://schemas.openxmlformats.org/officeDocument/2006/relationships" xmlns:p="http://schemas.openxmlformats.org/presentationml/2006/main">
   <p:cSld>
     <p:spTree>
       <p:nvGrpSpPr>
@@ -3474,7 +3479,14 @@
         <p:cNvGrpSpPr/>
         <p:nvPr/>
       </p:nvGrpSpPr>
-      <p:grpSpPr/>
+      <p:grpSpPr>
+        <a:xfrm>
+          <a:off x="0" y="0"/>
+          <a:ext cx="0" cy="0"/>
+          <a:chOff x="0" y="0"/>
+          <a:chExt cx="0" cy="0"/>
+        </a:xfrm>
+      </p:grpSpPr>
       <p:sp>
         <p:nvSpPr>
           <p:cNvPr id="4" name="Rectangle 3"/>
@@ -3516,6 +3528,7 @@
           <a:lstStyle/>
           <a:p>
             <a:pPr algn="ctr"/>
+            <a:endParaRPr/>
           </a:p>
         </p:txBody>
       </p:sp>
@@ -3593,7 +3606,7 @@
               </a:spcAft>
             </a:pPr>
             <a:r>
-              <a:rPr b="1" sz="1300">
+              <a:rPr sz="1300" b="1">
                 <a:solidFill>
                   <a:srgbClr val="C8820E"/>
                 </a:solidFill>
@@ -3601,7 +3614,7 @@
               <a:t>▸  </a:t>
             </a:r>
             <a:r>
-              <a:rPr b="1" sz="1300">
+              <a:rPr sz="1300" b="1">
                 <a:solidFill>
                   <a:srgbClr val="1F4E79"/>
                 </a:solidFill>
@@ -3627,7 +3640,7 @@
               </a:spcAft>
             </a:pPr>
             <a:r>
-              <a:rPr b="1" sz="1300">
+              <a:rPr sz="1300" b="1">
                 <a:solidFill>
                   <a:srgbClr val="C8820E"/>
                 </a:solidFill>
@@ -3635,7 +3648,7 @@
               <a:t>▸  </a:t>
             </a:r>
             <a:r>
-              <a:rPr b="1" sz="1300">
+              <a:rPr sz="1300" b="1">
                 <a:solidFill>
                   <a:srgbClr val="1F4E79"/>
                 </a:solidFill>
@@ -3661,7 +3674,7 @@
               </a:spcAft>
             </a:pPr>
             <a:r>
-              <a:rPr b="1" sz="1300">
+              <a:rPr sz="1300" b="1">
                 <a:solidFill>
                   <a:srgbClr val="C8820E"/>
                 </a:solidFill>
@@ -3669,7 +3682,7 @@
               <a:t>▸  </a:t>
             </a:r>
             <a:r>
-              <a:rPr b="1" sz="1300">
+              <a:rPr sz="1300" b="1">
                 <a:solidFill>
                   <a:srgbClr val="1F4E79"/>
                 </a:solidFill>
@@ -3695,7 +3708,7 @@
               </a:spcAft>
             </a:pPr>
             <a:r>
-              <a:rPr b="1" sz="1300">
+              <a:rPr sz="1300" b="1">
                 <a:solidFill>
                   <a:srgbClr val="C8820E"/>
                 </a:solidFill>
@@ -3703,7 +3716,7 @@
               <a:t>▸  </a:t>
             </a:r>
             <a:r>
-              <a:rPr b="1" sz="1300">
+              <a:rPr sz="1300" b="1">
                 <a:solidFill>
                   <a:srgbClr val="1F4E79"/>
                 </a:solidFill>
@@ -3729,7 +3742,7 @@
               </a:spcAft>
             </a:pPr>
             <a:r>
-              <a:rPr b="1" sz="1300">
+              <a:rPr sz="1300" b="1">
                 <a:solidFill>
                   <a:srgbClr val="C8820E"/>
                 </a:solidFill>
@@ -3737,7 +3750,7 @@
               <a:t>▸  </a:t>
             </a:r>
             <a:r>
-              <a:rPr b="1" sz="1300">
+              <a:rPr sz="1300" b="1">
                 <a:solidFill>
                   <a:srgbClr val="1F4E79"/>
                 </a:solidFill>
@@ -3763,7 +3776,7 @@
               </a:spcAft>
             </a:pPr>
             <a:r>
-              <a:rPr b="1" sz="1300">
+              <a:rPr sz="1300" b="1">
                 <a:solidFill>
                   <a:srgbClr val="C8820E"/>
                 </a:solidFill>
@@ -3771,7 +3784,7 @@
               <a:t>▸  </a:t>
             </a:r>
             <a:r>
-              <a:rPr b="1" sz="1300">
+              <a:rPr sz="1300" b="1">
                 <a:solidFill>
                   <a:srgbClr val="1F4E79"/>
                 </a:solidFill>
@@ -3797,7 +3810,7 @@
               </a:spcAft>
             </a:pPr>
             <a:r>
-              <a:rPr b="1" sz="1300">
+              <a:rPr sz="1300" b="1">
                 <a:solidFill>
                   <a:srgbClr val="C8820E"/>
                 </a:solidFill>
@@ -3805,7 +3818,7 @@
               <a:t>▸  </a:t>
             </a:r>
             <a:r>
-              <a:rPr b="1" sz="1300">
+              <a:rPr sz="1300" b="1">
                 <a:solidFill>
                   <a:srgbClr val="1F4E79"/>
                 </a:solidFill>
@@ -3831,7 +3844,7 @@
               </a:spcAft>
             </a:pPr>
             <a:r>
-              <a:rPr b="1" sz="1300">
+              <a:rPr sz="1300" b="1">
                 <a:solidFill>
                   <a:srgbClr val="C8820E"/>
                 </a:solidFill>
@@ -3839,7 +3852,7 @@
               <a:t>▸  </a:t>
             </a:r>
             <a:r>
-              <a:rPr b="1" sz="1300">
+              <a:rPr sz="1300" b="1">
                 <a:solidFill>
                   <a:srgbClr val="1F4E79"/>
                 </a:solidFill>
@@ -3898,6 +3911,7 @@
           <a:lstStyle/>
           <a:p>
             <a:pPr algn="ctr"/>
+            <a:endParaRPr/>
           </a:p>
         </p:txBody>
       </p:sp>
@@ -3940,7 +3954,7 @@
           </a:fontRef>
         </p:style>
         <p:txBody>
-          <a:bodyPr rtlCol="0" anchor="ctr" wrap="none" lIns="0" rIns="0" tIns="0" bIns="0"/>
+          <a:bodyPr wrap="none" lIns="0" tIns="0" rIns="0" bIns="0" rtlCol="0" anchor="ctr"/>
           <a:lstStyle/>
           <a:p>
             <a:pPr algn="ctr"/>
@@ -3997,6 +4011,7 @@
           <a:lstStyle/>
           <a:p>
             <a:pPr algn="ctr"/>
+            <a:endParaRPr/>
           </a:p>
         </p:txBody>
       </p:sp>
@@ -4076,7 +4091,7 @@
 </file>
 
 <file path=ppt/slides/slide11.xml><?xml version="1.0" encoding="utf-8"?>
-<p:sld xmlns:a="http://schemas.openxmlformats.org/drawingml/2006/main" xmlns:p="http://schemas.openxmlformats.org/presentationml/2006/main" xmlns:r="http://schemas.openxmlformats.org/officeDocument/2006/relationships">
+<p:sld xmlns:a="http://schemas.openxmlformats.org/drawingml/2006/main" xmlns:r="http://schemas.openxmlformats.org/officeDocument/2006/relationships" xmlns:p="http://schemas.openxmlformats.org/presentationml/2006/main">
   <p:cSld>
     <p:spTree>
       <p:nvGrpSpPr>
@@ -4084,7 +4099,14 @@
         <p:cNvGrpSpPr/>
         <p:nvPr/>
       </p:nvGrpSpPr>
-      <p:grpSpPr/>
+      <p:grpSpPr>
+        <a:xfrm>
+          <a:off x="0" y="0"/>
+          <a:ext cx="0" cy="0"/>
+          <a:chOff x="0" y="0"/>
+          <a:chExt cx="0" cy="0"/>
+        </a:xfrm>
+      </p:grpSpPr>
       <p:sp>
         <p:nvSpPr>
           <p:cNvPr id="4" name="Rectangle 3"/>
@@ -4126,6 +4148,7 @@
           <a:lstStyle/>
           <a:p>
             <a:pPr algn="ctr"/>
+            <a:endParaRPr/>
           </a:p>
         </p:txBody>
       </p:sp>
@@ -4193,7 +4216,7 @@
               </a:spcAft>
             </a:pPr>
             <a:r>
-              <a:rPr b="1" sz="1600">
+              <a:rPr sz="1600" b="1">
                 <a:solidFill>
                   <a:srgbClr val="C8820E"/>
                 </a:solidFill>
@@ -4219,7 +4242,7 @@
               </a:spcAft>
             </a:pPr>
             <a:r>
-              <a:rPr b="1" sz="1600">
+              <a:rPr sz="1600" b="1">
                 <a:solidFill>
                   <a:srgbClr val="C8820E"/>
                 </a:solidFill>
@@ -4245,7 +4268,7 @@
               </a:spcAft>
             </a:pPr>
             <a:r>
-              <a:rPr b="1" sz="1600">
+              <a:rPr sz="1600" b="1">
                 <a:solidFill>
                   <a:srgbClr val="C8820E"/>
                 </a:solidFill>
@@ -4271,7 +4294,7 @@
               </a:spcAft>
             </a:pPr>
             <a:r>
-              <a:rPr b="1" sz="1600">
+              <a:rPr sz="1600" b="1">
                 <a:solidFill>
                   <a:srgbClr val="C8820E"/>
                 </a:solidFill>
@@ -4297,7 +4320,7 @@
               </a:spcAft>
             </a:pPr>
             <a:r>
-              <a:rPr b="1" sz="1600">
+              <a:rPr sz="1600" b="1">
                 <a:solidFill>
                   <a:srgbClr val="C8820E"/>
                 </a:solidFill>
@@ -4323,7 +4346,7 @@
               </a:spcAft>
             </a:pPr>
             <a:r>
-              <a:rPr b="1" sz="1600">
+              <a:rPr sz="1600" b="1">
                 <a:solidFill>
                   <a:srgbClr val="C8820E"/>
                 </a:solidFill>
@@ -4382,6 +4405,7 @@
           <a:lstStyle/>
           <a:p>
             <a:pPr algn="ctr"/>
+            <a:endParaRPr/>
           </a:p>
         </p:txBody>
       </p:sp>
@@ -4424,7 +4448,7 @@
           </a:fontRef>
         </p:style>
         <p:txBody>
-          <a:bodyPr rtlCol="0" anchor="ctr" wrap="none" lIns="0" rIns="0" tIns="0" bIns="0"/>
+          <a:bodyPr wrap="none" lIns="0" tIns="0" rIns="0" bIns="0" rtlCol="0" anchor="ctr"/>
           <a:lstStyle/>
           <a:p>
             <a:pPr algn="ctr"/>
@@ -4481,6 +4505,7 @@
           <a:lstStyle/>
           <a:p>
             <a:pPr algn="ctr"/>
+            <a:endParaRPr/>
           </a:p>
         </p:txBody>
       </p:sp>
@@ -4560,7 +4585,7 @@
 </file>
 
 <file path=ppt/slides/slide2.xml><?xml version="1.0" encoding="utf-8"?>
-<p:sld xmlns:a="http://schemas.openxmlformats.org/drawingml/2006/main" xmlns:p="http://schemas.openxmlformats.org/presentationml/2006/main" xmlns:r="http://schemas.openxmlformats.org/officeDocument/2006/relationships">
+<p:sld xmlns:a="http://schemas.openxmlformats.org/drawingml/2006/main" xmlns:r="http://schemas.openxmlformats.org/officeDocument/2006/relationships" xmlns:p="http://schemas.openxmlformats.org/presentationml/2006/main">
   <p:cSld>
     <p:spTree>
       <p:nvGrpSpPr>
@@ -4568,7 +4593,14 @@
         <p:cNvGrpSpPr/>
         <p:nvPr/>
       </p:nvGrpSpPr>
-      <p:grpSpPr/>
+      <p:grpSpPr>
+        <a:xfrm>
+          <a:off x="0" y="0"/>
+          <a:ext cx="0" cy="0"/>
+          <a:chOff x="0" y="0"/>
+          <a:chExt cx="0" cy="0"/>
+        </a:xfrm>
+      </p:grpSpPr>
       <p:sp>
         <p:nvSpPr>
           <p:cNvPr id="4" name="Rectangle 3"/>
@@ -4610,6 +4642,7 @@
           <a:lstStyle/>
           <a:p>
             <a:pPr algn="ctr"/>
+            <a:endParaRPr/>
           </a:p>
         </p:txBody>
       </p:sp>
@@ -4687,7 +4720,7 @@
               </a:spcAft>
             </a:pPr>
             <a:r>
-              <a:rPr b="1" sz="1600">
+              <a:rPr sz="1600" b="1">
                 <a:solidFill>
                   <a:srgbClr val="C8820E"/>
                 </a:solidFill>
@@ -4695,7 +4728,7 @@
               <a:t>▸  </a:t>
             </a:r>
             <a:r>
-              <a:rPr b="1" sz="1600">
+              <a:rPr sz="1600" b="1">
                 <a:solidFill>
                   <a:srgbClr val="1F4E79"/>
                 </a:solidFill>
@@ -4721,7 +4754,7 @@
               </a:spcAft>
             </a:pPr>
             <a:r>
-              <a:rPr b="1" sz="1600">
+              <a:rPr sz="1600" b="1">
                 <a:solidFill>
                   <a:srgbClr val="C8820E"/>
                 </a:solidFill>
@@ -4729,7 +4762,7 @@
               <a:t>▸  </a:t>
             </a:r>
             <a:r>
-              <a:rPr b="1" sz="1600">
+              <a:rPr sz="1600" b="1">
                 <a:solidFill>
                   <a:srgbClr val="1F4E79"/>
                 </a:solidFill>
@@ -4755,7 +4788,7 @@
               </a:spcAft>
             </a:pPr>
             <a:r>
-              <a:rPr b="1" sz="1600">
+              <a:rPr sz="1600" b="1">
                 <a:solidFill>
                   <a:srgbClr val="C8820E"/>
                 </a:solidFill>
@@ -4763,7 +4796,7 @@
               <a:t>▸  </a:t>
             </a:r>
             <a:r>
-              <a:rPr b="1" sz="1600">
+              <a:rPr sz="1600" b="1">
                 <a:solidFill>
                   <a:srgbClr val="1F4E79"/>
                 </a:solidFill>
@@ -4789,7 +4822,7 @@
               </a:spcAft>
             </a:pPr>
             <a:r>
-              <a:rPr b="1" sz="1600">
+              <a:rPr sz="1600" b="1">
                 <a:solidFill>
                   <a:srgbClr val="C8820E"/>
                 </a:solidFill>
@@ -4797,7 +4830,7 @@
               <a:t>▸  </a:t>
             </a:r>
             <a:r>
-              <a:rPr b="1" sz="1600">
+              <a:rPr sz="1600" b="1">
                 <a:solidFill>
                   <a:srgbClr val="1F4E79"/>
                 </a:solidFill>
@@ -4823,7 +4856,7 @@
               </a:spcAft>
             </a:pPr>
             <a:r>
-              <a:rPr b="1" sz="1600">
+              <a:rPr sz="1600" b="1">
                 <a:solidFill>
                   <a:srgbClr val="C8820E"/>
                 </a:solidFill>
@@ -4831,7 +4864,7 @@
               <a:t>▸  </a:t>
             </a:r>
             <a:r>
-              <a:rPr b="1" sz="1600">
+              <a:rPr sz="1600" b="1">
                 <a:solidFill>
                   <a:srgbClr val="1F4E79"/>
                 </a:solidFill>
@@ -4857,7 +4890,7 @@
               </a:spcAft>
             </a:pPr>
             <a:r>
-              <a:rPr b="1" sz="1600">
+              <a:rPr sz="1600" b="1">
                 <a:solidFill>
                   <a:srgbClr val="C8820E"/>
                 </a:solidFill>
@@ -4865,7 +4898,7 @@
               <a:t>▸  </a:t>
             </a:r>
             <a:r>
-              <a:rPr b="1" sz="1600">
+              <a:rPr sz="1600" b="1">
                 <a:solidFill>
                   <a:srgbClr val="1F4E79"/>
                 </a:solidFill>
@@ -4924,6 +4957,7 @@
           <a:lstStyle/>
           <a:p>
             <a:pPr algn="ctr"/>
+            <a:endParaRPr/>
           </a:p>
         </p:txBody>
       </p:sp>
@@ -4966,7 +5000,7 @@
           </a:fontRef>
         </p:style>
         <p:txBody>
-          <a:bodyPr rtlCol="0" anchor="ctr" wrap="none" lIns="0" rIns="0" tIns="0" bIns="0"/>
+          <a:bodyPr wrap="none" lIns="0" tIns="0" rIns="0" bIns="0" rtlCol="0" anchor="ctr"/>
           <a:lstStyle/>
           <a:p>
             <a:pPr algn="ctr"/>
@@ -5023,6 +5057,7 @@
           <a:lstStyle/>
           <a:p>
             <a:pPr algn="ctr"/>
+            <a:endParaRPr/>
           </a:p>
         </p:txBody>
       </p:sp>
@@ -5102,7 +5137,7 @@
 </file>
 
 <file path=ppt/slides/slide3.xml><?xml version="1.0" encoding="utf-8"?>
-<p:sld xmlns:a="http://schemas.openxmlformats.org/drawingml/2006/main" xmlns:p="http://schemas.openxmlformats.org/presentationml/2006/main" xmlns:r="http://schemas.openxmlformats.org/officeDocument/2006/relationships">
+<p:sld xmlns:a="http://schemas.openxmlformats.org/drawingml/2006/main" xmlns:r="http://schemas.openxmlformats.org/officeDocument/2006/relationships" xmlns:p="http://schemas.openxmlformats.org/presentationml/2006/main">
   <p:cSld>
     <p:spTree>
       <p:nvGrpSpPr>
@@ -5110,7 +5145,14 @@
         <p:cNvGrpSpPr/>
         <p:nvPr/>
       </p:nvGrpSpPr>
-      <p:grpSpPr/>
+      <p:grpSpPr>
+        <a:xfrm>
+          <a:off x="0" y="0"/>
+          <a:ext cx="0" cy="0"/>
+          <a:chOff x="0" y="0"/>
+          <a:chExt cx="0" cy="0"/>
+        </a:xfrm>
+      </p:grpSpPr>
       <p:sp>
         <p:nvSpPr>
           <p:cNvPr id="5" name="Rectangle 4"/>
@@ -5152,6 +5194,7 @@
           <a:lstStyle/>
           <a:p>
             <a:pPr algn="ctr"/>
+            <a:endParaRPr/>
           </a:p>
         </p:txBody>
       </p:sp>
@@ -5217,8 +5260,20 @@
                 <a:tableStyleId>{5C22544A-7EE6-4342-B048-85BDC9FD1C3A}</a:tableStyleId>
               </a:tblPr>
               <a:tblGrid>
-                <a:gridCol w="5532120"/>
-                <a:gridCol w="5532120"/>
+                <a:gridCol w="5532120">
+                  <a:extLst>
+                    <a:ext uri="{9D8B030D-6E8A-4147-A177-3AD203B41FA5}">
+                      <a16:colId xmlns:a16="http://schemas.microsoft.com/office/drawing/2014/main" val="20000"/>
+                    </a:ext>
+                  </a:extLst>
+                </a:gridCol>
+                <a:gridCol w="5532120">
+                  <a:extLst>
+                    <a:ext uri="{9D8B030D-6E8A-4147-A177-3AD203B41FA5}">
+                      <a16:colId xmlns:a16="http://schemas.microsoft.com/office/drawing/2014/main" val="20001"/>
+                    </a:ext>
+                  </a:extLst>
+                </a:gridCol>
               </a:tblGrid>
               <a:tr h="365760">
                 <a:tc>
@@ -5265,6 +5320,11 @@
                     </a:solidFill>
                   </a:tcPr>
                 </a:tc>
+                <a:extLst>
+                  <a:ext uri="{0D108BD9-81ED-4DB2-BD59-A6C34878D82A}">
+                    <a16:rowId xmlns:a16="http://schemas.microsoft.com/office/drawing/2014/main" val="10000"/>
+                  </a:ext>
+                </a:extLst>
               </a:tr>
               <a:tr h="365760">
                 <a:tc>
@@ -5294,6 +5354,11 @@
                   </a:txBody>
                   <a:tcPr anchor="ctr"/>
                 </a:tc>
+                <a:extLst>
+                  <a:ext uri="{0D108BD9-81ED-4DB2-BD59-A6C34878D82A}">
+                    <a16:rowId xmlns:a16="http://schemas.microsoft.com/office/drawing/2014/main" val="10001"/>
+                  </a:ext>
+                </a:extLst>
               </a:tr>
               <a:tr h="365760">
                 <a:tc>
@@ -5323,6 +5388,11 @@
                   </a:txBody>
                   <a:tcPr anchor="ctr"/>
                 </a:tc>
+                <a:extLst>
+                  <a:ext uri="{0D108BD9-81ED-4DB2-BD59-A6C34878D82A}">
+                    <a16:rowId xmlns:a16="http://schemas.microsoft.com/office/drawing/2014/main" val="10002"/>
+                  </a:ext>
+                </a:extLst>
               </a:tr>
               <a:tr h="365760">
                 <a:tc>
@@ -5352,6 +5422,11 @@
                   </a:txBody>
                   <a:tcPr anchor="ctr"/>
                 </a:tc>
+                <a:extLst>
+                  <a:ext uri="{0D108BD9-81ED-4DB2-BD59-A6C34878D82A}">
+                    <a16:rowId xmlns:a16="http://schemas.microsoft.com/office/drawing/2014/main" val="10003"/>
+                  </a:ext>
+                </a:extLst>
               </a:tr>
               <a:tr h="365760">
                 <a:tc>
@@ -5381,6 +5456,11 @@
                   </a:txBody>
                   <a:tcPr anchor="ctr"/>
                 </a:tc>
+                <a:extLst>
+                  <a:ext uri="{0D108BD9-81ED-4DB2-BD59-A6C34878D82A}">
+                    <a16:rowId xmlns:a16="http://schemas.microsoft.com/office/drawing/2014/main" val="10004"/>
+                  </a:ext>
+                </a:extLst>
               </a:tr>
               <a:tr h="365760">
                 <a:tc>
@@ -5410,6 +5490,11 @@
                   </a:txBody>
                   <a:tcPr anchor="ctr"/>
                 </a:tc>
+                <a:extLst>
+                  <a:ext uri="{0D108BD9-81ED-4DB2-BD59-A6C34878D82A}">
+                    <a16:rowId xmlns:a16="http://schemas.microsoft.com/office/drawing/2014/main" val="10005"/>
+                  </a:ext>
+                </a:extLst>
               </a:tr>
               <a:tr h="365760">
                 <a:tc>
@@ -5439,6 +5524,11 @@
                   </a:txBody>
                   <a:tcPr anchor="ctr"/>
                 </a:tc>
+                <a:extLst>
+                  <a:ext uri="{0D108BD9-81ED-4DB2-BD59-A6C34878D82A}">
+                    <a16:rowId xmlns:a16="http://schemas.microsoft.com/office/drawing/2014/main" val="10006"/>
+                  </a:ext>
+                </a:extLst>
               </a:tr>
               <a:tr h="365760">
                 <a:tc>
@@ -5468,6 +5558,11 @@
                   </a:txBody>
                   <a:tcPr anchor="ctr"/>
                 </a:tc>
+                <a:extLst>
+                  <a:ext uri="{0D108BD9-81ED-4DB2-BD59-A6C34878D82A}">
+                    <a16:rowId xmlns:a16="http://schemas.microsoft.com/office/drawing/2014/main" val="10007"/>
+                  </a:ext>
+                </a:extLst>
               </a:tr>
             </a:tbl>
           </a:graphicData>
@@ -5504,7 +5599,7 @@
               </a:spcAft>
             </a:pPr>
             <a:r>
-              <a:rPr b="1" sz="1600">
+              <a:rPr sz="1600" b="1">
                 <a:solidFill>
                   <a:srgbClr val="C8820E"/>
                 </a:solidFill>
@@ -5512,7 +5607,7 @@
               <a:t>▸  </a:t>
             </a:r>
             <a:r>
-              <a:rPr b="1" sz="1600">
+              <a:rPr sz="1600" b="1">
                 <a:solidFill>
                   <a:srgbClr val="1F4E79"/>
                 </a:solidFill>
@@ -5571,6 +5666,7 @@
           <a:lstStyle/>
           <a:p>
             <a:pPr algn="ctr"/>
+            <a:endParaRPr/>
           </a:p>
         </p:txBody>
       </p:sp>
@@ -5613,7 +5709,7 @@
           </a:fontRef>
         </p:style>
         <p:txBody>
-          <a:bodyPr rtlCol="0" anchor="ctr" wrap="none" lIns="0" rIns="0" tIns="0" bIns="0"/>
+          <a:bodyPr wrap="none" lIns="0" tIns="0" rIns="0" bIns="0" rtlCol="0" anchor="ctr"/>
           <a:lstStyle/>
           <a:p>
             <a:pPr algn="ctr"/>
@@ -5670,6 +5766,7 @@
           <a:lstStyle/>
           <a:p>
             <a:pPr algn="ctr"/>
+            <a:endParaRPr/>
           </a:p>
         </p:txBody>
       </p:sp>
@@ -5749,7 +5846,7 @@
 </file>
 
 <file path=ppt/slides/slide4.xml><?xml version="1.0" encoding="utf-8"?>
-<p:sld xmlns:a="http://schemas.openxmlformats.org/drawingml/2006/main" xmlns:p="http://schemas.openxmlformats.org/presentationml/2006/main" xmlns:r="http://schemas.openxmlformats.org/officeDocument/2006/relationships">
+<p:sld xmlns:a="http://schemas.openxmlformats.org/drawingml/2006/main" xmlns:r="http://schemas.openxmlformats.org/officeDocument/2006/relationships" xmlns:p="http://schemas.openxmlformats.org/presentationml/2006/main">
   <p:cSld>
     <p:spTree>
       <p:nvGrpSpPr>
@@ -5757,7 +5854,14 @@
         <p:cNvGrpSpPr/>
         <p:nvPr/>
       </p:nvGrpSpPr>
-      <p:grpSpPr/>
+      <p:grpSpPr>
+        <a:xfrm>
+          <a:off x="0" y="0"/>
+          <a:ext cx="0" cy="0"/>
+          <a:chOff x="0" y="0"/>
+          <a:chExt cx="0" cy="0"/>
+        </a:xfrm>
+      </p:grpSpPr>
       <p:sp>
         <p:nvSpPr>
           <p:cNvPr id="4" name="Rectangle 3"/>
@@ -5799,6 +5903,7 @@
           <a:lstStyle/>
           <a:p>
             <a:pPr algn="ctr"/>
+            <a:endParaRPr/>
           </a:p>
         </p:txBody>
       </p:sp>
@@ -5855,7 +5960,7 @@
         </p:nvGraphicFramePr>
         <p:xfrm>
           <a:off x="548640" y="1371600"/>
-          <a:ext cx="11064240" cy="1828800"/>
+          <a:ext cx="11064240" cy="2072640"/>
         </p:xfrm>
         <a:graphic>
           <a:graphicData uri="http://schemas.openxmlformats.org/drawingml/2006/table">
@@ -5864,9 +5969,27 @@
                 <a:tableStyleId>{5C22544A-7EE6-4342-B048-85BDC9FD1C3A}</a:tableStyleId>
               </a:tblPr>
               <a:tblGrid>
-                <a:gridCol w="3688080"/>
-                <a:gridCol w="3688080"/>
-                <a:gridCol w="3688080"/>
+                <a:gridCol w="3688080">
+                  <a:extLst>
+                    <a:ext uri="{9D8B030D-6E8A-4147-A177-3AD203B41FA5}">
+                      <a16:colId xmlns:a16="http://schemas.microsoft.com/office/drawing/2014/main" val="20000"/>
+                    </a:ext>
+                  </a:extLst>
+                </a:gridCol>
+                <a:gridCol w="3688080">
+                  <a:extLst>
+                    <a:ext uri="{9D8B030D-6E8A-4147-A177-3AD203B41FA5}">
+                      <a16:colId xmlns:a16="http://schemas.microsoft.com/office/drawing/2014/main" val="20001"/>
+                    </a:ext>
+                  </a:extLst>
+                </a:gridCol>
+                <a:gridCol w="3688080">
+                  <a:extLst>
+                    <a:ext uri="{9D8B030D-6E8A-4147-A177-3AD203B41FA5}">
+                      <a16:colId xmlns:a16="http://schemas.microsoft.com/office/drawing/2014/main" val="20002"/>
+                    </a:ext>
+                  </a:extLst>
+                </a:gridCol>
               </a:tblGrid>
               <a:tr h="365760">
                 <a:tc>
@@ -5935,6 +6058,11 @@
                     </a:solidFill>
                   </a:tcPr>
                 </a:tc>
+                <a:extLst>
+                  <a:ext uri="{0D108BD9-81ED-4DB2-BD59-A6C34878D82A}">
+                    <a16:rowId xmlns:a16="http://schemas.microsoft.com/office/drawing/2014/main" val="10000"/>
+                  </a:ext>
+                </a:extLst>
               </a:tr>
               <a:tr h="365760">
                 <a:tc>
@@ -5979,6 +6107,11 @@
                   </a:txBody>
                   <a:tcPr anchor="ctr"/>
                 </a:tc>
+                <a:extLst>
+                  <a:ext uri="{0D108BD9-81ED-4DB2-BD59-A6C34878D82A}">
+                    <a16:rowId xmlns:a16="http://schemas.microsoft.com/office/drawing/2014/main" val="10001"/>
+                  </a:ext>
+                </a:extLst>
               </a:tr>
               <a:tr h="365760">
                 <a:tc>
@@ -6023,6 +6156,11 @@
                   </a:txBody>
                   <a:tcPr anchor="ctr"/>
                 </a:tc>
+                <a:extLst>
+                  <a:ext uri="{0D108BD9-81ED-4DB2-BD59-A6C34878D82A}">
+                    <a16:rowId xmlns:a16="http://schemas.microsoft.com/office/drawing/2014/main" val="10002"/>
+                  </a:ext>
+                </a:extLst>
               </a:tr>
               <a:tr h="365760">
                 <a:tc>
@@ -6067,6 +6205,11 @@
                   </a:txBody>
                   <a:tcPr anchor="ctr"/>
                 </a:tc>
+                <a:extLst>
+                  <a:ext uri="{0D108BD9-81ED-4DB2-BD59-A6C34878D82A}">
+                    <a16:rowId xmlns:a16="http://schemas.microsoft.com/office/drawing/2014/main" val="10003"/>
+                  </a:ext>
+                </a:extLst>
               </a:tr>
               <a:tr h="365760">
                 <a:tc>
@@ -6111,6 +6254,11 @@
                   </a:txBody>
                   <a:tcPr anchor="ctr"/>
                 </a:tc>
+                <a:extLst>
+                  <a:ext uri="{0D108BD9-81ED-4DB2-BD59-A6C34878D82A}">
+                    <a16:rowId xmlns:a16="http://schemas.microsoft.com/office/drawing/2014/main" val="10004"/>
+                  </a:ext>
+                </a:extLst>
               </a:tr>
             </a:tbl>
           </a:graphicData>
@@ -6157,6 +6305,7 @@
           <a:lstStyle/>
           <a:p>
             <a:pPr algn="ctr"/>
+            <a:endParaRPr/>
           </a:p>
         </p:txBody>
       </p:sp>
@@ -6199,7 +6348,7 @@
           </a:fontRef>
         </p:style>
         <p:txBody>
-          <a:bodyPr rtlCol="0" anchor="ctr" wrap="none" lIns="0" rIns="0" tIns="0" bIns="0"/>
+          <a:bodyPr wrap="none" lIns="0" tIns="0" rIns="0" bIns="0" rtlCol="0" anchor="ctr"/>
           <a:lstStyle/>
           <a:p>
             <a:pPr algn="ctr"/>
@@ -6256,6 +6405,7 @@
           <a:lstStyle/>
           <a:p>
             <a:pPr algn="ctr"/>
+            <a:endParaRPr/>
           </a:p>
         </p:txBody>
       </p:sp>
@@ -6335,7 +6485,7 @@
 </file>
 
 <file path=ppt/slides/slide5.xml><?xml version="1.0" encoding="utf-8"?>
-<p:sld xmlns:a="http://schemas.openxmlformats.org/drawingml/2006/main" xmlns:p="http://schemas.openxmlformats.org/presentationml/2006/main" xmlns:r="http://schemas.openxmlformats.org/officeDocument/2006/relationships">
+<p:sld xmlns:a="http://schemas.openxmlformats.org/drawingml/2006/main" xmlns:r="http://schemas.openxmlformats.org/officeDocument/2006/relationships" xmlns:p="http://schemas.openxmlformats.org/presentationml/2006/main">
   <p:cSld>
     <p:spTree>
       <p:nvGrpSpPr>
@@ -6343,7 +6493,14 @@
         <p:cNvGrpSpPr/>
         <p:nvPr/>
       </p:nvGrpSpPr>
-      <p:grpSpPr/>
+      <p:grpSpPr>
+        <a:xfrm>
+          <a:off x="0" y="0"/>
+          <a:ext cx="0" cy="0"/>
+          <a:chOff x="0" y="0"/>
+          <a:chExt cx="0" cy="0"/>
+        </a:xfrm>
+      </p:grpSpPr>
       <p:sp>
         <p:nvSpPr>
           <p:cNvPr id="4" name="Rectangle 3"/>
@@ -6385,6 +6542,7 @@
           <a:lstStyle/>
           <a:p>
             <a:pPr algn="ctr"/>
+            <a:endParaRPr/>
           </a:p>
         </p:txBody>
       </p:sp>
@@ -6441,7 +6599,7 @@
         </p:nvGraphicFramePr>
         <p:xfrm>
           <a:off x="548640" y="1371600"/>
-          <a:ext cx="11064240" cy="2560320"/>
+          <a:ext cx="11064240" cy="3291840"/>
         </p:xfrm>
         <a:graphic>
           <a:graphicData uri="http://schemas.openxmlformats.org/drawingml/2006/table">
@@ -6450,9 +6608,27 @@
                 <a:tableStyleId>{5C22544A-7EE6-4342-B048-85BDC9FD1C3A}</a:tableStyleId>
               </a:tblPr>
               <a:tblGrid>
-                <a:gridCol w="3688080"/>
-                <a:gridCol w="3688080"/>
-                <a:gridCol w="3688080"/>
+                <a:gridCol w="3688080">
+                  <a:extLst>
+                    <a:ext uri="{9D8B030D-6E8A-4147-A177-3AD203B41FA5}">
+                      <a16:colId xmlns:a16="http://schemas.microsoft.com/office/drawing/2014/main" val="20000"/>
+                    </a:ext>
+                  </a:extLst>
+                </a:gridCol>
+                <a:gridCol w="3688080">
+                  <a:extLst>
+                    <a:ext uri="{9D8B030D-6E8A-4147-A177-3AD203B41FA5}">
+                      <a16:colId xmlns:a16="http://schemas.microsoft.com/office/drawing/2014/main" val="20001"/>
+                    </a:ext>
+                  </a:extLst>
+                </a:gridCol>
+                <a:gridCol w="3688080">
+                  <a:extLst>
+                    <a:ext uri="{9D8B030D-6E8A-4147-A177-3AD203B41FA5}">
+                      <a16:colId xmlns:a16="http://schemas.microsoft.com/office/drawing/2014/main" val="20002"/>
+                    </a:ext>
+                  </a:extLst>
+                </a:gridCol>
               </a:tblGrid>
               <a:tr h="365760">
                 <a:tc>
@@ -6521,6 +6697,11 @@
                     </a:solidFill>
                   </a:tcPr>
                 </a:tc>
+                <a:extLst>
+                  <a:ext uri="{0D108BD9-81ED-4DB2-BD59-A6C34878D82A}">
+                    <a16:rowId xmlns:a16="http://schemas.microsoft.com/office/drawing/2014/main" val="10000"/>
+                  </a:ext>
+                </a:extLst>
               </a:tr>
               <a:tr h="365760">
                 <a:tc>
@@ -6589,6 +6770,11 @@
                     </a:solidFill>
                   </a:tcPr>
                 </a:tc>
+                <a:extLst>
+                  <a:ext uri="{0D108BD9-81ED-4DB2-BD59-A6C34878D82A}">
+                    <a16:rowId xmlns:a16="http://schemas.microsoft.com/office/drawing/2014/main" val="10001"/>
+                  </a:ext>
+                </a:extLst>
               </a:tr>
               <a:tr h="365760">
                 <a:tc>
@@ -6657,6 +6843,11 @@
                     </a:solidFill>
                   </a:tcPr>
                 </a:tc>
+                <a:extLst>
+                  <a:ext uri="{0D108BD9-81ED-4DB2-BD59-A6C34878D82A}">
+                    <a16:rowId xmlns:a16="http://schemas.microsoft.com/office/drawing/2014/main" val="10002"/>
+                  </a:ext>
+                </a:extLst>
               </a:tr>
               <a:tr h="365760">
                 <a:tc>
@@ -6725,6 +6916,11 @@
                     </a:solidFill>
                   </a:tcPr>
                 </a:tc>
+                <a:extLst>
+                  <a:ext uri="{0D108BD9-81ED-4DB2-BD59-A6C34878D82A}">
+                    <a16:rowId xmlns:a16="http://schemas.microsoft.com/office/drawing/2014/main" val="10003"/>
+                  </a:ext>
+                </a:extLst>
               </a:tr>
               <a:tr h="365760">
                 <a:tc>
@@ -6793,6 +6989,11 @@
                     </a:solidFill>
                   </a:tcPr>
                 </a:tc>
+                <a:extLst>
+                  <a:ext uri="{0D108BD9-81ED-4DB2-BD59-A6C34878D82A}">
+                    <a16:rowId xmlns:a16="http://schemas.microsoft.com/office/drawing/2014/main" val="10004"/>
+                  </a:ext>
+                </a:extLst>
               </a:tr>
               <a:tr h="365760">
                 <a:tc>
@@ -6861,6 +7062,11 @@
                     </a:solidFill>
                   </a:tcPr>
                 </a:tc>
+                <a:extLst>
+                  <a:ext uri="{0D108BD9-81ED-4DB2-BD59-A6C34878D82A}">
+                    <a16:rowId xmlns:a16="http://schemas.microsoft.com/office/drawing/2014/main" val="10005"/>
+                  </a:ext>
+                </a:extLst>
               </a:tr>
               <a:tr h="365760">
                 <a:tc>
@@ -6929,6 +7135,11 @@
                     </a:solidFill>
                   </a:tcPr>
                 </a:tc>
+                <a:extLst>
+                  <a:ext uri="{0D108BD9-81ED-4DB2-BD59-A6C34878D82A}">
+                    <a16:rowId xmlns:a16="http://schemas.microsoft.com/office/drawing/2014/main" val="10006"/>
+                  </a:ext>
+                </a:extLst>
               </a:tr>
             </a:tbl>
           </a:graphicData>
@@ -6975,6 +7186,7 @@
           <a:lstStyle/>
           <a:p>
             <a:pPr algn="ctr"/>
+            <a:endParaRPr/>
           </a:p>
         </p:txBody>
       </p:sp>
@@ -7017,7 +7229,7 @@
           </a:fontRef>
         </p:style>
         <p:txBody>
-          <a:bodyPr rtlCol="0" anchor="ctr" wrap="none" lIns="0" rIns="0" tIns="0" bIns="0"/>
+          <a:bodyPr wrap="none" lIns="0" tIns="0" rIns="0" bIns="0" rtlCol="0" anchor="ctr"/>
           <a:lstStyle/>
           <a:p>
             <a:pPr algn="ctr"/>
@@ -7074,6 +7286,7 @@
           <a:lstStyle/>
           <a:p>
             <a:pPr algn="ctr"/>
+            <a:endParaRPr/>
           </a:p>
         </p:txBody>
       </p:sp>
@@ -7153,7 +7366,7 @@
 </file>
 
 <file path=ppt/slides/slide6.xml><?xml version="1.0" encoding="utf-8"?>
-<p:sld xmlns:a="http://schemas.openxmlformats.org/drawingml/2006/main" xmlns:p="http://schemas.openxmlformats.org/presentationml/2006/main" xmlns:r="http://schemas.openxmlformats.org/officeDocument/2006/relationships">
+<p:sld xmlns:a="http://schemas.openxmlformats.org/drawingml/2006/main" xmlns:r="http://schemas.openxmlformats.org/officeDocument/2006/relationships" xmlns:p="http://schemas.openxmlformats.org/presentationml/2006/main">
   <p:cSld>
     <p:spTree>
       <p:nvGrpSpPr>
@@ -7161,7 +7374,14 @@
         <p:cNvGrpSpPr/>
         <p:nvPr/>
       </p:nvGrpSpPr>
-      <p:grpSpPr/>
+      <p:grpSpPr>
+        <a:xfrm>
+          <a:off x="0" y="0"/>
+          <a:ext cx="0" cy="0"/>
+          <a:chOff x="0" y="0"/>
+          <a:chExt cx="0" cy="0"/>
+        </a:xfrm>
+      </p:grpSpPr>
       <p:sp>
         <p:nvSpPr>
           <p:cNvPr id="6" name="Rectangle 5"/>
@@ -7203,6 +7423,7 @@
           <a:lstStyle/>
           <a:p>
             <a:pPr algn="ctr"/>
+            <a:endParaRPr/>
           </a:p>
         </p:txBody>
       </p:sp>
@@ -7214,8 +7435,8 @@
         </p:nvSpPr>
         <p:spPr>
           <a:xfrm>
-            <a:off x="1234440" y="91440"/>
-            <a:ext cx="10728655" cy="960120"/>
+            <a:off x="1234440" y="232946"/>
+            <a:ext cx="4203330" cy="677108"/>
           </a:xfrm>
           <a:prstGeom prst="rect">
             <a:avLst/>
@@ -7229,7 +7450,7 @@
           <a:lstStyle/>
           <a:p>
             <a:r>
-              <a:rPr sz="2600" b="1">
+              <a:rPr sz="2600" b="1" dirty="0">
                 <a:solidFill>
                   <a:srgbClr val="FFFFFF"/>
                 </a:solidFill>
@@ -7239,12 +7460,36 @@
           </a:p>
           <a:p>
             <a:r>
-              <a:rPr sz="1200">
+              <a:rPr sz="1200" dirty="0">
                 <a:solidFill>
                   <a:srgbClr val="C9D7E4"/>
                 </a:solidFill>
               </a:rPr>
-              <a:t>Playable game + autonomous rescue agent (robot or drone skin)</a:t>
+              <a:t>Playable game + </a:t>
+            </a:r>
+            <a:r>
+              <a:rPr lang="en-SG" sz="1200" dirty="0">
+                <a:solidFill>
+                  <a:srgbClr val="C9D7E4"/>
+                </a:solidFill>
+              </a:rPr>
+              <a:t>A</a:t>
+            </a:r>
+            <a:r>
+              <a:rPr sz="1200" dirty="0" err="1">
+                <a:solidFill>
+                  <a:srgbClr val="C9D7E4"/>
+                </a:solidFill>
+              </a:rPr>
+              <a:t>utonomous</a:t>
+            </a:r>
+            <a:r>
+              <a:rPr sz="1200" dirty="0">
+                <a:solidFill>
+                  <a:srgbClr val="C9D7E4"/>
+                </a:solidFill>
+              </a:rPr>
+              <a:t> rescue agent (robot or drone skin)</a:t>
             </a:r>
           </a:p>
         </p:txBody>
@@ -7280,7 +7525,7 @@
               </a:spcAft>
             </a:pPr>
             <a:r>
-              <a:rPr b="1" sz="1600">
+              <a:rPr sz="1600" b="1">
                 <a:solidFill>
                   <a:srgbClr val="C8820E"/>
                 </a:solidFill>
@@ -7288,7 +7533,7 @@
               <a:t>▸  </a:t>
             </a:r>
             <a:r>
-              <a:rPr b="1" sz="1600">
+              <a:rPr sz="1600" b="1">
                 <a:solidFill>
                   <a:srgbClr val="1F4E79"/>
                 </a:solidFill>
@@ -7314,7 +7559,7 @@
               </a:spcAft>
             </a:pPr>
             <a:r>
-              <a:rPr b="1" sz="1600">
+              <a:rPr sz="1600" b="1">
                 <a:solidFill>
                   <a:srgbClr val="C8820E"/>
                 </a:solidFill>
@@ -7322,7 +7567,7 @@
               <a:t>▸  </a:t>
             </a:r>
             <a:r>
-              <a:rPr b="1" sz="1600">
+              <a:rPr sz="1600" b="1">
                 <a:solidFill>
                   <a:srgbClr val="1F4E79"/>
                 </a:solidFill>
@@ -7348,7 +7593,7 @@
               </a:spcAft>
             </a:pPr>
             <a:r>
-              <a:rPr b="1" sz="1600">
+              <a:rPr sz="1600" b="1">
                 <a:solidFill>
                   <a:srgbClr val="C8820E"/>
                 </a:solidFill>
@@ -7356,12 +7601,20 @@
               <a:t>▸  </a:t>
             </a:r>
             <a:r>
+              <a:rPr sz="1600" b="1">
+                <a:solidFill>
+                  <a:srgbClr val="1F4E79"/>
+                </a:solidFill>
+              </a:rPr>
+              <a:t>Techniques (from the brief's list): </a:t>
+            </a:r>
+            <a:r>
               <a:rPr sz="1600">
                 <a:solidFill>
                   <a:srgbClr val="2B2B2B"/>
                 </a:solidFill>
               </a:rPr>
-              <a:t>Techniques (from the brief's list): Search (BFS/Dijkstra/A*/Greedy) • Intelligent agent • Decision-making under uncertainty • Machine learning (optional second brain, imitates A*)</a:t>
+              <a:t>Search (BFS/Dijkstra/A*/Greedy) • Intelligent agent • Decision-making under uncertainty • Machine learning (optional second brain, imitates A*)</a:t>
             </a:r>
           </a:p>
           <a:p>
@@ -7374,7 +7627,7 @@
               </a:spcAft>
             </a:pPr>
             <a:r>
-              <a:rPr b="1" sz="1600">
+              <a:rPr sz="1600" b="1">
                 <a:solidFill>
                   <a:srgbClr val="C8820E"/>
                 </a:solidFill>
@@ -7382,7 +7635,7 @@
               <a:t>▸  </a:t>
             </a:r>
             <a:r>
-              <a:rPr b="1" sz="1600">
+              <a:rPr sz="1600" b="1">
                 <a:solidFill>
                   <a:srgbClr val="1F4E79"/>
                 </a:solidFill>
@@ -7408,7 +7661,7 @@
               </a:spcAft>
             </a:pPr>
             <a:r>
-              <a:rPr b="1" sz="1600">
+              <a:rPr sz="1600" b="1">
                 <a:solidFill>
                   <a:srgbClr val="C8820E"/>
                 </a:solidFill>
@@ -7416,7 +7669,7 @@
               <a:t>▸  </a:t>
             </a:r>
             <a:r>
-              <a:rPr b="1" sz="1600">
+              <a:rPr sz="1600" b="1">
                 <a:solidFill>
                   <a:srgbClr val="1F4E79"/>
                 </a:solidFill>
@@ -7458,30 +7711,6 @@
           </a:prstGeom>
         </p:spPr>
       </p:pic>
-      <p:pic>
-        <p:nvPicPr>
-          <p:cNvPr id="5" name="Picture 4" descr="ui_sheet_final.png"/>
-          <p:cNvPicPr>
-            <a:picLocks noChangeAspect="1"/>
-          </p:cNvPicPr>
-          <p:nvPr/>
-        </p:nvPicPr>
-        <p:blipFill>
-          <a:blip r:embed="rId3"/>
-          <a:stretch>
-            <a:fillRect/>
-          </a:stretch>
-        </p:blipFill>
-        <p:spPr>
-          <a:xfrm>
-            <a:off x="5364201" y="4160520"/>
-            <a:ext cx="3360420" cy="2240280"/>
-          </a:xfrm>
-          <a:prstGeom prst="rect">
-            <a:avLst/>
-          </a:prstGeom>
-        </p:spPr>
-      </p:pic>
       <p:sp>
         <p:nvSpPr>
           <p:cNvPr id="7" name="Rectangle 6"/>
@@ -7523,6 +7752,7 @@
           <a:lstStyle/>
           <a:p>
             <a:pPr algn="ctr"/>
+            <a:endParaRPr/>
           </a:p>
         </p:txBody>
       </p:sp>
@@ -7565,7 +7795,7 @@
           </a:fontRef>
         </p:style>
         <p:txBody>
-          <a:bodyPr rtlCol="0" anchor="ctr" wrap="none" lIns="0" rIns="0" tIns="0" bIns="0"/>
+          <a:bodyPr wrap="none" lIns="0" tIns="0" rIns="0" bIns="0" rtlCol="0" anchor="ctr"/>
           <a:lstStyle/>
           <a:p>
             <a:pPr algn="ctr"/>
@@ -7622,6 +7852,7 @@
           <a:lstStyle/>
           <a:p>
             <a:pPr algn="ctr"/>
+            <a:endParaRPr/>
           </a:p>
         </p:txBody>
       </p:sp>
@@ -7692,6 +7923,30 @@
           </a:p>
         </p:txBody>
       </p:sp>
+      <p:pic>
+        <p:nvPicPr>
+          <p:cNvPr id="12" name="Picture 11" descr="slide6_two_panels.png"/>
+          <p:cNvPicPr>
+            <a:picLocks noChangeAspect="1"/>
+          </p:cNvPicPr>
+          <p:nvPr/>
+        </p:nvPicPr>
+        <p:blipFill>
+          <a:blip r:embed="rId4"/>
+          <a:stretch>
+            <a:fillRect/>
+          </a:stretch>
+        </p:blipFill>
+        <p:spPr>
+          <a:xfrm>
+            <a:off x="5074920" y="4160520"/>
+            <a:ext cx="5989320" cy="2240280"/>
+          </a:xfrm>
+          <a:prstGeom prst="rect">
+            <a:avLst/>
+          </a:prstGeom>
+        </p:spPr>
+      </p:pic>
     </p:spTree>
   </p:cSld>
   <p:clrMapOvr>
@@ -7701,7 +7956,7 @@
 </file>
 
 <file path=ppt/slides/slide7.xml><?xml version="1.0" encoding="utf-8"?>
-<p:sld xmlns:a="http://schemas.openxmlformats.org/drawingml/2006/main" xmlns:p="http://schemas.openxmlformats.org/presentationml/2006/main" xmlns:r="http://schemas.openxmlformats.org/officeDocument/2006/relationships">
+<p:sld xmlns:a="http://schemas.openxmlformats.org/drawingml/2006/main" xmlns:r="http://schemas.openxmlformats.org/officeDocument/2006/relationships" xmlns:p="http://schemas.openxmlformats.org/presentationml/2006/main">
   <p:cSld>
     <p:spTree>
       <p:nvGrpSpPr>
@@ -7709,7 +7964,14 @@
         <p:cNvGrpSpPr/>
         <p:nvPr/>
       </p:nvGrpSpPr>
-      <p:grpSpPr/>
+      <p:grpSpPr>
+        <a:xfrm>
+          <a:off x="0" y="0"/>
+          <a:ext cx="0" cy="0"/>
+          <a:chOff x="0" y="0"/>
+          <a:chExt cx="0" cy="0"/>
+        </a:xfrm>
+      </p:grpSpPr>
       <p:sp>
         <p:nvSpPr>
           <p:cNvPr id="6" name="Rectangle 5"/>
@@ -7751,6 +8013,7 @@
           <a:lstStyle/>
           <a:p>
             <a:pPr algn="ctr"/>
+            <a:endParaRPr/>
           </a:p>
         </p:txBody>
       </p:sp>
@@ -7828,7 +8091,7 @@
               </a:spcAft>
             </a:pPr>
             <a:r>
-              <a:rPr b="1" sz="1600">
+              <a:rPr sz="1600" b="1">
                 <a:solidFill>
                   <a:srgbClr val="C8820E"/>
                 </a:solidFill>
@@ -7836,7 +8099,7 @@
               <a:t>▸  </a:t>
             </a:r>
             <a:r>
-              <a:rPr b="1" sz="1600">
+              <a:rPr sz="1600" b="1">
                 <a:solidFill>
                   <a:srgbClr val="1F4E79"/>
                 </a:solidFill>
@@ -7873,10 +8136,34 @@
                 <a:tableStyleId>{5C22544A-7EE6-4342-B048-85BDC9FD1C3A}</a:tableStyleId>
               </a:tblPr>
               <a:tblGrid>
-                <a:gridCol w="2766060"/>
-                <a:gridCol w="2766060"/>
-                <a:gridCol w="2766060"/>
-                <a:gridCol w="2766060"/>
+                <a:gridCol w="2766060">
+                  <a:extLst>
+                    <a:ext uri="{9D8B030D-6E8A-4147-A177-3AD203B41FA5}">
+                      <a16:colId xmlns:a16="http://schemas.microsoft.com/office/drawing/2014/main" val="20000"/>
+                    </a:ext>
+                  </a:extLst>
+                </a:gridCol>
+                <a:gridCol w="2766060">
+                  <a:extLst>
+                    <a:ext uri="{9D8B030D-6E8A-4147-A177-3AD203B41FA5}">
+                      <a16:colId xmlns:a16="http://schemas.microsoft.com/office/drawing/2014/main" val="20001"/>
+                    </a:ext>
+                  </a:extLst>
+                </a:gridCol>
+                <a:gridCol w="2766060">
+                  <a:extLst>
+                    <a:ext uri="{9D8B030D-6E8A-4147-A177-3AD203B41FA5}">
+                      <a16:colId xmlns:a16="http://schemas.microsoft.com/office/drawing/2014/main" val="20002"/>
+                    </a:ext>
+                  </a:extLst>
+                </a:gridCol>
+                <a:gridCol w="2766060">
+                  <a:extLst>
+                    <a:ext uri="{9D8B030D-6E8A-4147-A177-3AD203B41FA5}">
+                      <a16:colId xmlns:a16="http://schemas.microsoft.com/office/drawing/2014/main" val="20003"/>
+                    </a:ext>
+                  </a:extLst>
+                </a:gridCol>
               </a:tblGrid>
               <a:tr h="365760">
                 <a:tc>
@@ -7884,6 +8171,7 @@
                     <a:bodyPr/>
                     <a:lstStyle/>
                     <a:p>
+                      <a:pPr algn="ctr"/>
                       <a:r>
                         <a:rPr sz="1300" b="1">
                           <a:solidFill>
@@ -7894,7 +8182,7 @@
                       </a:r>
                     </a:p>
                   </a:txBody>
-                  <a:tcPr>
+                  <a:tcPr anchor="ctr">
                     <a:solidFill>
                       <a:srgbClr val="1F4E79"/>
                     </a:solidFill>
@@ -7905,6 +8193,7 @@
                     <a:bodyPr/>
                     <a:lstStyle/>
                     <a:p>
+                      <a:pPr algn="ctr"/>
                       <a:r>
                         <a:rPr sz="1300" b="1">
                           <a:solidFill>
@@ -7915,7 +8204,7 @@
                       </a:r>
                     </a:p>
                   </a:txBody>
-                  <a:tcPr>
+                  <a:tcPr anchor="ctr">
                     <a:solidFill>
                       <a:srgbClr val="1F4E79"/>
                     </a:solidFill>
@@ -7926,6 +8215,7 @@
                     <a:bodyPr/>
                     <a:lstStyle/>
                     <a:p>
+                      <a:pPr algn="ctr"/>
                       <a:r>
                         <a:rPr sz="1300" b="1">
                           <a:solidFill>
@@ -7936,7 +8226,7 @@
                       </a:r>
                     </a:p>
                   </a:txBody>
-                  <a:tcPr>
+                  <a:tcPr anchor="ctr">
                     <a:solidFill>
                       <a:srgbClr val="1F4E79"/>
                     </a:solidFill>
@@ -7947,6 +8237,7 @@
                     <a:bodyPr/>
                     <a:lstStyle/>
                     <a:p>
+                      <a:pPr algn="ctr"/>
                       <a:r>
                         <a:rPr sz="1300" b="1">
                           <a:solidFill>
@@ -7957,12 +8248,17 @@
                       </a:r>
                     </a:p>
                   </a:txBody>
-                  <a:tcPr>
+                  <a:tcPr anchor="ctr">
                     <a:solidFill>
                       <a:srgbClr val="1F4E79"/>
                     </a:solidFill>
                   </a:tcPr>
                 </a:tc>
+                <a:extLst>
+                  <a:ext uri="{0D108BD9-81ED-4DB2-BD59-A6C34878D82A}">
+                    <a16:rowId xmlns:a16="http://schemas.microsoft.com/office/drawing/2014/main" val="10000"/>
+                  </a:ext>
+                </a:extLst>
               </a:tr>
               <a:tr h="365760">
                 <a:tc>
@@ -7970,6 +8266,7 @@
                     <a:bodyPr/>
                     <a:lstStyle/>
                     <a:p>
+                      <a:pPr algn="ctr"/>
                       <a:r>
                         <a:rPr sz="1300" b="1">
                           <a:solidFill>
@@ -7980,7 +8277,7 @@
                       </a:r>
                     </a:p>
                   </a:txBody>
-                  <a:tcPr>
+                  <a:tcPr anchor="ctr">
                     <a:solidFill>
                       <a:srgbClr val="FBE7E4"/>
                     </a:solidFill>
@@ -7991,6 +8288,7 @@
                     <a:bodyPr/>
                     <a:lstStyle/>
                     <a:p>
+                      <a:pPr algn="ctr"/>
                       <a:r>
                         <a:rPr sz="1300" b="1">
                           <a:solidFill>
@@ -8001,7 +8299,7 @@
                       </a:r>
                     </a:p>
                   </a:txBody>
-                  <a:tcPr>
+                  <a:tcPr anchor="ctr">
                     <a:solidFill>
                       <a:srgbClr val="FBE7E4"/>
                     </a:solidFill>
@@ -8012,6 +8310,7 @@
                     <a:bodyPr/>
                     <a:lstStyle/>
                     <a:p>
+                      <a:pPr algn="ctr"/>
                       <a:r>
                         <a:rPr sz="1300" b="1">
                           <a:solidFill>
@@ -8022,7 +8321,7 @@
                       </a:r>
                     </a:p>
                   </a:txBody>
-                  <a:tcPr>
+                  <a:tcPr anchor="ctr">
                     <a:solidFill>
                       <a:srgbClr val="FBE7E4"/>
                     </a:solidFill>
@@ -8033,6 +8332,7 @@
                     <a:bodyPr/>
                     <a:lstStyle/>
                     <a:p>
+                      <a:pPr algn="ctr"/>
                       <a:r>
                         <a:rPr sz="1300" b="1">
                           <a:solidFill>
@@ -8043,12 +8343,17 @@
                       </a:r>
                     </a:p>
                   </a:txBody>
-                  <a:tcPr>
+                  <a:tcPr anchor="ctr">
                     <a:solidFill>
                       <a:srgbClr val="FBE7E4"/>
                     </a:solidFill>
                   </a:tcPr>
                 </a:tc>
+                <a:extLst>
+                  <a:ext uri="{0D108BD9-81ED-4DB2-BD59-A6C34878D82A}">
+                    <a16:rowId xmlns:a16="http://schemas.microsoft.com/office/drawing/2014/main" val="10001"/>
+                  </a:ext>
+                </a:extLst>
               </a:tr>
               <a:tr h="365760">
                 <a:tc>
@@ -8056,53 +8361,62 @@
                     <a:bodyPr/>
                     <a:lstStyle/>
                     <a:p>
+                      <a:pPr algn="ctr"/>
                       <a:r>
                         <a:rPr sz="1300"/>
                         <a:t>Dijkstra</a:t>
                       </a:r>
                     </a:p>
                   </a:txBody>
-                  <a:tcPr/>
+                  <a:tcPr anchor="ctr"/>
                 </a:tc>
                 <a:tc>
                   <a:txBody>
                     <a:bodyPr/>
                     <a:lstStyle/>
                     <a:p>
+                      <a:pPr algn="ctr"/>
                       <a:r>
                         <a:rPr sz="1300"/>
                         <a:t>43.8</a:t>
                       </a:r>
                     </a:p>
                   </a:txBody>
-                  <a:tcPr/>
+                  <a:tcPr anchor="ctr"/>
                 </a:tc>
                 <a:tc>
                   <a:txBody>
                     <a:bodyPr/>
                     <a:lstStyle/>
                     <a:p>
+                      <a:pPr algn="ctr"/>
                       <a:r>
                         <a:rPr sz="1300"/>
                         <a:t>42</a:t>
                       </a:r>
                     </a:p>
                   </a:txBody>
-                  <a:tcPr/>
+                  <a:tcPr anchor="ctr"/>
                 </a:tc>
                 <a:tc>
                   <a:txBody>
                     <a:bodyPr/>
                     <a:lstStyle/>
                     <a:p>
+                      <a:pPr algn="ctr"/>
                       <a:r>
                         <a:rPr sz="1300"/>
                         <a:t>2</a:t>
                       </a:r>
                     </a:p>
                   </a:txBody>
-                  <a:tcPr/>
+                  <a:tcPr anchor="ctr"/>
                 </a:tc>
+                <a:extLst>
+                  <a:ext uri="{0D108BD9-81ED-4DB2-BD59-A6C34878D82A}">
+                    <a16:rowId xmlns:a16="http://schemas.microsoft.com/office/drawing/2014/main" val="10002"/>
+                  </a:ext>
+                </a:extLst>
               </a:tr>
               <a:tr h="365760">
                 <a:tc>
@@ -8110,6 +8424,7 @@
                     <a:bodyPr/>
                     <a:lstStyle/>
                     <a:p>
+                      <a:pPr algn="ctr"/>
                       <a:r>
                         <a:rPr sz="1300" b="1">
                           <a:solidFill>
@@ -8120,7 +8435,7 @@
                       </a:r>
                     </a:p>
                   </a:txBody>
-                  <a:tcPr>
+                  <a:tcPr anchor="ctr">
                     <a:solidFill>
                       <a:srgbClr val="E4F3E8"/>
                     </a:solidFill>
@@ -8131,6 +8446,7 @@
                     <a:bodyPr/>
                     <a:lstStyle/>
                     <a:p>
+                      <a:pPr algn="ctr"/>
                       <a:r>
                         <a:rPr sz="1300" b="1">
                           <a:solidFill>
@@ -8141,7 +8457,7 @@
                       </a:r>
                     </a:p>
                   </a:txBody>
-                  <a:tcPr>
+                  <a:tcPr anchor="ctr">
                     <a:solidFill>
                       <a:srgbClr val="E4F3E8"/>
                     </a:solidFill>
@@ -8152,6 +8468,7 @@
                     <a:bodyPr/>
                     <a:lstStyle/>
                     <a:p>
+                      <a:pPr algn="ctr"/>
                       <a:r>
                         <a:rPr sz="1300" b="1">
                           <a:solidFill>
@@ -8162,7 +8479,7 @@
                       </a:r>
                     </a:p>
                   </a:txBody>
-                  <a:tcPr>
+                  <a:tcPr anchor="ctr">
                     <a:solidFill>
                       <a:srgbClr val="E4F3E8"/>
                     </a:solidFill>
@@ -8173,6 +8490,7 @@
                     <a:bodyPr/>
                     <a:lstStyle/>
                     <a:p>
+                      <a:pPr algn="ctr"/>
                       <a:r>
                         <a:rPr sz="1300" b="1">
                           <a:solidFill>
@@ -8183,12 +8501,17 @@
                       </a:r>
                     </a:p>
                   </a:txBody>
-                  <a:tcPr>
+                  <a:tcPr anchor="ctr">
                     <a:solidFill>
                       <a:srgbClr val="E4F3E8"/>
                     </a:solidFill>
                   </a:tcPr>
                 </a:tc>
+                <a:extLst>
+                  <a:ext uri="{0D108BD9-81ED-4DB2-BD59-A6C34878D82A}">
+                    <a16:rowId xmlns:a16="http://schemas.microsoft.com/office/drawing/2014/main" val="10003"/>
+                  </a:ext>
+                </a:extLst>
               </a:tr>
               <a:tr h="365760">
                 <a:tc>
@@ -8196,6 +8519,7 @@
                     <a:bodyPr/>
                     <a:lstStyle/>
                     <a:p>
+                      <a:pPr algn="ctr"/>
                       <a:r>
                         <a:rPr sz="1300" b="1">
                           <a:solidFill>
@@ -8206,7 +8530,7 @@
                       </a:r>
                     </a:p>
                   </a:txBody>
-                  <a:tcPr>
+                  <a:tcPr anchor="ctr">
                     <a:solidFill>
                       <a:srgbClr val="FBE7E4"/>
                     </a:solidFill>
@@ -8217,6 +8541,7 @@
                     <a:bodyPr/>
                     <a:lstStyle/>
                     <a:p>
+                      <a:pPr algn="ctr"/>
                       <a:r>
                         <a:rPr sz="1300" b="1">
                           <a:solidFill>
@@ -8227,7 +8552,7 @@
                       </a:r>
                     </a:p>
                   </a:txBody>
-                  <a:tcPr>
+                  <a:tcPr anchor="ctr">
                     <a:solidFill>
                       <a:srgbClr val="FBE7E4"/>
                     </a:solidFill>
@@ -8238,6 +8563,7 @@
                     <a:bodyPr/>
                     <a:lstStyle/>
                     <a:p>
+                      <a:pPr algn="ctr"/>
                       <a:r>
                         <a:rPr sz="1300" b="1">
                           <a:solidFill>
@@ -8248,7 +8574,7 @@
                       </a:r>
                     </a:p>
                   </a:txBody>
-                  <a:tcPr>
+                  <a:tcPr anchor="ctr">
                     <a:solidFill>
                       <a:srgbClr val="FBE7E4"/>
                     </a:solidFill>
@@ -8259,6 +8585,7 @@
                     <a:bodyPr/>
                     <a:lstStyle/>
                     <a:p>
+                      <a:pPr algn="ctr"/>
                       <a:r>
                         <a:rPr sz="1300" b="1">
                           <a:solidFill>
@@ -8269,12 +8596,17 @@
                       </a:r>
                     </a:p>
                   </a:txBody>
-                  <a:tcPr>
+                  <a:tcPr anchor="ctr">
                     <a:solidFill>
                       <a:srgbClr val="FBE7E4"/>
                     </a:solidFill>
                   </a:tcPr>
                 </a:tc>
+                <a:extLst>
+                  <a:ext uri="{0D108BD9-81ED-4DB2-BD59-A6C34878D82A}">
+                    <a16:rowId xmlns:a16="http://schemas.microsoft.com/office/drawing/2014/main" val="10004"/>
+                  </a:ext>
+                </a:extLst>
               </a:tr>
             </a:tbl>
           </a:graphicData>
@@ -8311,7 +8643,7 @@
               </a:spcAft>
             </a:pPr>
             <a:r>
-              <a:rPr b="1" sz="1600">
+              <a:rPr sz="1600" b="1">
                 <a:solidFill>
                   <a:srgbClr val="C8820E"/>
                 </a:solidFill>
@@ -8319,7 +8651,7 @@
               <a:t>▸  </a:t>
             </a:r>
             <a:r>
-              <a:rPr b="1" sz="1600">
+              <a:rPr sz="1600" b="1">
                 <a:solidFill>
                   <a:srgbClr val="1F4E79"/>
                 </a:solidFill>
@@ -8345,7 +8677,7 @@
               </a:spcAft>
             </a:pPr>
             <a:r>
-              <a:rPr b="1" sz="1600">
+              <a:rPr sz="1600" b="1">
                 <a:solidFill>
                   <a:srgbClr val="C8820E"/>
                 </a:solidFill>
@@ -8353,7 +8685,7 @@
               <a:t>▸  </a:t>
             </a:r>
             <a:r>
-              <a:rPr b="1" sz="1600">
+              <a:rPr sz="1600" b="1">
                 <a:solidFill>
                   <a:srgbClr val="1F4E79"/>
                 </a:solidFill>
@@ -8379,7 +8711,7 @@
               </a:spcAft>
             </a:pPr>
             <a:r>
-              <a:rPr b="1" sz="1600">
+              <a:rPr sz="1600" b="1">
                 <a:solidFill>
                   <a:srgbClr val="C8820E"/>
                 </a:solidFill>
@@ -8387,7 +8719,7 @@
               <a:t>▸  </a:t>
             </a:r>
             <a:r>
-              <a:rPr b="1" sz="1600">
+              <a:rPr sz="1600" b="1">
                 <a:solidFill>
                   <a:srgbClr val="1F4E79"/>
                 </a:solidFill>
@@ -8446,6 +8778,7 @@
           <a:lstStyle/>
           <a:p>
             <a:pPr algn="ctr"/>
+            <a:endParaRPr/>
           </a:p>
         </p:txBody>
       </p:sp>
@@ -8488,7 +8821,7 @@
           </a:fontRef>
         </p:style>
         <p:txBody>
-          <a:bodyPr rtlCol="0" anchor="ctr" wrap="none" lIns="0" rIns="0" tIns="0" bIns="0"/>
+          <a:bodyPr wrap="none" lIns="0" tIns="0" rIns="0" bIns="0" rtlCol="0" anchor="ctr"/>
           <a:lstStyle/>
           <a:p>
             <a:pPr algn="ctr"/>
@@ -8545,6 +8878,7 @@
           <a:lstStyle/>
           <a:p>
             <a:pPr algn="ctr"/>
+            <a:endParaRPr/>
           </a:p>
         </p:txBody>
       </p:sp>
@@ -8624,7 +8958,7 @@
 </file>
 
 <file path=ppt/slides/slide8.xml><?xml version="1.0" encoding="utf-8"?>
-<p:sld xmlns:a="http://schemas.openxmlformats.org/drawingml/2006/main" xmlns:p="http://schemas.openxmlformats.org/presentationml/2006/main" xmlns:r="http://schemas.openxmlformats.org/officeDocument/2006/relationships">
+<p:sld xmlns:a="http://schemas.openxmlformats.org/drawingml/2006/main" xmlns:r="http://schemas.openxmlformats.org/officeDocument/2006/relationships" xmlns:p="http://schemas.openxmlformats.org/presentationml/2006/main">
   <p:cSld>
     <p:spTree>
       <p:nvGrpSpPr>
@@ -8632,7 +8966,14 @@
         <p:cNvGrpSpPr/>
         <p:nvPr/>
       </p:nvGrpSpPr>
-      <p:grpSpPr/>
+      <p:grpSpPr>
+        <a:xfrm>
+          <a:off x="0" y="0"/>
+          <a:ext cx="0" cy="0"/>
+          <a:chOff x="0" y="0"/>
+          <a:chExt cx="0" cy="0"/>
+        </a:xfrm>
+      </p:grpSpPr>
       <p:sp>
         <p:nvSpPr>
           <p:cNvPr id="5" name="Rectangle 4"/>
@@ -8674,6 +9015,7 @@
           <a:lstStyle/>
           <a:p>
             <a:pPr algn="ctr"/>
+            <a:endParaRPr/>
           </a:p>
         </p:txBody>
       </p:sp>
@@ -8739,8 +9081,20 @@
                 <a:tableStyleId>{5C22544A-7EE6-4342-B048-85BDC9FD1C3A}</a:tableStyleId>
               </a:tblPr>
               <a:tblGrid>
-                <a:gridCol w="5532120"/>
-                <a:gridCol w="5532120"/>
+                <a:gridCol w="5532120">
+                  <a:extLst>
+                    <a:ext uri="{9D8B030D-6E8A-4147-A177-3AD203B41FA5}">
+                      <a16:colId xmlns:a16="http://schemas.microsoft.com/office/drawing/2014/main" val="20000"/>
+                    </a:ext>
+                  </a:extLst>
+                </a:gridCol>
+                <a:gridCol w="5532120">
+                  <a:extLst>
+                    <a:ext uri="{9D8B030D-6E8A-4147-A177-3AD203B41FA5}">
+                      <a16:colId xmlns:a16="http://schemas.microsoft.com/office/drawing/2014/main" val="20001"/>
+                    </a:ext>
+                  </a:extLst>
+                </a:gridCol>
               </a:tblGrid>
               <a:tr h="365760">
                 <a:tc>
@@ -8785,6 +9139,11 @@
                     </a:solidFill>
                   </a:tcPr>
                 </a:tc>
+                <a:extLst>
+                  <a:ext uri="{0D108BD9-81ED-4DB2-BD59-A6C34878D82A}">
+                    <a16:rowId xmlns:a16="http://schemas.microsoft.com/office/drawing/2014/main" val="10000"/>
+                  </a:ext>
+                </a:extLst>
               </a:tr>
               <a:tr h="365760">
                 <a:tc>
@@ -8813,6 +9172,11 @@
                   </a:txBody>
                   <a:tcPr/>
                 </a:tc>
+                <a:extLst>
+                  <a:ext uri="{0D108BD9-81ED-4DB2-BD59-A6C34878D82A}">
+                    <a16:rowId xmlns:a16="http://schemas.microsoft.com/office/drawing/2014/main" val="10001"/>
+                  </a:ext>
+                </a:extLst>
               </a:tr>
               <a:tr h="365760">
                 <a:tc>
@@ -8841,6 +9205,11 @@
                   </a:txBody>
                   <a:tcPr/>
                 </a:tc>
+                <a:extLst>
+                  <a:ext uri="{0D108BD9-81ED-4DB2-BD59-A6C34878D82A}">
+                    <a16:rowId xmlns:a16="http://schemas.microsoft.com/office/drawing/2014/main" val="10002"/>
+                  </a:ext>
+                </a:extLst>
               </a:tr>
               <a:tr h="365760">
                 <a:tc>
@@ -8869,6 +9238,11 @@
                   </a:txBody>
                   <a:tcPr/>
                 </a:tc>
+                <a:extLst>
+                  <a:ext uri="{0D108BD9-81ED-4DB2-BD59-A6C34878D82A}">
+                    <a16:rowId xmlns:a16="http://schemas.microsoft.com/office/drawing/2014/main" val="10003"/>
+                  </a:ext>
+                </a:extLst>
               </a:tr>
               <a:tr h="365760">
                 <a:tc>
@@ -8897,6 +9271,11 @@
                   </a:txBody>
                   <a:tcPr/>
                 </a:tc>
+                <a:extLst>
+                  <a:ext uri="{0D108BD9-81ED-4DB2-BD59-A6C34878D82A}">
+                    <a16:rowId xmlns:a16="http://schemas.microsoft.com/office/drawing/2014/main" val="10004"/>
+                  </a:ext>
+                </a:extLst>
               </a:tr>
               <a:tr h="365760">
                 <a:tc>
@@ -8925,6 +9304,11 @@
                   </a:txBody>
                   <a:tcPr/>
                 </a:tc>
+                <a:extLst>
+                  <a:ext uri="{0D108BD9-81ED-4DB2-BD59-A6C34878D82A}">
+                    <a16:rowId xmlns:a16="http://schemas.microsoft.com/office/drawing/2014/main" val="10005"/>
+                  </a:ext>
+                </a:extLst>
               </a:tr>
               <a:tr h="365760">
                 <a:tc>
@@ -8953,6 +9337,11 @@
                   </a:txBody>
                   <a:tcPr/>
                 </a:tc>
+                <a:extLst>
+                  <a:ext uri="{0D108BD9-81ED-4DB2-BD59-A6C34878D82A}">
+                    <a16:rowId xmlns:a16="http://schemas.microsoft.com/office/drawing/2014/main" val="10006"/>
+                  </a:ext>
+                </a:extLst>
               </a:tr>
               <a:tr h="365760">
                 <a:tc>
@@ -8981,6 +9370,11 @@
                   </a:txBody>
                   <a:tcPr/>
                 </a:tc>
+                <a:extLst>
+                  <a:ext uri="{0D108BD9-81ED-4DB2-BD59-A6C34878D82A}">
+                    <a16:rowId xmlns:a16="http://schemas.microsoft.com/office/drawing/2014/main" val="10007"/>
+                  </a:ext>
+                </a:extLst>
               </a:tr>
             </a:tbl>
           </a:graphicData>
@@ -9017,7 +9411,7 @@
               </a:spcAft>
             </a:pPr>
             <a:r>
-              <a:rPr b="1" sz="1600">
+              <a:rPr sz="1600" b="1">
                 <a:solidFill>
                   <a:srgbClr val="C8820E"/>
                 </a:solidFill>
@@ -9025,7 +9419,7 @@
               <a:t>▸  </a:t>
             </a:r>
             <a:r>
-              <a:rPr b="1" sz="1600">
+              <a:rPr sz="1600" b="1">
                 <a:solidFill>
                   <a:srgbClr val="1F4E79"/>
                 </a:solidFill>
@@ -9084,6 +9478,7 @@
           <a:lstStyle/>
           <a:p>
             <a:pPr algn="ctr"/>
+            <a:endParaRPr/>
           </a:p>
         </p:txBody>
       </p:sp>
@@ -9126,7 +9521,7 @@
           </a:fontRef>
         </p:style>
         <p:txBody>
-          <a:bodyPr rtlCol="0" anchor="ctr" wrap="none" lIns="0" rIns="0" tIns="0" bIns="0"/>
+          <a:bodyPr wrap="none" lIns="0" tIns="0" rIns="0" bIns="0" rtlCol="0" anchor="ctr"/>
           <a:lstStyle/>
           <a:p>
             <a:pPr algn="ctr"/>
@@ -9183,6 +9578,7 @@
           <a:lstStyle/>
           <a:p>
             <a:pPr algn="ctr"/>
+            <a:endParaRPr/>
           </a:p>
         </p:txBody>
       </p:sp>
@@ -9262,7 +9658,7 @@
 </file>
 
 <file path=ppt/slides/slide9.xml><?xml version="1.0" encoding="utf-8"?>
-<p:sld xmlns:a="http://schemas.openxmlformats.org/drawingml/2006/main" xmlns:p="http://schemas.openxmlformats.org/presentationml/2006/main" xmlns:r="http://schemas.openxmlformats.org/officeDocument/2006/relationships">
+<p:sld xmlns:a="http://schemas.openxmlformats.org/drawingml/2006/main" xmlns:r="http://schemas.openxmlformats.org/officeDocument/2006/relationships" xmlns:p="http://schemas.openxmlformats.org/presentationml/2006/main">
   <p:cSld>
     <p:spTree>
       <p:nvGrpSpPr>
@@ -9270,7 +9666,14 @@
         <p:cNvGrpSpPr/>
         <p:nvPr/>
       </p:nvGrpSpPr>
-      <p:grpSpPr/>
+      <p:grpSpPr>
+        <a:xfrm>
+          <a:off x="0" y="0"/>
+          <a:ext cx="0" cy="0"/>
+          <a:chOff x="0" y="0"/>
+          <a:chExt cx="0" cy="0"/>
+        </a:xfrm>
+      </p:grpSpPr>
       <p:sp>
         <p:nvSpPr>
           <p:cNvPr id="4" name="Rectangle 3"/>
@@ -9312,6 +9715,7 @@
           <a:lstStyle/>
           <a:p>
             <a:pPr algn="ctr"/>
+            <a:endParaRPr/>
           </a:p>
         </p:txBody>
       </p:sp>
@@ -9389,7 +9793,7 @@
               </a:spcAft>
             </a:pPr>
             <a:r>
-              <a:rPr b="1" sz="1600">
+              <a:rPr sz="1600" b="1">
                 <a:solidFill>
                   <a:srgbClr val="C8820E"/>
                 </a:solidFill>
@@ -9397,7 +9801,7 @@
               <a:t>▸  </a:t>
             </a:r>
             <a:r>
-              <a:rPr b="1" sz="1600">
+              <a:rPr sz="1600" b="1">
                 <a:solidFill>
                   <a:srgbClr val="1F4E79"/>
                 </a:solidFill>
@@ -9423,7 +9827,7 @@
               </a:spcAft>
             </a:pPr>
             <a:r>
-              <a:rPr b="1" sz="1600">
+              <a:rPr sz="1600" b="1">
                 <a:solidFill>
                   <a:srgbClr val="C8820E"/>
                 </a:solidFill>
@@ -9431,7 +9835,7 @@
               <a:t>▸  </a:t>
             </a:r>
             <a:r>
-              <a:rPr b="1" sz="1600">
+              <a:rPr sz="1600" b="1">
                 <a:solidFill>
                   <a:srgbClr val="1F4E79"/>
                 </a:solidFill>
@@ -9457,7 +9861,7 @@
               </a:spcAft>
             </a:pPr>
             <a:r>
-              <a:rPr b="1" sz="1600">
+              <a:rPr sz="1600" b="1">
                 <a:solidFill>
                   <a:srgbClr val="C8820E"/>
                 </a:solidFill>
@@ -9465,7 +9869,7 @@
               <a:t>▸  </a:t>
             </a:r>
             <a:r>
-              <a:rPr b="1" sz="1600">
+              <a:rPr sz="1600" b="1">
                 <a:solidFill>
                   <a:srgbClr val="1F4E79"/>
                 </a:solidFill>
@@ -9491,7 +9895,7 @@
               </a:spcAft>
             </a:pPr>
             <a:r>
-              <a:rPr b="1" sz="1600">
+              <a:rPr sz="1600" b="1">
                 <a:solidFill>
                   <a:srgbClr val="C8820E"/>
                 </a:solidFill>
@@ -9499,7 +9903,7 @@
               <a:t>▸  </a:t>
             </a:r>
             <a:r>
-              <a:rPr b="1" sz="1600">
+              <a:rPr sz="1600" b="1">
                 <a:solidFill>
                   <a:srgbClr val="1F4E79"/>
                 </a:solidFill>
@@ -9525,7 +9929,7 @@
               </a:spcAft>
             </a:pPr>
             <a:r>
-              <a:rPr b="1" sz="1600">
+              <a:rPr sz="1600" b="1">
                 <a:solidFill>
                   <a:srgbClr val="C8820E"/>
                 </a:solidFill>
@@ -9533,7 +9937,7 @@
               <a:t>▸  </a:t>
             </a:r>
             <a:r>
-              <a:rPr b="1" sz="1600">
+              <a:rPr sz="1600" b="1">
                 <a:solidFill>
                   <a:srgbClr val="1F4E79"/>
                 </a:solidFill>
@@ -9559,7 +9963,7 @@
               </a:spcAft>
             </a:pPr>
             <a:r>
-              <a:rPr b="1" sz="1600">
+              <a:rPr sz="1600" b="1">
                 <a:solidFill>
                   <a:srgbClr val="C8820E"/>
                 </a:solidFill>
@@ -9618,6 +10022,7 @@
           <a:lstStyle/>
           <a:p>
             <a:pPr algn="ctr"/>
+            <a:endParaRPr/>
           </a:p>
         </p:txBody>
       </p:sp>
@@ -9660,7 +10065,7 @@
           </a:fontRef>
         </p:style>
         <p:txBody>
-          <a:bodyPr rtlCol="0" anchor="ctr" wrap="none" lIns="0" rIns="0" tIns="0" bIns="0"/>
+          <a:bodyPr wrap="none" lIns="0" tIns="0" rIns="0" bIns="0" rtlCol="0" anchor="ctr"/>
           <a:lstStyle/>
           <a:p>
             <a:pPr algn="ctr"/>
@@ -9717,6 +10122,7 @@
           <a:lstStyle/>
           <a:p>
             <a:pPr algn="ctr"/>
+            <a:endParaRPr/>
           </a:p>
         </p:txBody>
       </p:sp>

</xml_diff>

<commit_message>
Slides: center the Responsible AI table's headers and cells
Last of the five tables -- all now use the same centered header/cell
treatment.

Co-Authored-By: Claude Sonnet 5 <noreply@anthropic.com>
</commit_message>
<xml_diff>
--- a/docs/report/CT3201_Slides.pptx
+++ b/docs/report/CT3201_Slides.pptx
@@ -9102,6 +9102,7 @@
                     <a:bodyPr/>
                     <a:lstStyle/>
                     <a:p>
+                      <a:pPr algn="ctr"/>
                       <a:r>
                         <a:rPr sz="1300" b="1">
                           <a:solidFill>
@@ -9112,7 +9113,7 @@
                       </a:r>
                     </a:p>
                   </a:txBody>
-                  <a:tcPr>
+                  <a:tcPr anchor="ctr">
                     <a:solidFill>
                       <a:srgbClr val="1F4E79"/>
                     </a:solidFill>
@@ -9123,6 +9124,7 @@
                     <a:bodyPr/>
                     <a:lstStyle/>
                     <a:p>
+                      <a:pPr algn="ctr"/>
                       <a:r>
                         <a:rPr sz="1300" b="1">
                           <a:solidFill>
@@ -9133,7 +9135,7 @@
                       </a:r>
                     </a:p>
                   </a:txBody>
-                  <a:tcPr>
+                  <a:tcPr anchor="ctr">
                     <a:solidFill>
                       <a:srgbClr val="1F4E79"/>
                     </a:solidFill>
@@ -9151,26 +9153,28 @@
                     <a:bodyPr/>
                     <a:lstStyle/>
                     <a:p>
+                      <a:pPr algn="ctr"/>
                       <a:r>
                         <a:rPr sz="1300"/>
                         <a:t>Fairness</a:t>
                       </a:r>
                     </a:p>
                   </a:txBody>
-                  <a:tcPr/>
+                  <a:tcPr anchor="ctr"/>
                 </a:tc>
                 <a:tc>
                   <a:txBody>
                     <a:bodyPr/>
                     <a:lstStyle/>
                     <a:p>
+                      <a:pPr algn="ctr"/>
                       <a:r>
                         <a:rPr sz="1300"/>
                         <a:t>In-game the AI agent takes hazard damage &amp; has the same vision as the human - fair by construction</a:t>
                       </a:r>
                     </a:p>
                   </a:txBody>
-                  <a:tcPr/>
+                  <a:tcPr anchor="ctr"/>
                 </a:tc>
                 <a:extLst>
                   <a:ext uri="{0D108BD9-81ED-4DB2-BD59-A6C34878D82A}">
@@ -9184,26 +9188,28 @@
                     <a:bodyPr/>
                     <a:lstStyle/>
                     <a:p>
+                      <a:pPr algn="ctr"/>
                       <a:r>
                         <a:rPr sz="1300"/>
                         <a:t>Bias</a:t>
                       </a:r>
                     </a:p>
                   </a:txBody>
-                  <a:tcPr/>
+                  <a:tcPr anchor="ctr"/>
                 </a:tc>
                 <a:tc>
                   <a:txBody>
                     <a:bodyPr/>
                     <a:lstStyle/>
                     <a:p>
+                      <a:pPr algn="ctr"/>
                       <a:r>
                         <a:rPr sz="1300"/>
                         <a:t>Goal selection is greedy nearest-first: no triage, no notion of who is most at risk</a:t>
                       </a:r>
                     </a:p>
                   </a:txBody>
-                  <a:tcPr/>
+                  <a:tcPr anchor="ctr"/>
                 </a:tc>
                 <a:extLst>
                   <a:ext uri="{0D108BD9-81ED-4DB2-BD59-A6C34878D82A}">
@@ -9217,26 +9223,28 @@
                     <a:bodyPr/>
                     <a:lstStyle/>
                     <a:p>
+                      <a:pPr algn="ctr"/>
                       <a:r>
                         <a:rPr sz="1300"/>
                         <a:t>Transparency</a:t>
                       </a:r>
                     </a:p>
                   </a:txBody>
-                  <a:tcPr/>
+                  <a:tcPr anchor="ctr"/>
                 </a:tc>
                 <a:tc>
                   <a:txBody>
                     <a:bodyPr/>
                     <a:lstStyle/>
                     <a:p>
+                      <a:pPr algn="ctr"/>
                       <a:r>
                         <a:rPr sz="1300"/>
                         <a:t>The agent DRAWS its planned route + walked trail - you can see what it decided and why it changed</a:t>
                       </a:r>
                     </a:p>
                   </a:txBody>
-                  <a:tcPr/>
+                  <a:tcPr anchor="ctr"/>
                 </a:tc>
                 <a:extLst>
                   <a:ext uri="{0D108BD9-81ED-4DB2-BD59-A6C34878D82A}">
@@ -9250,26 +9258,28 @@
                     <a:bodyPr/>
                     <a:lstStyle/>
                     <a:p>
+                      <a:pPr algn="ctr"/>
                       <a:r>
                         <a:rPr sz="1300"/>
                         <a:t>Privacy</a:t>
                       </a:r>
                     </a:p>
                   </a:txBody>
-                  <a:tcPr/>
+                  <a:tcPr anchor="ctr"/>
                 </a:tc>
                 <a:tc>
                   <a:txBody>
                     <a:bodyPr/>
                     <a:lstStyle/>
                     <a:p>
+                      <a:pPr algn="ctr"/>
                       <a:r>
                         <a:rPr sz="1300"/>
                         <a:t>A real occupant-locator needs live location data on people - sensitive, must be minimised</a:t>
                       </a:r>
                     </a:p>
                   </a:txBody>
-                  <a:tcPr/>
+                  <a:tcPr anchor="ctr"/>
                 </a:tc>
                 <a:extLst>
                   <a:ext uri="{0D108BD9-81ED-4DB2-BD59-A6C34878D82A}">
@@ -9283,26 +9293,28 @@
                     <a:bodyPr/>
                     <a:lstStyle/>
                     <a:p>
+                      <a:pPr algn="ctr"/>
                       <a:r>
                         <a:rPr sz="1300"/>
                         <a:t>Security</a:t>
                       </a:r>
                     </a:p>
                   </a:txBody>
-                  <a:tcPr/>
+                  <a:tcPr anchor="ctr"/>
                 </a:tc>
                 <a:tc>
                   <a:txBody>
                     <a:bodyPr/>
                     <a:lstStyle/>
                     <a:p>
+                      <a:pPr algn="ctr"/>
                       <a:r>
                         <a:rPr sz="1300"/>
                         <a:t>The agent trusts its hazard map; a spoofed feed could steer it (and followers) into a hazard</a:t>
                       </a:r>
                     </a:p>
                   </a:txBody>
-                  <a:tcPr/>
+                  <a:tcPr anchor="ctr"/>
                 </a:tc>
                 <a:extLst>
                   <a:ext uri="{0D108BD9-81ED-4DB2-BD59-A6C34878D82A}">
@@ -9316,26 +9328,28 @@
                     <a:bodyPr/>
                     <a:lstStyle/>
                     <a:p>
+                      <a:pPr algn="ctr"/>
                       <a:r>
                         <a:rPr sz="1300"/>
                         <a:t>Accountability</a:t>
                       </a:r>
                     </a:p>
                   </a:txBody>
-                  <a:tcPr/>
+                  <a:tcPr anchor="ctr"/>
                 </a:tc>
                 <a:tc>
                   <a:txBody>
                     <a:bodyPr/>
                     <a:lstStyle/>
                     <a:p>
+                      <a:pPr algn="ctr"/>
                       <a:r>
                         <a:rPr sz="1300"/>
                         <a:t>If it leads someone into a collapse - operator? developer? sensor vendor? needs an audit log</a:t>
                       </a:r>
                     </a:p>
                   </a:txBody>
-                  <a:tcPr/>
+                  <a:tcPr anchor="ctr"/>
                 </a:tc>
                 <a:extLst>
                   <a:ext uri="{0D108BD9-81ED-4DB2-BD59-A6C34878D82A}">
@@ -9349,26 +9363,28 @@
                     <a:bodyPr/>
                     <a:lstStyle/>
                     <a:p>
+                      <a:pPr algn="ctr"/>
                       <a:r>
                         <a:rPr sz="1300"/>
                         <a:t>Human oversight</a:t>
                       </a:r>
                     </a:p>
                   </a:txBody>
-                  <a:tcPr/>
+                  <a:tcPr anchor="ctr"/>
                 </a:tc>
                 <a:tc>
                   <a:txBody>
                     <a:bodyPr/>
                     <a:lstStyle/>
                     <a:p>
+                      <a:pPr algn="ctr"/>
                       <a:r>
                         <a:rPr sz="1300"/>
                         <a:t>It's decision-support, not an autonomous replacement for firefighters - the right posture</a:t>
                       </a:r>
                     </a:p>
                   </a:txBody>
-                  <a:tcPr/>
+                  <a:tcPr anchor="ctr"/>
                 </a:tc>
                 <a:extLst>
                   <a:ext uri="{0D108BD9-81ED-4DB2-BD59-A6C34878D82A}">

</xml_diff>

<commit_message>
Slides: bring slide 10 back to 16pt with tighter spacing to fit
Matches the font size used on every other content slide now (was
13pt). Fits by reducing space-after (12pt -> 4pt) and line spacing
(1.08 -> 1.0) instead of shrinking the font, after confirming at
default spacing it overflowed past the footer.

Co-Authored-By: Claude Sonnet 5 <noreply@anthropic.com>
</commit_message>
<xml_diff>
--- a/docs/report/CT3201_Slides.pptx
+++ b/docs/report/CT3201_Slides.pptx
@@ -3602,11 +3602,11 @@
                 <a:spcPct val="100000"/>
               </a:lnSpc>
               <a:spcAft>
-                <a:spcPts val="600"/>
+                <a:spcPts val="400"/>
               </a:spcAft>
             </a:pPr>
             <a:r>
-              <a:rPr sz="1300" b="1">
+              <a:rPr sz="1600" b="1">
                 <a:solidFill>
                   <a:srgbClr val="C8820E"/>
                 </a:solidFill>
@@ -3614,7 +3614,7 @@
               <a:t>▸  </a:t>
             </a:r>
             <a:r>
-              <a:rPr sz="1300" b="1">
+              <a:rPr sz="1600" b="1">
                 <a:solidFill>
                   <a:srgbClr val="1F4E79"/>
                 </a:solidFill>
@@ -3622,7 +3622,7 @@
               <a:t>AI helped: </a:t>
             </a:r>
             <a:r>
-              <a:rPr sz="1300">
+              <a:rPr sz="1600">
                 <a:solidFill>
                   <a:srgbClr val="2B2B2B"/>
                 </a:solidFill>
@@ -3636,11 +3636,11 @@
                 <a:spcPct val="100000"/>
               </a:lnSpc>
               <a:spcAft>
-                <a:spcPts val="600"/>
+                <a:spcPts val="400"/>
               </a:spcAft>
             </a:pPr>
             <a:r>
-              <a:rPr sz="1300" b="1">
+              <a:rPr sz="1600" b="1">
                 <a:solidFill>
                   <a:srgbClr val="C8820E"/>
                 </a:solidFill>
@@ -3648,7 +3648,7 @@
               <a:t>▸  </a:t>
             </a:r>
             <a:r>
-              <a:rPr sz="1300" b="1">
+              <a:rPr sz="1600" b="1">
                 <a:solidFill>
                   <a:srgbClr val="1F4E79"/>
                 </a:solidFill>
@@ -3656,7 +3656,7 @@
               <a:t>AI got wrong: </a:t>
             </a:r>
             <a:r>
-              <a:rPr sz="1300">
+              <a:rPr sz="1600">
                 <a:solidFill>
                   <a:srgbClr val="2B2B2B"/>
                 </a:solidFill>
@@ -3670,11 +3670,11 @@
                 <a:spcPct val="100000"/>
               </a:lnSpc>
               <a:spcAft>
-                <a:spcPts val="600"/>
+                <a:spcPts val="400"/>
               </a:spcAft>
             </a:pPr>
             <a:r>
-              <a:rPr sz="1300" b="1">
+              <a:rPr sz="1600" b="1">
                 <a:solidFill>
                   <a:srgbClr val="C8820E"/>
                 </a:solidFill>
@@ -3682,7 +3682,7 @@
               <a:t>▸  </a:t>
             </a:r>
             <a:r>
-              <a:rPr sz="1300" b="1">
+              <a:rPr sz="1600" b="1">
                 <a:solidFill>
                   <a:srgbClr val="1F4E79"/>
                 </a:solidFill>
@@ -3690,7 +3690,7 @@
               <a:t>Accepted: </a:t>
             </a:r>
             <a:r>
-              <a:rPr sz="1300">
+              <a:rPr sz="1600">
                 <a:solidFill>
                   <a:srgbClr val="2B2B2B"/>
                 </a:solidFill>
@@ -3704,11 +3704,11 @@
                 <a:spcPct val="100000"/>
               </a:lnSpc>
               <a:spcAft>
-                <a:spcPts val="600"/>
+                <a:spcPts val="400"/>
               </a:spcAft>
             </a:pPr>
             <a:r>
-              <a:rPr sz="1300" b="1">
+              <a:rPr sz="1600" b="1">
                 <a:solidFill>
                   <a:srgbClr val="C8820E"/>
                 </a:solidFill>
@@ -3716,7 +3716,7 @@
               <a:t>▸  </a:t>
             </a:r>
             <a:r>
-              <a:rPr sz="1300" b="1">
+              <a:rPr sz="1600" b="1">
                 <a:solidFill>
                   <a:srgbClr val="1F4E79"/>
                 </a:solidFill>
@@ -3724,7 +3724,7 @@
               <a:t>Rejected: </a:t>
             </a:r>
             <a:r>
-              <a:rPr sz="1300">
+              <a:rPr sz="1600">
                 <a:solidFill>
                   <a:srgbClr val="2B2B2B"/>
                 </a:solidFill>
@@ -3738,11 +3738,11 @@
                 <a:spcPct val="100000"/>
               </a:lnSpc>
               <a:spcAft>
-                <a:spcPts val="600"/>
+                <a:spcPts val="400"/>
               </a:spcAft>
             </a:pPr>
             <a:r>
-              <a:rPr sz="1300" b="1">
+              <a:rPr sz="1600" b="1">
                 <a:solidFill>
                   <a:srgbClr val="C8820E"/>
                 </a:solidFill>
@@ -3750,7 +3750,7 @@
               <a:t>▸  </a:t>
             </a:r>
             <a:r>
-              <a:rPr sz="1300" b="1">
+              <a:rPr sz="1600" b="1">
                 <a:solidFill>
                   <a:srgbClr val="1F4E79"/>
                 </a:solidFill>
@@ -3758,7 +3758,7 @@
               <a:t>Verified via: </a:t>
             </a:r>
             <a:r>
-              <a:rPr sz="1300">
+              <a:rPr sz="1600">
                 <a:solidFill>
                   <a:srgbClr val="2B2B2B"/>
                 </a:solidFill>
@@ -3772,11 +3772,11 @@
                 <a:spcPct val="100000"/>
               </a:lnSpc>
               <a:spcAft>
-                <a:spcPts val="600"/>
+                <a:spcPts val="400"/>
               </a:spcAft>
             </a:pPr>
             <a:r>
-              <a:rPr sz="1300" b="1">
+              <a:rPr sz="1600" b="1">
                 <a:solidFill>
                   <a:srgbClr val="C8820E"/>
                 </a:solidFill>
@@ -3784,7 +3784,7 @@
               <a:t>▸  </a:t>
             </a:r>
             <a:r>
-              <a:rPr sz="1300" b="1">
+              <a:rPr sz="1600" b="1">
                 <a:solidFill>
                   <a:srgbClr val="1F4E79"/>
                 </a:solidFill>
@@ -3792,7 +3792,7 @@
               <a:t>Human judgement was necessary for: </a:t>
             </a:r>
             <a:r>
-              <a:rPr sz="1300">
+              <a:rPr sz="1600">
                 <a:solidFill>
                   <a:srgbClr val="2B2B2B"/>
                 </a:solidFill>
@@ -3806,11 +3806,11 @@
                 <a:spcPct val="100000"/>
               </a:lnSpc>
               <a:spcAft>
-                <a:spcPts val="600"/>
+                <a:spcPts val="400"/>
               </a:spcAft>
             </a:pPr>
             <a:r>
-              <a:rPr sz="1300" b="1">
+              <a:rPr sz="1600" b="1">
                 <a:solidFill>
                   <a:srgbClr val="C8820E"/>
                 </a:solidFill>
@@ -3818,7 +3818,7 @@
               <a:t>▸  </a:t>
             </a:r>
             <a:r>
-              <a:rPr sz="1300" b="1">
+              <a:rPr sz="1600" b="1">
                 <a:solidFill>
                   <a:srgbClr val="1F4E79"/>
                 </a:solidFill>
@@ -3826,7 +3826,7 @@
               <a:t>If we'd blindly followed AI: </a:t>
             </a:r>
             <a:r>
-              <a:rPr sz="1300">
+              <a:rPr sz="1600">
                 <a:solidFill>
                   <a:srgbClr val="2B2B2B"/>
                 </a:solidFill>
@@ -3840,11 +3840,11 @@
                 <a:spcPct val="100000"/>
               </a:lnSpc>
               <a:spcAft>
-                <a:spcPts val="600"/>
+                <a:spcPts val="400"/>
               </a:spcAft>
             </a:pPr>
             <a:r>
-              <a:rPr sz="1300" b="1">
+              <a:rPr sz="1600" b="1">
                 <a:solidFill>
                   <a:srgbClr val="C8820E"/>
                 </a:solidFill>
@@ -3852,7 +3852,7 @@
               <a:t>▸  </a:t>
             </a:r>
             <a:r>
-              <a:rPr sz="1300" b="1">
+              <a:rPr sz="1600" b="1">
                 <a:solidFill>
                   <a:srgbClr val="1F4E79"/>
                 </a:solidFill>
@@ -3860,7 +3860,7 @@
               <a:t>Learned: </a:t>
             </a:r>
             <a:r>
-              <a:rPr sz="1300">
+              <a:rPr sz="1600">
                 <a:solidFill>
                   <a:srgbClr val="2B2B2B"/>
                 </a:solidFill>

</xml_diff>

<commit_message>
Slides: strengthen evidence, add bookend visuals, full course name in footer
- Slide 7: added the systematic result (Greedy costlier than A* in 98
  of 150 situations across every stage/layout/fire time) alongside the
  single-example evidence, matching the report's strongest evidence
  instead of only the illustrative one.
- Slide 1: added the game's actual title-screen image to the empty
  space between the header and the team/problem bullets.
- Slide 11: added the "AI cleared the stage" results-screen image as a
  closing visual instead of ending on bare text.
- Footer: spelled out the course's full name ("CT3201 Introduction to
  Artificial Intelligence Mini Project") on all 11 slides.

Co-Authored-By: Claude Sonnet 5 <noreply@anthropic.com>
</commit_message>
<xml_diff>
--- a/docs/report/CT3201_Slides.pptx
+++ b/docs/report/CT3201_Slides.pptx
@@ -3423,7 +3423,7 @@
                   <a:srgbClr val="9A9A9A"/>
                 </a:solidFill>
               </a:rPr>
-              <a:t>Pyro Pete: Emergency Evacuation  ·  CT3201 Mini Project</a:t>
+              <a:t>Pyro Pete: Emergency Evacuation  ·  CT3201 Introduction to Artificial Intelligence Mini Project</a:t>
             </a:r>
           </a:p>
         </p:txBody>
@@ -3462,6 +3462,30 @@
           </a:p>
         </p:txBody>
       </p:sp>
+      <p:pic>
+        <p:nvPicPr>
+          <p:cNvPr id="9" name="Picture 8" descr="crop_title.png"/>
+          <p:cNvPicPr>
+            <a:picLocks noChangeAspect="1"/>
+          </p:cNvPicPr>
+          <p:nvPr/>
+        </p:nvPicPr>
+        <p:blipFill>
+          <a:blip r:embed="rId2"/>
+          <a:stretch>
+            <a:fillRect/>
+          </a:stretch>
+        </p:blipFill>
+        <p:spPr>
+          <a:xfrm>
+            <a:off x="4827270" y="1188720"/>
+            <a:ext cx="2537460" cy="1691640"/>
+          </a:xfrm>
+          <a:prstGeom prst="rect">
+            <a:avLst/>
+          </a:prstGeom>
+        </p:spPr>
+      </p:pic>
     </p:spTree>
   </p:cSld>
   <p:clrMapOvr>
@@ -4043,7 +4067,7 @@
                   <a:srgbClr val="9A9A9A"/>
                 </a:solidFill>
               </a:rPr>
-              <a:t>Pyro Pete: Emergency Evacuation  ·  CT3201 Mini Project</a:t>
+              <a:t>Pyro Pete: Emergency Evacuation  ·  CT3201 Introduction to Artificial Intelligence Mini Project</a:t>
             </a:r>
           </a:p>
         </p:txBody>
@@ -4537,7 +4561,7 @@
                   <a:srgbClr val="9A9A9A"/>
                 </a:solidFill>
               </a:rPr>
-              <a:t>Pyro Pete: Emergency Evacuation  ·  CT3201 Mini Project</a:t>
+              <a:t>Pyro Pete: Emergency Evacuation  ·  CT3201 Introduction to Artificial Intelligence Mini Project</a:t>
             </a:r>
           </a:p>
         </p:txBody>
@@ -4576,6 +4600,30 @@
           </a:p>
         </p:txBody>
       </p:sp>
+      <p:pic>
+        <p:nvPicPr>
+          <p:cNvPr id="10" name="Picture 9" descr="crop_results.png"/>
+          <p:cNvPicPr>
+            <a:picLocks noChangeAspect="1"/>
+          </p:cNvPicPr>
+          <p:nvPr/>
+        </p:nvPicPr>
+        <p:blipFill>
+          <a:blip r:embed="rId2"/>
+          <a:stretch>
+            <a:fillRect/>
+          </a:stretch>
+        </p:blipFill>
+        <p:spPr>
+          <a:xfrm>
+            <a:off x="4861560" y="4754880"/>
+            <a:ext cx="2468880" cy="1645920"/>
+          </a:xfrm>
+          <a:prstGeom prst="rect">
+            <a:avLst/>
+          </a:prstGeom>
+        </p:spPr>
+      </p:pic>
     </p:spTree>
   </p:cSld>
   <p:clrMapOvr>
@@ -5089,7 +5137,7 @@
                   <a:srgbClr val="9A9A9A"/>
                 </a:solidFill>
               </a:rPr>
-              <a:t>Pyro Pete: Emergency Evacuation  ·  CT3201 Mini Project</a:t>
+              <a:t>Pyro Pete: Emergency Evacuation  ·  CT3201 Introduction to Artificial Intelligence Mini Project</a:t>
             </a:r>
           </a:p>
         </p:txBody>
@@ -5798,7 +5846,7 @@
                   <a:srgbClr val="9A9A9A"/>
                 </a:solidFill>
               </a:rPr>
-              <a:t>Pyro Pete: Emergency Evacuation  ·  CT3201 Mini Project</a:t>
+              <a:t>Pyro Pete: Emergency Evacuation  ·  CT3201 Introduction to Artificial Intelligence Mini Project</a:t>
             </a:r>
           </a:p>
         </p:txBody>
@@ -6437,7 +6485,7 @@
                   <a:srgbClr val="9A9A9A"/>
                 </a:solidFill>
               </a:rPr>
-              <a:t>Pyro Pete: Emergency Evacuation  ·  CT3201 Mini Project</a:t>
+              <a:t>Pyro Pete: Emergency Evacuation  ·  CT3201 Introduction to Artificial Intelligence Mini Project</a:t>
             </a:r>
           </a:p>
         </p:txBody>
@@ -7318,7 +7366,7 @@
                   <a:srgbClr val="9A9A9A"/>
                 </a:solidFill>
               </a:rPr>
-              <a:t>Pyro Pete: Emergency Evacuation  ·  CT3201 Mini Project</a:t>
+              <a:t>Pyro Pete: Emergency Evacuation  ·  CT3201 Introduction to Artificial Intelligence Mini Project</a:t>
             </a:r>
           </a:p>
         </p:txBody>
@@ -7884,7 +7932,7 @@
                   <a:srgbClr val="9A9A9A"/>
                 </a:solidFill>
               </a:rPr>
-              <a:t>Pyro Pete: Emergency Evacuation  ·  CT3201 Mini Project</a:t>
+              <a:t>Pyro Pete: Emergency Evacuation  ·  CT3201 Introduction to Artificial Intelligence Mini Project</a:t>
             </a:r>
           </a:p>
         </p:txBody>
@@ -8698,7 +8746,7 @@
                   <a:srgbClr val="2B2B2B"/>
                 </a:solidFill>
               </a:rPr>
-              <a:t>BFS route = 2.3x the cost through 9 burning tiles. A* = Dijkstra cost, fewer expansions -&gt; optimal AND fast.</a:t>
+              <a:t>BFS route = 2.3x the cost through 9 burning tiles. A* = Dijkstra cost, fewer expansions -&gt; optimal AND fast. Tested systematically (10 stages x 3 layouts x 5 fire times): Greedy costlier than A* in 98 of 150 situations, never cheaper.</a:t>
             </a:r>
           </a:p>
           <a:p>
@@ -8910,7 +8958,7 @@
                   <a:srgbClr val="9A9A9A"/>
                 </a:solidFill>
               </a:rPr>
-              <a:t>Pyro Pete: Emergency Evacuation  ·  CT3201 Mini Project</a:t>
+              <a:t>Pyro Pete: Emergency Evacuation  ·  CT3201 Introduction to Artificial Intelligence Mini Project</a:t>
             </a:r>
           </a:p>
         </p:txBody>
@@ -9626,7 +9674,7 @@
                   <a:srgbClr val="9A9A9A"/>
                 </a:solidFill>
               </a:rPr>
-              <a:t>Pyro Pete: Emergency Evacuation  ·  CT3201 Mini Project</a:t>
+              <a:t>Pyro Pete: Emergency Evacuation  ·  CT3201 Introduction to Artificial Intelligence Mini Project</a:t>
             </a:r>
           </a:p>
         </p:txBody>
@@ -10170,7 +10218,7 @@
                   <a:srgbClr val="9A9A9A"/>
                 </a:solidFill>
               </a:rPr>
-              <a:t>Pyro Pete: Emergency Evacuation  ·  CT3201 Mini Project</a:t>
+              <a:t>Pyro Pete: Emergency Evacuation  ·  CT3201 Introduction to Artificial Intelligence Mini Project</a:t>
             </a:r>
           </a:p>
         </p:txBody>

</xml_diff>

<commit_message>
Slides: fill remaining empty space on the title and exploration slides
- Slide 1: enlarged the title-screen image into a proper hero visual,
  and gave the three bullets more size (16pt -> 18pt) and spacing to
  balance against it.
- Slide 4: grew the table's row heights and font (13pt -> 15pt) to use
  the space down to the footer instead of leaving it mostly empty --
  same fix already applied to the Responsible AI table.

Co-Authored-By: Claude Sonnet 5 <noreply@anthropic.com>
</commit_message>
<xml_diff>
--- a/docs/report/CT3201_Slides.pptx
+++ b/docs/report/CT3201_Slides.pptx
@@ -3196,7 +3196,7 @@
         </p:nvSpPr>
         <p:spPr>
           <a:xfrm>
-            <a:off x="640080" y="2926080"/>
+            <a:off x="640080" y="3749039"/>
             <a:ext cx="10972800" cy="5029200"/>
           </a:xfrm>
           <a:prstGeom prst="rect">
@@ -3212,14 +3212,14 @@
           <a:p>
             <a:pPr>
               <a:lnSpc>
-                <a:spcPct val="108000"/>
+                <a:spcPct val="115000"/>
               </a:lnSpc>
               <a:spcAft>
-                <a:spcPts val="1200"/>
+                <a:spcPts val="2200"/>
               </a:spcAft>
             </a:pPr>
             <a:r>
-              <a:rPr sz="1600" b="1">
+              <a:rPr sz="1800" b="1">
                 <a:solidFill>
                   <a:srgbClr val="C8820E"/>
                 </a:solidFill>
@@ -3227,7 +3227,7 @@
               <a:t>▸  </a:t>
             </a:r>
             <a:r>
-              <a:rPr sz="1600" b="1">
+              <a:rPr sz="1800" b="1">
                 <a:solidFill>
                   <a:srgbClr val="1F4E79"/>
                 </a:solidFill>
@@ -3235,7 +3235,7 @@
               <a:t>Team: </a:t>
             </a:r>
             <a:r>
-              <a:rPr sz="1600">
+              <a:rPr sz="1800">
                 <a:solidFill>
                   <a:srgbClr val="2B2B2B"/>
                 </a:solidFill>
@@ -3246,14 +3246,14 @@
           <a:p>
             <a:pPr>
               <a:lnSpc>
-                <a:spcPct val="108000"/>
+                <a:spcPct val="115000"/>
               </a:lnSpc>
               <a:spcAft>
-                <a:spcPts val="1200"/>
+                <a:spcPts val="2200"/>
               </a:spcAft>
             </a:pPr>
             <a:r>
-              <a:rPr sz="1600" b="1">
+              <a:rPr sz="1800" b="1">
                 <a:solidFill>
                   <a:srgbClr val="C8820E"/>
                 </a:solidFill>
@@ -3261,7 +3261,7 @@
               <a:t>▸  </a:t>
             </a:r>
             <a:r>
-              <a:rPr sz="1600" b="1">
+              <a:rPr sz="1800" b="1">
                 <a:solidFill>
                   <a:srgbClr val="1F4E79"/>
                 </a:solidFill>
@@ -3269,7 +3269,7 @@
               <a:t>Problem area: </a:t>
             </a:r>
             <a:r>
-              <a:rPr sz="1600">
+              <a:rPr sz="1800">
                 <a:solidFill>
                   <a:srgbClr val="2B2B2B"/>
                 </a:solidFill>
@@ -3280,14 +3280,14 @@
           <a:p>
             <a:pPr>
               <a:lnSpc>
-                <a:spcPct val="108000"/>
+                <a:spcPct val="115000"/>
               </a:lnSpc>
               <a:spcAft>
-                <a:spcPts val="1200"/>
+                <a:spcPts val="2200"/>
               </a:spcAft>
             </a:pPr>
             <a:r>
-              <a:rPr sz="1600" b="1">
+              <a:rPr sz="1800" b="1">
                 <a:solidFill>
                   <a:srgbClr val="C8820E"/>
                 </a:solidFill>
@@ -3295,7 +3295,7 @@
               <a:t>▸  </a:t>
             </a:r>
             <a:r>
-              <a:rPr sz="1600">
+              <a:rPr sz="1800">
                 <a:solidFill>
                   <a:srgbClr val="2B2B2B"/>
                 </a:solidFill>
@@ -3478,8 +3478,8 @@
         </p:blipFill>
         <p:spPr>
           <a:xfrm>
-            <a:off x="4827270" y="1188720"/>
-            <a:ext cx="2537460" cy="1691640"/>
+            <a:off x="4312920" y="1143000"/>
+            <a:ext cx="3566160" cy="2377440"/>
           </a:xfrm>
           <a:prstGeom prst="rect">
             <a:avLst/>
@@ -6008,7 +6008,7 @@
         </p:nvGraphicFramePr>
         <p:xfrm>
           <a:off x="548640" y="1371600"/>
-          <a:ext cx="11064240" cy="2072640"/>
+          <a:ext cx="11064240" cy="3931920"/>
         </p:xfrm>
         <a:graphic>
           <a:graphicData uri="http://schemas.openxmlformats.org/drawingml/2006/table">
@@ -6039,7 +6039,7 @@
                   </a:extLst>
                 </a:gridCol>
               </a:tblGrid>
-              <a:tr h="365760">
+              <a:tr h="786384">
                 <a:tc>
                   <a:txBody>
                     <a:bodyPr/>
@@ -6047,7 +6047,7 @@
                     <a:p>
                       <a:pPr algn="ctr"/>
                       <a:r>
-                        <a:rPr sz="1300" b="1">
+                        <a:rPr sz="1500" b="1">
                           <a:solidFill>
                             <a:srgbClr val="FFFFFF"/>
                           </a:solidFill>
@@ -6069,7 +6069,7 @@
                     <a:p>
                       <a:pPr algn="ctr"/>
                       <a:r>
-                        <a:rPr sz="1300" b="1">
+                        <a:rPr sz="1500" b="1">
                           <a:solidFill>
                             <a:srgbClr val="FFFFFF"/>
                           </a:solidFill>
@@ -6091,7 +6091,7 @@
                     <a:p>
                       <a:pPr algn="ctr"/>
                       <a:r>
-                        <a:rPr sz="1300" b="1">
+                        <a:rPr sz="1500" b="1">
                           <a:solidFill>
                             <a:srgbClr val="FFFFFF"/>
                           </a:solidFill>
@@ -6112,7 +6112,7 @@
                   </a:ext>
                 </a:extLst>
               </a:tr>
-              <a:tr h="365760">
+              <a:tr h="786384">
                 <a:tc>
                   <a:txBody>
                     <a:bodyPr/>
@@ -6120,7 +6120,7 @@
                     <a:p>
                       <a:pPr algn="ctr"/>
                       <a:r>
-                        <a:rPr sz="1300"/>
+                        <a:rPr sz="1500"/>
                         <a:t>Challenge BFS-with-fire-as-a-wall</a:t>
                       </a:r>
                     </a:p>
@@ -6134,7 +6134,7 @@
                     <a:p>
                       <a:pPr algn="ctr"/>
                       <a:r>
-                        <a:rPr sz="1300"/>
+                        <a:rPr sz="1500"/>
                         <a:t>BFS minimises tiles, not danger - it walks through fire to save a step</a:t>
                       </a:r>
                     </a:p>
@@ -6148,7 +6148,7 @@
                     <a:p>
                       <a:pPr algn="ctr"/>
                       <a:r>
-                        <a:rPr sz="1300"/>
+                        <a:rPr sz="1500"/>
                         <a:t>Treat hazards as weighted costs; use cost-aware search</a:t>
                       </a:r>
                     </a:p>
@@ -6161,7 +6161,7 @@
                   </a:ext>
                 </a:extLst>
               </a:tr>
-              <a:tr h="365760">
+              <a:tr h="786384">
                 <a:tc>
                   <a:txBody>
                     <a:bodyPr/>
@@ -6169,7 +6169,7 @@
                     <a:p>
                       <a:pPr algn="ctr"/>
                       <a:r>
-                        <a:rPr sz="1300"/>
+                        <a:rPr sz="1500"/>
                         <a:t>Suggest alternative search strategies</a:t>
                       </a:r>
                     </a:p>
@@ -6183,7 +6183,7 @@
                     <a:p>
                       <a:pPr algn="ctr"/>
                       <a:r>
-                        <a:rPr sz="1300"/>
+                        <a:rPr sz="1500"/>
                         <a:t>Dijkstra / A* / Greedy and their trade-offs</a:t>
                       </a:r>
                     </a:p>
@@ -6197,7 +6197,7 @@
                     <a:p>
                       <a:pPr algn="ctr"/>
                       <a:r>
-                        <a:rPr sz="1300"/>
+                        <a:rPr sz="1500"/>
                         <a:t>Implement all four to compare on our own map</a:t>
                       </a:r>
                     </a:p>
@@ -6210,7 +6210,7 @@
                   </a:ext>
                 </a:extLst>
               </a:tr>
-              <a:tr h="365760">
+              <a:tr h="786384">
                 <a:tc>
                   <a:txBody>
                     <a:bodyPr/>
@@ -6218,7 +6218,7 @@
                     <a:p>
                       <a:pPr algn="ctr"/>
                       <a:r>
-                        <a:rPr sz="1300"/>
+                        <a:rPr sz="1500"/>
                         <a:t>Point out assumptions</a:t>
                       </a:r>
                     </a:p>
@@ -6232,7 +6232,7 @@
                     <a:p>
                       <a:pPr algn="ctr"/>
                       <a:r>
-                        <a:rPr sz="1300"/>
+                        <a:rPr sz="1500"/>
                         <a:t>We assumed a full map of occupant locations</a:t>
                       </a:r>
                     </a:p>
@@ -6246,7 +6246,7 @@
                     <a:p>
                       <a:pPr algn="ctr"/>
                       <a:r>
-                        <a:rPr sz="1300"/>
+                        <a:rPr sz="1500"/>
                         <a:t>Add partial observability + frontier exploration</a:t>
                       </a:r>
                     </a:p>
@@ -6259,7 +6259,7 @@
                   </a:ext>
                 </a:extLst>
               </a:tr>
-              <a:tr h="365760">
+              <a:tr h="786384">
                 <a:tc>
                   <a:txBody>
                     <a:bodyPr/>
@@ -6267,7 +6267,7 @@
                     <a:p>
                       <a:pPr algn="ctr"/>
                       <a:r>
-                        <a:rPr sz="1300"/>
+                        <a:rPr sz="1500"/>
                         <a:t>What could make it fail?</a:t>
                       </a:r>
                     </a:p>
@@ -6281,7 +6281,7 @@
                     <a:p>
                       <a:pPr algn="ctr"/>
                       <a:r>
-                        <a:rPr sz="1300"/>
+                        <a:rPr sz="1500"/>
                         <a:t>Locked door on the only corridor; a collapse could trap someone</a:t>
                       </a:r>
                     </a:p>
@@ -6295,7 +6295,7 @@
                     <a:p>
                       <a:pPr algn="ctr"/>
                       <a:r>
-                        <a:rPr sz="1300"/>
+                        <a:rPr sz="1500"/>
                         <a:t>Key sub-goal; connectivity-checked collapse</a:t>
                       </a:r>
                     </a:p>

</xml_diff>

<commit_message>
Slides: fill remaining empty space on the AI Critique table
Same row-height/font treatment as the other four tables.

Co-Authored-By: Claude Sonnet 5 <noreply@anthropic.com>
</commit_message>
<xml_diff>
--- a/docs/report/CT3201_Slides.pptx
+++ b/docs/report/CT3201_Slides.pptx
@@ -6647,7 +6647,7 @@
         </p:nvGraphicFramePr>
         <p:xfrm>
           <a:off x="548640" y="1371600"/>
-          <a:ext cx="11064240" cy="3291840"/>
+          <a:ext cx="11064240" cy="4800600"/>
         </p:xfrm>
         <a:graphic>
           <a:graphicData uri="http://schemas.openxmlformats.org/drawingml/2006/table">
@@ -6678,7 +6678,7 @@
                   </a:extLst>
                 </a:gridCol>
               </a:tblGrid>
-              <a:tr h="365760">
+              <a:tr h="685800">
                 <a:tc>
                   <a:txBody>
                     <a:bodyPr/>
@@ -6686,7 +6686,7 @@
                     <a:p>
                       <a:pPr algn="ctr"/>
                       <a:r>
-                        <a:rPr sz="1300" b="1">
+                        <a:rPr sz="1400" b="1">
                           <a:solidFill>
                             <a:srgbClr val="FFFFFF"/>
                           </a:solidFill>
@@ -6708,7 +6708,7 @@
                     <a:p>
                       <a:pPr algn="ctr"/>
                       <a:r>
-                        <a:rPr sz="1300" b="1">
+                        <a:rPr sz="1400" b="1">
                           <a:solidFill>
                             <a:srgbClr val="FFFFFF"/>
                           </a:solidFill>
@@ -6730,7 +6730,7 @@
                     <a:p>
                       <a:pPr algn="ctr"/>
                       <a:r>
-                        <a:rPr sz="1300" b="1">
+                        <a:rPr sz="1400" b="1">
                           <a:solidFill>
                             <a:srgbClr val="FFFFFF"/>
                           </a:solidFill>
@@ -6751,7 +6751,7 @@
                   </a:ext>
                 </a:extLst>
               </a:tr>
-              <a:tr h="365760">
+              <a:tr h="685800">
                 <a:tc>
                   <a:txBody>
                     <a:bodyPr/>
@@ -6759,7 +6759,7 @@
                     <a:p>
                       <a:pPr algn="ctr"/>
                       <a:r>
-                        <a:rPr sz="1300" b="1">
+                        <a:rPr sz="1400" b="1">
                           <a:solidFill>
                             <a:srgbClr val="A32B1F"/>
                           </a:solidFill>
@@ -6781,7 +6781,7 @@
                     <a:p>
                       <a:pPr algn="ctr"/>
                       <a:r>
-                        <a:rPr sz="1300" b="1">
+                        <a:rPr sz="1400" b="1">
                           <a:solidFill>
                             <a:srgbClr val="A32B1F"/>
                           </a:solidFill>
@@ -6803,7 +6803,7 @@
                     <a:p>
                       <a:pPr algn="ctr"/>
                       <a:r>
-                        <a:rPr sz="1300" b="1">
+                        <a:rPr sz="1400" b="1">
                           <a:solidFill>
                             <a:srgbClr val="A32B1F"/>
                           </a:solidFill>
@@ -6824,7 +6824,7 @@
                   </a:ext>
                 </a:extLst>
               </a:tr>
-              <a:tr h="365760">
+              <a:tr h="685800">
                 <a:tc>
                   <a:txBody>
                     <a:bodyPr/>
@@ -6832,7 +6832,7 @@
                     <a:p>
                       <a:pPr algn="ctr"/>
                       <a:r>
-                        <a:rPr sz="1300" b="1">
+                        <a:rPr sz="1400" b="1">
                           <a:solidFill>
                             <a:srgbClr val="1E6B3D"/>
                           </a:solidFill>
@@ -6854,7 +6854,7 @@
                     <a:p>
                       <a:pPr algn="ctr"/>
                       <a:r>
-                        <a:rPr sz="1300" b="1">
+                        <a:rPr sz="1400" b="1">
                           <a:solidFill>
                             <a:srgbClr val="1E6B3D"/>
                           </a:solidFill>
@@ -6876,7 +6876,7 @@
                     <a:p>
                       <a:pPr algn="ctr"/>
                       <a:r>
-                        <a:rPr sz="1300" b="1">
+                        <a:rPr sz="1400" b="1">
                           <a:solidFill>
                             <a:srgbClr val="1E6B3D"/>
                           </a:solidFill>
@@ -6897,7 +6897,7 @@
                   </a:ext>
                 </a:extLst>
               </a:tr>
-              <a:tr h="365760">
+              <a:tr h="685800">
                 <a:tc>
                   <a:txBody>
                     <a:bodyPr/>
@@ -6905,7 +6905,7 @@
                     <a:p>
                       <a:pPr algn="ctr"/>
                       <a:r>
-                        <a:rPr sz="1300" b="1">
+                        <a:rPr sz="1400" b="1">
                           <a:solidFill>
                             <a:srgbClr val="1E6B3D"/>
                           </a:solidFill>
@@ -6927,7 +6927,7 @@
                     <a:p>
                       <a:pPr algn="ctr"/>
                       <a:r>
-                        <a:rPr sz="1300" b="1">
+                        <a:rPr sz="1400" b="1">
                           <a:solidFill>
                             <a:srgbClr val="1E6B3D"/>
                           </a:solidFill>
@@ -6949,7 +6949,7 @@
                     <a:p>
                       <a:pPr algn="ctr"/>
                       <a:r>
-                        <a:rPr sz="1300" b="1">
+                        <a:rPr sz="1400" b="1">
                           <a:solidFill>
                             <a:srgbClr val="1E6B3D"/>
                           </a:solidFill>
@@ -6970,7 +6970,7 @@
                   </a:ext>
                 </a:extLst>
               </a:tr>
-              <a:tr h="365760">
+              <a:tr h="685800">
                 <a:tc>
                   <a:txBody>
                     <a:bodyPr/>
@@ -6978,7 +6978,7 @@
                     <a:p>
                       <a:pPr algn="ctr"/>
                       <a:r>
-                        <a:rPr sz="1300" b="1">
+                        <a:rPr sz="1400" b="1">
                           <a:solidFill>
                             <a:srgbClr val="A32B1F"/>
                           </a:solidFill>
@@ -7000,7 +7000,7 @@
                     <a:p>
                       <a:pPr algn="ctr"/>
                       <a:r>
-                        <a:rPr sz="1300" b="1">
+                        <a:rPr sz="1400" b="1">
                           <a:solidFill>
                             <a:srgbClr val="A32B1F"/>
                           </a:solidFill>
@@ -7022,7 +7022,7 @@
                     <a:p>
                       <a:pPr algn="ctr"/>
                       <a:r>
-                        <a:rPr sz="1300" b="1">
+                        <a:rPr sz="1400" b="1">
                           <a:solidFill>
                             <a:srgbClr val="A32B1F"/>
                           </a:solidFill>
@@ -7043,7 +7043,7 @@
                   </a:ext>
                 </a:extLst>
               </a:tr>
-              <a:tr h="365760">
+              <a:tr h="685800">
                 <a:tc>
                   <a:txBody>
                     <a:bodyPr/>
@@ -7051,7 +7051,7 @@
                     <a:p>
                       <a:pPr algn="ctr"/>
                       <a:r>
-                        <a:rPr sz="1300" b="1">
+                        <a:rPr sz="1400" b="1">
                           <a:solidFill>
                             <a:srgbClr val="8A5A12"/>
                           </a:solidFill>
@@ -7073,7 +7073,7 @@
                     <a:p>
                       <a:pPr algn="ctr"/>
                       <a:r>
-                        <a:rPr sz="1300" b="1">
+                        <a:rPr sz="1400" b="1">
                           <a:solidFill>
                             <a:srgbClr val="8A5A12"/>
                           </a:solidFill>
@@ -7095,7 +7095,7 @@
                     <a:p>
                       <a:pPr algn="ctr"/>
                       <a:r>
-                        <a:rPr sz="1300" b="1">
+                        <a:rPr sz="1400" b="1">
                           <a:solidFill>
                             <a:srgbClr val="8A5A12"/>
                           </a:solidFill>
@@ -7116,7 +7116,7 @@
                   </a:ext>
                 </a:extLst>
               </a:tr>
-              <a:tr h="365760">
+              <a:tr h="685800">
                 <a:tc>
                   <a:txBody>
                     <a:bodyPr/>
@@ -7124,7 +7124,7 @@
                     <a:p>
                       <a:pPr algn="ctr"/>
                       <a:r>
-                        <a:rPr sz="1300" b="1">
+                        <a:rPr sz="1400" b="1">
                           <a:solidFill>
                             <a:srgbClr val="A32B1F"/>
                           </a:solidFill>
@@ -7146,7 +7146,7 @@
                     <a:p>
                       <a:pPr algn="ctr"/>
                       <a:r>
-                        <a:rPr sz="1300" b="1">
+                        <a:rPr sz="1400" b="1">
                           <a:solidFill>
                             <a:srgbClr val="A32B1F"/>
                           </a:solidFill>
@@ -7168,7 +7168,7 @@
                     <a:p>
                       <a:pPr algn="ctr"/>
                       <a:r>
-                        <a:rPr sz="1300" b="1">
+                        <a:rPr sz="1400" b="1">
                           <a:solidFill>
                             <a:srgbClr val="A32B1F"/>
                           </a:solidFill>

</xml_diff>

<commit_message>
Slides: accessible decision symbols, unify slide 6's image framing
- Added check/cross/tilde symbols (checkmark/cross/tilde) next to
  Accept/Reject/Modify and the strategy table's verdicts, so the
  decision reads without relying on red/green color alone.
- Wrapped the flowchart in a light rounded card border matching the
  two screenshot panels, so all three images on slide 6 read as one
  coherent set instead of a plain diagram next to dark game shots.

Co-Authored-By: Claude Sonnet 5 <noreply@anthropic.com>
</commit_message>
<xml_diff>
--- a/docs/report/CT3201_Slides.pptx
+++ b/docs/report/CT3201_Slides.pptx
@@ -6786,7 +6786,7 @@
                             <a:srgbClr val="A32B1F"/>
                           </a:solidFill>
                         </a:rPr>
-                        <a:t>Reject</a:t>
+                        <a:t>✗ Reject</a:t>
                       </a:r>
                     </a:p>
                   </a:txBody>
@@ -6859,7 +6859,7 @@
                             <a:srgbClr val="1E6B3D"/>
                           </a:solidFill>
                         </a:rPr>
-                        <a:t>Accept</a:t>
+                        <a:t>✓ Accept</a:t>
                       </a:r>
                     </a:p>
                   </a:txBody>
@@ -6932,7 +6932,7 @@
                             <a:srgbClr val="1E6B3D"/>
                           </a:solidFill>
                         </a:rPr>
-                        <a:t>Accept</a:t>
+                        <a:t>✓ Accept</a:t>
                       </a:r>
                     </a:p>
                   </a:txBody>
@@ -7005,7 +7005,7 @@
                             <a:srgbClr val="A32B1F"/>
                           </a:solidFill>
                         </a:rPr>
-                        <a:t>Reject</a:t>
+                        <a:t>✗ Reject</a:t>
                       </a:r>
                     </a:p>
                   </a:txBody>
@@ -7078,7 +7078,7 @@
                             <a:srgbClr val="8A5A12"/>
                           </a:solidFill>
                         </a:rPr>
-                        <a:t>Modify</a:t>
+                        <a:t>~ Modify</a:t>
                       </a:r>
                     </a:p>
                   </a:txBody>
@@ -7151,7 +7151,7 @@
                             <a:srgbClr val="A32B1F"/>
                           </a:solidFill>
                         </a:rPr>
-                        <a:t>Reject</a:t>
+                        <a:t>✗ Reject</a:t>
                       </a:r>
                     </a:p>
                   </a:txBody>
@@ -7735,30 +7735,6 @@
           </a:p>
         </p:txBody>
       </p:sp>
-      <p:pic>
-        <p:nvPicPr>
-          <p:cNvPr id="4" name="Picture 3" descr="fig_decision_loop.png"/>
-          <p:cNvPicPr>
-            <a:picLocks noChangeAspect="1"/>
-          </p:cNvPicPr>
-          <p:nvPr/>
-        </p:nvPicPr>
-        <p:blipFill>
-          <a:blip r:embed="rId2"/>
-          <a:stretch>
-            <a:fillRect/>
-          </a:stretch>
-        </p:blipFill>
-        <p:spPr>
-          <a:xfrm>
-            <a:off x="3055593" y="4160520"/>
-            <a:ext cx="1649437" cy="2240280"/>
-          </a:xfrm>
-          <a:prstGeom prst="rect">
-            <a:avLst/>
-          </a:prstGeom>
-        </p:spPr>
-      </p:pic>
       <p:sp>
         <p:nvSpPr>
           <p:cNvPr id="7" name="Rectangle 6"/>
@@ -7989,6 +7965,30 @@
           <a:xfrm>
             <a:off x="5074920" y="4160520"/>
             <a:ext cx="5989320" cy="2240280"/>
+          </a:xfrm>
+          <a:prstGeom prst="rect">
+            <a:avLst/>
+          </a:prstGeom>
+        </p:spPr>
+      </p:pic>
+      <p:pic>
+        <p:nvPicPr>
+          <p:cNvPr id="13" name="Picture 12" descr="flowchart_card.png"/>
+          <p:cNvPicPr>
+            <a:picLocks noChangeAspect="1"/>
+          </p:cNvPicPr>
+          <p:nvPr/>
+        </p:nvPicPr>
+        <p:blipFill>
+          <a:blip r:embed="rId5"/>
+          <a:stretch>
+            <a:fillRect/>
+          </a:stretch>
+        </p:blipFill>
+        <p:spPr>
+          <a:xfrm>
+            <a:off x="3055593" y="4114800"/>
+            <a:ext cx="1731498" cy="2322341"/>
           </a:xfrm>
           <a:prstGeom prst="rect">
             <a:avLst/>
@@ -8321,7 +8321,7 @@
                             <a:srgbClr val="A32B1F"/>
                           </a:solidFill>
                         </a:rPr>
-                        <a:t>BFS (unweighted)</a:t>
+                        <a:t>✗ BFS (unweighted)</a:t>
                       </a:r>
                     </a:p>
                   </a:txBody>
@@ -8479,7 +8479,7 @@
                             <a:srgbClr val="1E6B3D"/>
                           </a:solidFill>
                         </a:rPr>
-                        <a:t>A*</a:t>
+                        <a:t>✓ A*</a:t>
                       </a:r>
                     </a:p>
                   </a:txBody>
@@ -8574,7 +8574,7 @@
                             <a:srgbClr val="A32B1F"/>
                           </a:solidFill>
                         </a:rPr>
-                        <a:t>Greedy best-first</a:t>
+                        <a:t>✗ Greedy best-first</a:t>
                       </a:r>
                     </a:p>
                   </a:txBody>

</xml_diff>